<commit_message>
feat: add dual Landscape and Portrait camera modes with live switcher and update web ppt presentation
</commit_message>
<xml_diff>
--- a/Yoga_AI_Presentation.pptx
+++ b/Yoga_AI_Presentation.pptx
@@ -4952,7 +4952,7 @@
               </a:defRPr>
             </a:pPr>
             <a:r>
-              <a:t>• 3. Anatomically Continuous Skeleton: Explicit anatomical joint binding (hips to knees to ankles) with green/amber/red color status.</a:t>
+              <a:t>• 3. Dual Landscape &amp; Portrait Modes: One-click switcher toggles between 4:3 Wide Studio &amp; 3:4 Tall Full-Body view for standing postures.</a:t>
             </a:r>
           </a:p>
           <a:p>
@@ -6331,7 +6331,7 @@
               </a:defRPr>
             </a:pPr>
             <a:r>
-              <a:t>Clean Studio UI &amp; 10-Second Diagnostic Scorecard</a:t>
+              <a:t>Dual-Mode Camera (Landscape &amp; Portrait) &amp; 10s Scorecard</a:t>
             </a:r>
           </a:p>
         </p:txBody>
@@ -6414,60 +6414,75 @@
               </a:defRPr>
             </a:pPr>
             <a:r>
-              <a:t>🧘 Ergonomic Studio UI Design</a:t>
-            </a:r>
-          </a:p>
-          <a:p>
-            <a:pPr>
-              <a:spcAft>
-                <a:spcPts val="500"/>
-              </a:spcAft>
-              <a:defRPr sz="1250">
-                <a:solidFill>
-                  <a:srgbClr val="CBD5E1"/>
-                </a:solidFill>
-              </a:defRPr>
-            </a:pPr>
-            <a:r>
-              <a:t>• Responsive Studio Stage: Flexbox layout displays webcam feed (640x480) and target pose illustration side-by-side on all screens.</a:t>
-            </a:r>
-          </a:p>
-          <a:p>
-            <a:pPr>
-              <a:spcAft>
-                <a:spcPts val="500"/>
-              </a:spcAft>
-              <a:defRPr sz="1250">
-                <a:solidFill>
-                  <a:srgbClr val="CBD5E1"/>
-                </a:solidFill>
-              </a:defRPr>
-            </a:pPr>
-            <a:r>
-              <a:t>• HUD Overlays: Floating semi-transparent cards report real-time 'Pose Time: X.X s' and 'Best: X.X s' without obscuring the user.</a:t>
-            </a:r>
-          </a:p>
-          <a:p>
-            <a:pPr>
-              <a:spcAft>
-                <a:spcPts val="500"/>
-              </a:spcAft>
-              <a:defRPr sz="1250">
-                <a:solidFill>
-                  <a:srgbClr val="CBD5E1"/>
-                </a:solidFill>
-              </a:defRPr>
-            </a:pPr>
-            <a:r>
-              <a:t>• Continuous Anatomy: Green bones when aligned, Orange warnings on deviations, and Red alerts on hyperextension risks.</a:t>
-            </a:r>
-          </a:p>
-          <a:p>
-            <a:pPr>
-              <a:spcAft>
-                <a:spcPts val="500"/>
-              </a:spcAft>
-              <a:defRPr sz="1250">
+              <a:t>🧘 Dual-Mode Camera &amp; Ergonomics</a:t>
+            </a:r>
+          </a:p>
+          <a:p>
+            <a:pPr>
+              <a:spcAft>
+                <a:spcPts val="500"/>
+              </a:spcAft>
+              <a:defRPr sz="1200">
+                <a:solidFill>
+                  <a:srgbClr val="CBD5E1"/>
+                </a:solidFill>
+              </a:defRPr>
+            </a:pPr>
+            <a:r>
+              <a:t>• Landscape (640x480): Wide studio perspective ideal for mat floor poses like Downward Dog and Cobra.</a:t>
+            </a:r>
+          </a:p>
+          <a:p>
+            <a:pPr>
+              <a:spcAft>
+                <a:spcPts val="500"/>
+              </a:spcAft>
+              <a:defRPr sz="1200">
+                <a:solidFill>
+                  <a:srgbClr val="CBD5E1"/>
+                </a:solidFill>
+              </a:defRPr>
+            </a:pPr>
+            <a:r>
+              <a:t>• Portrait (480x640): Tall full-body perspective ideal for vertical standing poses like Tree and Chair.</a:t>
+            </a:r>
+          </a:p>
+          <a:p>
+            <a:pPr>
+              <a:spcAft>
+                <a:spcPts val="500"/>
+              </a:spcAft>
+              <a:defRPr sz="1200">
+                <a:solidFill>
+                  <a:srgbClr val="CBD5E1"/>
+                </a:solidFill>
+              </a:defRPr>
+            </a:pPr>
+            <a:r>
+              <a:t>• One-Click Live Switcher: Instant toggle button on the camera HUD switches resolution without reloading models.</a:t>
+            </a:r>
+          </a:p>
+          <a:p>
+            <a:pPr>
+              <a:spcAft>
+                <a:spcPts val="500"/>
+              </a:spcAft>
+              <a:defRPr sz="1200">
+                <a:solidFill>
+                  <a:srgbClr val="CBD5E1"/>
+                </a:solidFill>
+              </a:defRPr>
+            </a:pPr>
+            <a:r>
+              <a:t>• Responsive Stage: Flexbox layout displays camera feed and target reference photo side-by-side on all screens.</a:t>
+            </a:r>
+          </a:p>
+          <a:p>
+            <a:pPr>
+              <a:spcAft>
+                <a:spcPts val="500"/>
+              </a:spcAft>
+              <a:defRPr sz="1200">
                 <a:solidFill>
                   <a:srgbClr val="CBD5E1"/>
                 </a:solidFill>

</xml_diff>

<commit_message>
fix(presentation): remove FAQ, eliminate white scrollbar, enlarge card typography and ensure 100% visibility
</commit_message>
<xml_diff>
--- a/Yoga_AI_Presentation.pptx
+++ b/Yoga_AI_Presentation.pptx
@@ -3249,7 +3249,7 @@
               </a:spcBef>
               <a:defRPr sz="1400">
                 <a:solidFill>
-                  <a:srgbClr val="CBD5E1"/>
+                  <a:srgbClr val="E2E8F0"/>
                 </a:solidFill>
               </a:defRPr>
             </a:pPr>
@@ -3512,38 +3512,38 @@
           <a:p>
             <a:pPr algn="ctr">
               <a:spcAft>
+                <a:spcPts val="1200"/>
+              </a:spcAft>
+              <a:defRPr sz="1800" b="1">
+                <a:solidFill>
+                  <a:srgbClr val="FFFFFF"/>
+                </a:solidFill>
+              </a:defRPr>
+            </a:pPr>
+            <a:r>
+              <a:t>Winning 3-Step Live Demonstration Protocol for Judges:</a:t>
+            </a:r>
+          </a:p>
+          <a:p>
+            <a:pPr>
+              <a:defRPr sz="1500" b="1">
+                <a:solidFill>
+                  <a:srgbClr val="10B981"/>
+                </a:solidFill>
+              </a:defRPr>
+            </a:pPr>
+            <a:r>
+              <a:t>Step 1: Anti-Cheat &amp; True Pose Verification Demo</a:t>
+            </a:r>
+          </a:p>
+          <a:p>
+            <a:pPr>
+              <a:spcAft>
                 <a:spcPts val="800"/>
               </a:spcAft>
-              <a:defRPr sz="1700" b="1">
-                <a:solidFill>
-                  <a:srgbClr val="FFFFFF"/>
-                </a:solidFill>
-              </a:defRPr>
-            </a:pPr>
-            <a:r>
-              <a:t>Winning 3-Step Live Demonstration Protocol for Judges:</a:t>
-            </a:r>
-          </a:p>
-          <a:p>
-            <a:pPr>
-              <a:defRPr sz="1400" b="1">
-                <a:solidFill>
-                  <a:srgbClr val="10B981"/>
-                </a:solidFill>
-              </a:defRPr>
-            </a:pPr>
-            <a:r>
-              <a:t>Step 1: Anti-Cheat &amp; True Pose Verification Demo</a:t>
-            </a:r>
-          </a:p>
-          <a:p>
-            <a:pPr>
-              <a:spcAft>
-                <a:spcPts val="600"/>
-              </a:spcAft>
-              <a:defRPr sz="1200">
-                <a:solidFill>
-                  <a:srgbClr val="CBD5E1"/>
+              <a:defRPr sz="1300">
+                <a:solidFill>
+                  <a:srgbClr val="E2E8F0"/>
                 </a:solidFill>
               </a:defRPr>
             </a:pPr>
@@ -3557,34 +3557,38 @@
           </a:p>
           <a:p>
             <a:pPr>
-              <a:defRPr sz="1400" b="1">
+              <a:defRPr sz="1500" b="1">
                 <a:solidFill>
                   <a:srgbClr val="0EA5E9"/>
                 </a:solidFill>
               </a:defRPr>
             </a:pPr>
             <a:r>
-              <a:t>Step 2: 10-Second Auto-Closing Modal &amp; Soft Scrollability Demo</a:t>
-            </a:r>
-          </a:p>
-          <a:p>
-            <a:pPr>
-              <a:spcAft>
-                <a:spcPts val="600"/>
-              </a:spcAft>
-              <a:defRPr sz="1200">
-                <a:solidFill>
-                  <a:srgbClr val="CBD5E1"/>
-                </a:solidFill>
-              </a:defRPr>
-            </a:pPr>
-            <a:r>
-              <a:t>   • Click 'Stop Pose'. Observe the 10-second countdown bar. Hover mouse over the card to pause countdown, scroll smoothly with soft-tinted scrollbars, or let it close hands-free.</a:t>
-            </a:r>
-          </a:p>
-          <a:p>
-            <a:pPr>
-              <a:defRPr sz="1400" b="1">
+              <a:t>Step 2: Dual Camera Modes &amp; 10-Second Auto-Closing Modal Demo</a:t>
+            </a:r>
+          </a:p>
+          <a:p>
+            <a:pPr>
+              <a:spcAft>
+                <a:spcPts val="800"/>
+              </a:spcAft>
+              <a:defRPr sz="1300">
+                <a:solidFill>
+                  <a:srgbClr val="E2E8F0"/>
+                </a:solidFill>
+              </a:defRPr>
+            </a:pPr>
+            <a:r>
+              <a:t>   • Toggle between 🖥️ Landscape and 📱 Portrait mode with one click to show full-body tracking adaptation.</a:t>
+            </a:r>
+            <a:br/>
+            <a:r>
+              <a:t>   • Click 'Stop Pose'. Observe the 10-second countdown bar. Hover mouse over the card to pause countdown, or let it close hands-free.</a:t>
+            </a:r>
+          </a:p>
+          <a:p>
+            <a:pPr>
+              <a:defRPr sz="1500" b="1">
                 <a:solidFill>
                   <a:srgbClr val="A855F7"/>
                 </a:solidFill>
@@ -3596,14 +3600,18 @@
           </a:p>
           <a:p>
             <a:pPr>
-              <a:defRPr sz="1200">
-                <a:solidFill>
-                  <a:srgbClr val="CBD5E1"/>
-                </a:solidFill>
-              </a:defRPr>
-            </a:pPr>
-            <a:r>
-              <a:t>   • Navigate to /progress. Inspect the dual SVG performance chart showing stability trajectory and posture scores. Click 'Export JSON Report 📥' to download raw clinical audit data.</a:t>
+              <a:defRPr sz="1300">
+                <a:solidFill>
+                  <a:srgbClr val="E2E8F0"/>
+                </a:solidFill>
+              </a:defRPr>
+            </a:pPr>
+            <a:r>
+              <a:t>   • Navigate to /progress. Inspect the dual SVG performance chart showing stability trajectory and posture scores.</a:t>
+            </a:r>
+            <a:br/>
+            <a:r>
+              <a:t>   • Click 'Export JSON Report 📥' to download raw clinical audit data, proving 100% offline persistence.</a:t>
             </a:r>
           </a:p>
         </p:txBody>
@@ -3712,7 +3720,7 @@
         </p:nvSpPr>
         <p:spPr>
           <a:xfrm>
-            <a:off x="731520" y="685800"/>
+            <a:off x="731520" y="640080"/>
             <a:ext cx="10698480" cy="685800"/>
           </a:xfrm>
           <a:prstGeom prst="rect">
@@ -3727,14 +3735,14 @@
           <a:lstStyle/>
           <a:p>
             <a:pPr>
-              <a:defRPr sz="2600" b="1">
+              <a:defRPr sz="2800" b="1">
                 <a:solidFill>
                   <a:srgbClr val="FFFFFF"/>
                 </a:solidFill>
               </a:defRPr>
             </a:pPr>
             <a:r>
-              <a:t>Purpose, Clinical Vision &amp; Presentation Agenda</a:t>
+              <a:t>Purpose &amp; Clinical Healthcare Vision</a:t>
             </a:r>
           </a:p>
         </p:txBody>
@@ -3748,7 +3756,7 @@
         <p:spPr>
           <a:xfrm>
             <a:off x="731520" y="1463040"/>
-            <a:ext cx="5943600" cy="4846320"/>
+            <a:ext cx="5120640" cy="4846320"/>
           </a:xfrm>
           <a:prstGeom prst="roundRect">
             <a:avLst/>
@@ -3756,7 +3764,7 @@
           <a:solidFill>
             <a:srgbClr val="1E293B"/>
           </a:solidFill>
-          <a:ln w="19050">
+          <a:ln w="25400">
             <a:solidFill>
               <a:srgbClr val="10B981"/>
             </a:solidFill>
@@ -3792,8 +3800,8 @@
         </p:nvSpPr>
         <p:spPr>
           <a:xfrm>
-            <a:off x="960120" y="1645920"/>
-            <a:ext cx="5486400" cy="4480560"/>
+            <a:off x="1005840" y="1719072"/>
+            <a:ext cx="4572000" cy="4334256"/>
           </a:xfrm>
           <a:prstGeom prst="rect">
             <a:avLst/>
@@ -3808,106 +3816,76 @@
           <a:p>
             <a:pPr>
               <a:spcAft>
-                <a:spcPts val="800"/>
-              </a:spcAft>
-              <a:defRPr sz="1600" b="1">
+                <a:spcPts val="1200"/>
+              </a:spcAft>
+              <a:defRPr sz="2000" b="1">
                 <a:solidFill>
                   <a:srgbClr val="10B981"/>
                 </a:solidFill>
               </a:defRPr>
             </a:pPr>
             <a:r>
-              <a:t>📋 10-Slide Exhibition Journey</a:t>
-            </a:r>
-          </a:p>
-          <a:p>
-            <a:pPr>
-              <a:spcAft>
-                <a:spcPts val="500"/>
-              </a:spcAft>
-              <a:defRPr sz="1250">
-                <a:solidFill>
-                  <a:srgbClr val="CBD5E1"/>
-                </a:solidFill>
-              </a:defRPr>
-            </a:pPr>
-            <a:r>
-              <a:t>• 1. Clinical Vision: Bringing zero-cost, private posture correction to every household, school, and rural center.</a:t>
-            </a:r>
-          </a:p>
-          <a:p>
-            <a:pPr>
-              <a:spcAft>
-                <a:spcPts val="500"/>
-              </a:spcAft>
-              <a:defRPr sz="1250">
-                <a:solidFill>
-                  <a:srgbClr val="CBD5E1"/>
-                </a:solidFill>
-              </a:defRPr>
-            </a:pPr>
-            <a:r>
-              <a:t>• 2. Anti-Cheating Technology: Eliminating false positives through strict geometric angle and distance gating.</a:t>
-            </a:r>
-          </a:p>
-          <a:p>
-            <a:pPr>
-              <a:spcAft>
-                <a:spcPts val="500"/>
-              </a:spcAft>
-              <a:defRPr sz="1250">
-                <a:solidFill>
-                  <a:srgbClr val="CBD5E1"/>
-                </a:solidFill>
-              </a:defRPr>
-            </a:pPr>
-            <a:r>
-              <a:t>• 3. Real-Time Ergonomics: Live 30-60 FPS skeleton tracking, soft-tinted scrollbars, and side-by-side pose guides.</a:t>
-            </a:r>
-          </a:p>
-          <a:p>
-            <a:pPr>
-              <a:spcAft>
-                <a:spcPts val="500"/>
-              </a:spcAft>
-              <a:defRPr sz="1250">
-                <a:solidFill>
-                  <a:srgbClr val="CBD5E1"/>
-                </a:solidFill>
-              </a:defRPr>
-            </a:pPr>
-            <a:r>
-              <a:t>• 4. Hands-Free Convenience: 10-second auto-closing diagnostic scorecard that auto-persists records to IndexedDB.</a:t>
-            </a:r>
-          </a:p>
-          <a:p>
-            <a:pPr>
-              <a:spcAft>
-                <a:spcPts val="500"/>
-              </a:spcAft>
-              <a:defRPr sz="1250">
-                <a:solidFill>
-                  <a:srgbClr val="CBD5E1"/>
-                </a:solidFill>
-              </a:defRPr>
-            </a:pPr>
-            <a:r>
-              <a:t>• 5. Longitudinal Analytics: Interactive SVG performance trend charts tracking stability, accuracy, and hold times.</a:t>
-            </a:r>
-          </a:p>
-          <a:p>
-            <a:pPr>
-              <a:spcAft>
-                <a:spcPts val="500"/>
-              </a:spcAft>
-              <a:defRPr sz="1250">
-                <a:solidFill>
-                  <a:srgbClr val="CBD5E1"/>
-                </a:solidFill>
-              </a:defRPr>
-            </a:pPr>
-            <a:r>
-              <a:t>• 6. Winning Live Demo: A 3-step proof sequence designed specifically for district judge evaluation.</a:t>
+              <a:t>🎯 Universal Healthcare Mission</a:t>
+            </a:r>
+          </a:p>
+          <a:p>
+            <a:pPr>
+              <a:spcAft>
+                <a:spcPts val="1000"/>
+              </a:spcAft>
+              <a:defRPr sz="1500">
+                <a:solidFill>
+                  <a:srgbClr val="E2E8F0"/>
+                </a:solidFill>
+              </a:defRPr>
+            </a:pPr>
+            <a:r>
+              <a:t>• Democratize Clinical Yoga: Bring certified posture guidance to every student, family, and rural school.</a:t>
+            </a:r>
+          </a:p>
+          <a:p>
+            <a:pPr>
+              <a:spcAft>
+                <a:spcPts val="1000"/>
+              </a:spcAft>
+              <a:defRPr sz="1500">
+                <a:solidFill>
+                  <a:srgbClr val="E2E8F0"/>
+                </a:solidFill>
+              </a:defRPr>
+            </a:pPr>
+            <a:r>
+              <a:t>• 100% On-Device Privacy: Camera frames are evaluated purely in local memory and never uploaded to any server.</a:t>
+            </a:r>
+          </a:p>
+          <a:p>
+            <a:pPr>
+              <a:spcAft>
+                <a:spcPts val="1000"/>
+              </a:spcAft>
+              <a:defRPr sz="1500">
+                <a:solidFill>
+                  <a:srgbClr val="E2E8F0"/>
+                </a:solidFill>
+              </a:defRPr>
+            </a:pPr>
+            <a:r>
+              <a:t>• Zero Hardware Barriers: Works with standard laptop webcams without wearable sensors or depth cameras.</a:t>
+            </a:r>
+          </a:p>
+          <a:p>
+            <a:pPr>
+              <a:spcAft>
+                <a:spcPts val="1000"/>
+              </a:spcAft>
+              <a:defRPr sz="1500">
+                <a:solidFill>
+                  <a:srgbClr val="E2E8F0"/>
+                </a:solidFill>
+              </a:defRPr>
+            </a:pPr>
+            <a:r>
+              <a:t>• Zero Ongoing Fees: Completely free and open-source with no recurring subscriptions or API costs.</a:t>
             </a:r>
           </a:p>
         </p:txBody>
@@ -3920,8 +3898,8 @@
         </p:nvSpPr>
         <p:spPr>
           <a:xfrm>
-            <a:off x="6949440" y="1463040"/>
-            <a:ext cx="4480560" cy="4846320"/>
+            <a:off x="6309360" y="1463040"/>
+            <a:ext cx="5120640" cy="4846320"/>
           </a:xfrm>
           <a:prstGeom prst="roundRect">
             <a:avLst/>
@@ -3929,7 +3907,7 @@
           <a:solidFill>
             <a:srgbClr val="1E293B"/>
           </a:solidFill>
-          <a:ln w="19050">
+          <a:ln w="25400">
             <a:solidFill>
               <a:srgbClr val="0EA5E9"/>
             </a:solidFill>
@@ -3965,8 +3943,8 @@
         </p:nvSpPr>
         <p:spPr>
           <a:xfrm>
-            <a:off x="7178040" y="1645920"/>
-            <a:ext cx="4023360" cy="4480560"/>
+            <a:off x="6583680" y="1719072"/>
+            <a:ext cx="4572000" cy="4334256"/>
           </a:xfrm>
           <a:prstGeom prst="rect">
             <a:avLst/>
@@ -3981,76 +3959,76 @@
           <a:p>
             <a:pPr>
               <a:spcAft>
-                <a:spcPts val="800"/>
-              </a:spcAft>
-              <a:defRPr sz="1600" b="1">
+                <a:spcPts val="1200"/>
+              </a:spcAft>
+              <a:defRPr sz="2000" b="1">
                 <a:solidFill>
                   <a:srgbClr val="0EA5E9"/>
                 </a:solidFill>
               </a:defRPr>
             </a:pPr>
             <a:r>
-              <a:t>🎯 Mission &amp; Impact Objectives</a:t>
-            </a:r>
-          </a:p>
-          <a:p>
-            <a:pPr>
-              <a:spcAft>
-                <a:spcPts val="500"/>
-              </a:spcAft>
-              <a:defRPr sz="1250">
-                <a:solidFill>
-                  <a:srgbClr val="CBD5E1"/>
-                </a:solidFill>
-              </a:defRPr>
-            </a:pPr>
-            <a:r>
-              <a:t>• Eliminates the risk of acute yoga injuries caused by unsupervised solo workouts.</a:t>
-            </a:r>
-          </a:p>
-          <a:p>
-            <a:pPr>
-              <a:spcAft>
-                <a:spcPts val="500"/>
-              </a:spcAft>
-              <a:defRPr sz="1250">
-                <a:solidFill>
-                  <a:srgbClr val="CBD5E1"/>
-                </a:solidFill>
-              </a:defRPr>
-            </a:pPr>
-            <a:r>
-              <a:t>• 100% on-device edge execution guarantees student biometric video never leaves the computer.</a:t>
-            </a:r>
-          </a:p>
-          <a:p>
-            <a:pPr>
-              <a:spcAft>
-                <a:spcPts val="500"/>
-              </a:spcAft>
-              <a:defRPr sz="1250">
-                <a:solidFill>
-                  <a:srgbClr val="CBD5E1"/>
-                </a:solidFill>
-              </a:defRPr>
-            </a:pPr>
-            <a:r>
-              <a:t>• Sub-15ms feedback loop provides instant auditory corrections before strain develops.</a:t>
-            </a:r>
-          </a:p>
-          <a:p>
-            <a:pPr>
-              <a:spcAft>
-                <a:spcPts val="500"/>
-              </a:spcAft>
-              <a:defRPr sz="1250">
-                <a:solidFill>
-                  <a:srgbClr val="CBD5E1"/>
-                </a:solidFill>
-              </a:defRPr>
-            </a:pPr>
-            <a:r>
-              <a:t>• Zero ongoing infrastructure or cloud API cost ensures indefinite scalability.</a:t>
+              <a:t>🛡️ Core Scientific Objectives</a:t>
+            </a:r>
+          </a:p>
+          <a:p>
+            <a:pPr>
+              <a:spcAft>
+                <a:spcPts val="1000"/>
+              </a:spcAft>
+              <a:defRPr sz="1500">
+                <a:solidFill>
+                  <a:srgbClr val="E2E8F0"/>
+                </a:solidFill>
+              </a:defRPr>
+            </a:pPr>
+            <a:r>
+              <a:t>• Eliminate Solo Injuries: Stops acute joint sprains, lower back impingement, and knee ligament damage.</a:t>
+            </a:r>
+          </a:p>
+          <a:p>
+            <a:pPr>
+              <a:spcAft>
+                <a:spcPts val="1000"/>
+              </a:spcAft>
+              <a:defRPr sz="1500">
+                <a:solidFill>
+                  <a:srgbClr val="E2E8F0"/>
+                </a:solidFill>
+              </a:defRPr>
+            </a:pPr>
+            <a:r>
+              <a:t>• Sub-15ms Real-Time Feedback: Gives spoken voice coaching before bad habits set into muscle memory.</a:t>
+            </a:r>
+          </a:p>
+          <a:p>
+            <a:pPr>
+              <a:spcAft>
+                <a:spcPts val="1000"/>
+              </a:spcAft>
+              <a:defRPr sz="1500">
+                <a:solidFill>
+                  <a:srgbClr val="E2E8F0"/>
+                </a:solidFill>
+              </a:defRPr>
+            </a:pPr>
+            <a:r>
+              <a:t>• Strict Anti-Cheating: Rejects false postures (unjoined hands, floating feet) to ensure true alignment.</a:t>
+            </a:r>
+          </a:p>
+          <a:p>
+            <a:pPr>
+              <a:spcAft>
+                <a:spcPts val="1000"/>
+              </a:spcAft>
+              <a:defRPr sz="1500">
+                <a:solidFill>
+                  <a:srgbClr val="E2E8F0"/>
+                </a:solidFill>
+              </a:defRPr>
+            </a:pPr>
+            <a:r>
+              <a:t>• Objective Telemetry: Automatically records stability, hold duration, and symmetry in local IndexedDB.</a:t>
             </a:r>
           </a:p>
         </p:txBody>
@@ -4159,7 +4137,7 @@
         </p:nvSpPr>
         <p:spPr>
           <a:xfrm>
-            <a:off x="731520" y="685800"/>
+            <a:off x="731520" y="640080"/>
             <a:ext cx="10698480" cy="685800"/>
           </a:xfrm>
           <a:prstGeom prst="rect">
@@ -4174,7 +4152,7 @@
           <a:lstStyle/>
           <a:p>
             <a:pPr>
-              <a:defRPr sz="2600" b="1">
+              <a:defRPr sz="2800" b="1">
                 <a:solidFill>
                   <a:srgbClr val="FFFFFF"/>
                 </a:solidFill>
@@ -4195,7 +4173,7 @@
         <p:spPr>
           <a:xfrm>
             <a:off x="731520" y="1463040"/>
-            <a:ext cx="5120640" cy="2331720"/>
+            <a:ext cx="5120640" cy="4846320"/>
           </a:xfrm>
           <a:prstGeom prst="roundRect">
             <a:avLst/>
@@ -4203,7 +4181,7 @@
           <a:solidFill>
             <a:srgbClr val="1E293B"/>
           </a:solidFill>
-          <a:ln w="19050">
+          <a:ln w="25400">
             <a:solidFill>
               <a:srgbClr val="EF4444"/>
             </a:solidFill>
@@ -4239,8 +4217,8 @@
         </p:nvSpPr>
         <p:spPr>
           <a:xfrm>
-            <a:off x="960120" y="1645920"/>
-            <a:ext cx="4663440" cy="1965960"/>
+            <a:off x="1005840" y="1719072"/>
+            <a:ext cx="4572000" cy="4334256"/>
           </a:xfrm>
           <a:prstGeom prst="rect">
             <a:avLst/>
@@ -4255,61 +4233,76 @@
           <a:p>
             <a:pPr>
               <a:spcAft>
-                <a:spcPts val="800"/>
-              </a:spcAft>
-              <a:defRPr sz="1600" b="1">
+                <a:spcPts val="1200"/>
+              </a:spcAft>
+              <a:defRPr sz="2000" b="1">
                 <a:solidFill>
                   <a:srgbClr val="EF4444"/>
                 </a:solidFill>
               </a:defRPr>
             </a:pPr>
             <a:r>
-              <a:t>⚠️ High Injury Rates in Solo Practice</a:t>
-            </a:r>
-          </a:p>
-          <a:p>
-            <a:pPr>
-              <a:spcAft>
-                <a:spcPts val="500"/>
-              </a:spcAft>
-              <a:defRPr sz="1250">
-                <a:solidFill>
-                  <a:srgbClr val="CBD5E1"/>
-                </a:solidFill>
-              </a:defRPr>
-            </a:pPr>
-            <a:r>
-              <a:t>• Over 60% of solitary yoga practitioners suffer neck, spinal, or knee strains.</a:t>
-            </a:r>
-          </a:p>
-          <a:p>
-            <a:pPr>
-              <a:spcAft>
-                <a:spcPts val="500"/>
-              </a:spcAft>
-              <a:defRPr sz="1250">
-                <a:solidFill>
-                  <a:srgbClr val="CBD5E1"/>
-                </a:solidFill>
-              </a:defRPr>
-            </a:pPr>
-            <a:r>
-              <a:t>• Practitioners cannot view a mirror while balancing or twisting without twisting spine.</a:t>
-            </a:r>
-          </a:p>
-          <a:p>
-            <a:pPr>
-              <a:spcAft>
-                <a:spcPts val="500"/>
-              </a:spcAft>
-              <a:defRPr sz="1250">
-                <a:solidFill>
-                  <a:srgbClr val="CBD5E1"/>
-                </a:solidFill>
-              </a:defRPr>
-            </a:pPr>
-            <a:r>
-              <a:t>• Without guidance, bad posture is reinforced into permanent muscle memory.</a:t>
+              <a:t>⚠️ Solitary Practice Risks</a:t>
+            </a:r>
+          </a:p>
+          <a:p>
+            <a:pPr>
+              <a:spcAft>
+                <a:spcPts val="1000"/>
+              </a:spcAft>
+              <a:defRPr sz="1500">
+                <a:solidFill>
+                  <a:srgbClr val="E2E8F0"/>
+                </a:solidFill>
+              </a:defRPr>
+            </a:pPr>
+            <a:r>
+              <a:t>• High Injury Frequency: Over 60% of solo practitioners sustain neck, lower back, or knee strain.</a:t>
+            </a:r>
+          </a:p>
+          <a:p>
+            <a:pPr>
+              <a:spcAft>
+                <a:spcPts val="1000"/>
+              </a:spcAft>
+              <a:defRPr sz="1500">
+                <a:solidFill>
+                  <a:srgbClr val="E2E8F0"/>
+                </a:solidFill>
+              </a:defRPr>
+            </a:pPr>
+            <a:r>
+              <a:t>• No Visual Correction: Looking into a mirror while balancing twists the cervical spine dangerously.</a:t>
+            </a:r>
+          </a:p>
+          <a:p>
+            <a:pPr>
+              <a:spcAft>
+                <a:spcPts val="1000"/>
+              </a:spcAft>
+              <a:defRPr sz="1500">
+                <a:solidFill>
+                  <a:srgbClr val="E2E8F0"/>
+                </a:solidFill>
+              </a:defRPr>
+            </a:pPr>
+            <a:r>
+              <a:t>• Permanent Bad Habits: Repeating flawed joint alignment ingrains harmful posture into muscle memory.</a:t>
+            </a:r>
+          </a:p>
+          <a:p>
+            <a:pPr>
+              <a:spcAft>
+                <a:spcPts val="1000"/>
+              </a:spcAft>
+              <a:defRPr sz="1500">
+                <a:solidFill>
+                  <a:srgbClr val="E2E8F0"/>
+                </a:solidFill>
+              </a:defRPr>
+            </a:pPr>
+            <a:r>
+              <a:t>• High Dropout Rate: Over 70% of fitness beginners abandon solo routines due to a lack of guidance.</a:t>
             </a:r>
           </a:p>
         </p:txBody>
@@ -4323,7 +4316,7 @@
         <p:spPr>
           <a:xfrm>
             <a:off x="6309360" y="1463040"/>
-            <a:ext cx="5120640" cy="2331720"/>
+            <a:ext cx="5120640" cy="4846320"/>
           </a:xfrm>
           <a:prstGeom prst="roundRect">
             <a:avLst/>
@@ -4331,7 +4324,7 @@
           <a:solidFill>
             <a:srgbClr val="1E293B"/>
           </a:solidFill>
-          <a:ln w="19050">
+          <a:ln w="25400">
             <a:solidFill>
               <a:srgbClr val="F59E0B"/>
             </a:solidFill>
@@ -4367,8 +4360,8 @@
         </p:nvSpPr>
         <p:spPr>
           <a:xfrm>
-            <a:off x="6537960" y="1645920"/>
-            <a:ext cx="4663440" cy="1965960"/>
+            <a:off x="6583680" y="1719072"/>
+            <a:ext cx="4572000" cy="4334256"/>
           </a:xfrm>
           <a:prstGeom prst="rect">
             <a:avLst/>
@@ -4383,317 +4376,76 @@
           <a:p>
             <a:pPr>
               <a:spcAft>
-                <a:spcPts val="800"/>
-              </a:spcAft>
-              <a:defRPr sz="1600" b="1">
+                <a:spcPts val="1200"/>
+              </a:spcAft>
+              <a:defRPr sz="2000" b="1">
                 <a:solidFill>
                   <a:srgbClr val="F59E0B"/>
                 </a:solidFill>
               </a:defRPr>
             </a:pPr>
             <a:r>
-              <a:t>💸 Financial &amp; Geographic Inaccessibility</a:t>
-            </a:r>
-          </a:p>
-          <a:p>
-            <a:pPr>
-              <a:spcAft>
-                <a:spcPts val="500"/>
-              </a:spcAft>
-              <a:defRPr sz="1250">
-                <a:solidFill>
-                  <a:srgbClr val="CBD5E1"/>
-                </a:solidFill>
-              </a:defRPr>
-            </a:pPr>
-            <a:r>
-              <a:t>• Personal certified yoga therapists charge $50–$100/hr, unaffordable for common families.</a:t>
-            </a:r>
-          </a:p>
-          <a:p>
-            <a:pPr>
-              <a:spcAft>
-                <a:spcPts val="500"/>
-              </a:spcAft>
-              <a:defRPr sz="1250">
-                <a:solidFill>
-                  <a:srgbClr val="CBD5E1"/>
-                </a:solidFill>
-              </a:defRPr>
-            </a:pPr>
-            <a:r>
-              <a:t>• Rural educational institutions lack access to qualified yoga instructors.</a:t>
-            </a:r>
-          </a:p>
-          <a:p>
-            <a:pPr>
-              <a:spcAft>
-                <a:spcPts val="500"/>
-              </a:spcAft>
-              <a:defRPr sz="1250">
-                <a:solidFill>
-                  <a:srgbClr val="CBD5E1"/>
-                </a:solidFill>
-              </a:defRPr>
-            </a:pPr>
-            <a:r>
-              <a:t>• Over 70% of beginners give up solo routines due to a lack of feedback.</a:t>
-            </a:r>
-          </a:p>
-        </p:txBody>
-      </p:sp>
-      <p:sp>
-        <p:nvSpPr>
-          <p:cNvPr id="9" name="Rounded Rectangle 8"/>
-          <p:cNvSpPr/>
-          <p:nvPr/>
-        </p:nvSpPr>
-        <p:spPr>
-          <a:xfrm>
-            <a:off x="731520" y="3977639"/>
-            <a:ext cx="5120640" cy="2331720"/>
-          </a:xfrm>
-          <a:prstGeom prst="roundRect">
-            <a:avLst/>
-          </a:prstGeom>
-          <a:solidFill>
-            <a:srgbClr val="1E293B"/>
-          </a:solidFill>
-          <a:ln w="19050">
-            <a:solidFill>
-              <a:srgbClr val="A855F7"/>
-            </a:solidFill>
-          </a:ln>
-        </p:spPr>
-        <p:style>
-          <a:lnRef idx="1">
-            <a:schemeClr val="accent1"/>
-          </a:lnRef>
-          <a:fillRef idx="3">
-            <a:schemeClr val="accent1"/>
-          </a:fillRef>
-          <a:effectRef idx="2">
-            <a:schemeClr val="accent1"/>
-          </a:effectRef>
-          <a:fontRef idx="minor">
-            <a:schemeClr val="lt1"/>
-          </a:fontRef>
-        </p:style>
-        <p:txBody>
-          <a:bodyPr rtlCol="0" anchor="ctr"/>
-          <a:lstStyle/>
-          <a:p>
-            <a:pPr algn="ctr"/>
-          </a:p>
-        </p:txBody>
-      </p:sp>
-      <p:sp>
-        <p:nvSpPr>
-          <p:cNvPr id="10" name="TextBox 9"/>
-          <p:cNvSpPr txBox="1"/>
-          <p:nvPr/>
-        </p:nvSpPr>
-        <p:spPr>
-          <a:xfrm>
-            <a:off x="960120" y="4160519"/>
-            <a:ext cx="4663440" cy="1965960"/>
-          </a:xfrm>
-          <a:prstGeom prst="rect">
-            <a:avLst/>
-          </a:prstGeom>
-          <a:noFill/>
-        </p:spPr>
-        <p:txBody>
-          <a:bodyPr wrap="square">
-            <a:spAutoFit/>
-          </a:bodyPr>
-          <a:lstStyle/>
-          <a:p>
-            <a:pPr>
-              <a:spcAft>
-                <a:spcPts val="800"/>
-              </a:spcAft>
-              <a:defRPr sz="1600" b="1">
-                <a:solidFill>
-                  <a:srgbClr val="A855F7"/>
-                </a:solidFill>
-              </a:defRPr>
-            </a:pPr>
-            <a:r>
-              <a:t>🔒 Cloud Privacy Violations &amp; Latency</a:t>
-            </a:r>
-          </a:p>
-          <a:p>
-            <a:pPr>
-              <a:spcAft>
-                <a:spcPts val="500"/>
-              </a:spcAft>
-              <a:defRPr sz="1250">
-                <a:solidFill>
-                  <a:srgbClr val="CBD5E1"/>
-                </a:solidFill>
-              </a:defRPr>
-            </a:pPr>
-            <a:r>
-              <a:t>• Commercial AI apps upload live camera streams to remote servers, violating privacy.</a:t>
-            </a:r>
-          </a:p>
-          <a:p>
-            <a:pPr>
-              <a:spcAft>
-                <a:spcPts val="500"/>
-              </a:spcAft>
-              <a:defRPr sz="1250">
-                <a:solidFill>
-                  <a:srgbClr val="CBD5E1"/>
-                </a:solidFill>
-              </a:defRPr>
-            </a:pPr>
-            <a:r>
-              <a:t>• Cloud network latency (300ms–800ms) produces choppy, delayed posture corrections.</a:t>
-            </a:r>
-          </a:p>
-          <a:p>
-            <a:pPr>
-              <a:spcAft>
-                <a:spcPts val="500"/>
-              </a:spcAft>
-              <a:defRPr sz="1250">
-                <a:solidFill>
-                  <a:srgbClr val="CBD5E1"/>
-                </a:solidFill>
-              </a:defRPr>
-            </a:pPr>
-            <a:r>
-              <a:t>• High bandwidth requirements cause total failure in rural or offline venues.</a:t>
-            </a:r>
-          </a:p>
-        </p:txBody>
-      </p:sp>
-      <p:sp>
-        <p:nvSpPr>
-          <p:cNvPr id="11" name="Rounded Rectangle 10"/>
-          <p:cNvSpPr/>
-          <p:nvPr/>
-        </p:nvSpPr>
-        <p:spPr>
-          <a:xfrm>
-            <a:off x="6309360" y="3977639"/>
-            <a:ext cx="5120640" cy="2331720"/>
-          </a:xfrm>
-          <a:prstGeom prst="roundRect">
-            <a:avLst/>
-          </a:prstGeom>
-          <a:solidFill>
-            <a:srgbClr val="1E293B"/>
-          </a:solidFill>
-          <a:ln w="19050">
-            <a:solidFill>
-              <a:srgbClr val="0EA5E9"/>
-            </a:solidFill>
-          </a:ln>
-        </p:spPr>
-        <p:style>
-          <a:lnRef idx="1">
-            <a:schemeClr val="accent1"/>
-          </a:lnRef>
-          <a:fillRef idx="3">
-            <a:schemeClr val="accent1"/>
-          </a:fillRef>
-          <a:effectRef idx="2">
-            <a:schemeClr val="accent1"/>
-          </a:effectRef>
-          <a:fontRef idx="minor">
-            <a:schemeClr val="lt1"/>
-          </a:fontRef>
-        </p:style>
-        <p:txBody>
-          <a:bodyPr rtlCol="0" anchor="ctr"/>
-          <a:lstStyle/>
-          <a:p>
-            <a:pPr algn="ctr"/>
-          </a:p>
-        </p:txBody>
-      </p:sp>
-      <p:sp>
-        <p:nvSpPr>
-          <p:cNvPr id="12" name="TextBox 11"/>
-          <p:cNvSpPr txBox="1"/>
-          <p:nvPr/>
-        </p:nvSpPr>
-        <p:spPr>
-          <a:xfrm>
-            <a:off x="6537960" y="4160519"/>
-            <a:ext cx="4663440" cy="1965960"/>
-          </a:xfrm>
-          <a:prstGeom prst="rect">
-            <a:avLst/>
-          </a:prstGeom>
-          <a:noFill/>
-        </p:spPr>
-        <p:txBody>
-          <a:bodyPr wrap="square">
-            <a:spAutoFit/>
-          </a:bodyPr>
-          <a:lstStyle/>
-          <a:p>
-            <a:pPr>
-              <a:spcAft>
-                <a:spcPts val="800"/>
-              </a:spcAft>
-              <a:defRPr sz="1600" b="1">
-                <a:solidFill>
-                  <a:srgbClr val="0EA5E9"/>
-                </a:solidFill>
-              </a:defRPr>
-            </a:pPr>
-            <a:r>
-              <a:t>📺 The Fatal Flaw of YouTube Videos</a:t>
-            </a:r>
-          </a:p>
-          <a:p>
-            <a:pPr>
-              <a:spcAft>
-                <a:spcPts val="500"/>
-              </a:spcAft>
-              <a:defRPr sz="1250">
-                <a:solidFill>
-                  <a:srgbClr val="CBD5E1"/>
-                </a:solidFill>
-              </a:defRPr>
-            </a:pPr>
-            <a:r>
-              <a:t>• Pre-recorded video tutorials provide zero real-time posture feedback.</a:t>
-            </a:r>
-          </a:p>
-          <a:p>
-            <a:pPr>
-              <a:spcAft>
-                <a:spcPts val="500"/>
-              </a:spcAft>
-              <a:defRPr sz="1250">
-                <a:solidFill>
-                  <a:srgbClr val="CBD5E1"/>
-                </a:solidFill>
-              </a:defRPr>
-            </a:pPr>
-            <a:r>
-              <a:t>• Users unknowingly cheat poses (unjoined hands, hyper-extended knees, false balance).</a:t>
-            </a:r>
-          </a:p>
-          <a:p>
-            <a:pPr>
-              <a:spcAft>
-                <a:spcPts val="500"/>
-              </a:spcAft>
-              <a:defRPr sz="1250">
-                <a:solidFill>
-                  <a:srgbClr val="CBD5E1"/>
-                </a:solidFill>
-              </a:defRPr>
-            </a:pPr>
-            <a:r>
-              <a:t>• Creates a false sense of accomplishment while spinal alignment remains flawed.</a:t>
+              <a:t>❌ Flaws of Current Solutions</a:t>
+            </a:r>
+          </a:p>
+          <a:p>
+            <a:pPr>
+              <a:spcAft>
+                <a:spcPts val="1000"/>
+              </a:spcAft>
+              <a:defRPr sz="1500">
+                <a:solidFill>
+                  <a:srgbClr val="E2E8F0"/>
+                </a:solidFill>
+              </a:defRPr>
+            </a:pPr>
+            <a:r>
+              <a:t>• Expensive Personal Coaches: Certified instructors charge $50–$100/hr, unaffordable for most families.</a:t>
+            </a:r>
+          </a:p>
+          <a:p>
+            <a:pPr>
+              <a:spcAft>
+                <a:spcPts val="1000"/>
+              </a:spcAft>
+              <a:defRPr sz="1500">
+                <a:solidFill>
+                  <a:srgbClr val="E2E8F0"/>
+                </a:solidFill>
+              </a:defRPr>
+            </a:pPr>
+            <a:r>
+              <a:t>• YouTube Videos are Passive: Pre-recorded videos provide zero real-time correction or form evaluation.</a:t>
+            </a:r>
+          </a:p>
+          <a:p>
+            <a:pPr>
+              <a:spcAft>
+                <a:spcPts val="1000"/>
+              </a:spcAft>
+              <a:defRPr sz="1500">
+                <a:solidFill>
+                  <a:srgbClr val="E2E8F0"/>
+                </a:solidFill>
+              </a:defRPr>
+            </a:pPr>
+            <a:r>
+              <a:t>• Commercial Fitness Apps: Cost $30–$80/month and upload private home video feeds to cloud servers.</a:t>
+            </a:r>
+          </a:p>
+          <a:p>
+            <a:pPr>
+              <a:spcAft>
+                <a:spcPts val="1000"/>
+              </a:spcAft>
+              <a:defRPr sz="1500">
+                <a:solidFill>
+                  <a:srgbClr val="E2E8F0"/>
+                </a:solidFill>
+              </a:defRPr>
+            </a:pPr>
+            <a:r>
+              <a:t>• Cloud Network Latency: High latency (400–800ms) causes choppy corrections that arrive too late.</a:t>
             </a:r>
           </a:p>
         </p:txBody>
@@ -4802,7 +4554,7 @@
         </p:nvSpPr>
         <p:spPr>
           <a:xfrm>
-            <a:off x="731520" y="685800"/>
+            <a:off x="731520" y="640080"/>
             <a:ext cx="10698480" cy="685800"/>
           </a:xfrm>
           <a:prstGeom prst="rect">
@@ -4817,7 +4569,7 @@
           <a:lstStyle/>
           <a:p>
             <a:pPr>
-              <a:defRPr sz="2600" b="1">
+              <a:defRPr sz="2800" b="1">
                 <a:solidFill>
                   <a:srgbClr val="FFFFFF"/>
                 </a:solidFill>
@@ -4846,7 +4598,7 @@
           <a:solidFill>
             <a:srgbClr val="1E293B"/>
           </a:solidFill>
-          <a:ln w="19050">
+          <a:ln w="25400">
             <a:solidFill>
               <a:srgbClr val="10B981"/>
             </a:solidFill>
@@ -4882,8 +4634,8 @@
         </p:nvSpPr>
         <p:spPr>
           <a:xfrm>
-            <a:off x="960120" y="1645920"/>
-            <a:ext cx="4663440" cy="4480560"/>
+            <a:off x="1005840" y="1719072"/>
+            <a:ext cx="4572000" cy="4334256"/>
           </a:xfrm>
           <a:prstGeom prst="rect">
             <a:avLst/>
@@ -4898,9 +4650,9 @@
           <a:p>
             <a:pPr>
               <a:spcAft>
-                <a:spcPts val="800"/>
-              </a:spcAft>
-              <a:defRPr sz="1600" b="1">
+                <a:spcPts val="1200"/>
+              </a:spcAft>
+              <a:defRPr sz="2000" b="1">
                 <a:solidFill>
                   <a:srgbClr val="10B981"/>
                 </a:solidFill>
@@ -4913,61 +4665,61 @@
           <a:p>
             <a:pPr>
               <a:spcAft>
-                <a:spcPts val="500"/>
-              </a:spcAft>
-              <a:defRPr sz="1250">
-                <a:solidFill>
-                  <a:srgbClr val="CBD5E1"/>
-                </a:solidFill>
-              </a:defRPr>
-            </a:pPr>
-            <a:r>
-              <a:t>• 1. Anti-Cheating Hand &amp; Leg Gates: Hands must be in prayer/overhead; one straight standing leg and one elevated foot required.</a:t>
-            </a:r>
-          </a:p>
-          <a:p>
-            <a:pPr>
-              <a:spcAft>
-                <a:spcPts val="500"/>
-              </a:spcAft>
-              <a:defRPr sz="1250">
-                <a:solidFill>
-                  <a:srgbClr val="CBD5E1"/>
-                </a:solidFill>
-              </a:defRPr>
-            </a:pPr>
-            <a:r>
-              <a:t>• 2. Natural Biomechanical Tolerances: Relaxed thresholds (wrist distance &lt;65% torso, knee bend &gt;130°) so real human postures score smoothly.</a:t>
-            </a:r>
-          </a:p>
-          <a:p>
-            <a:pPr>
-              <a:spcAft>
-                <a:spcPts val="500"/>
-              </a:spcAft>
-              <a:defRPr sz="1250">
-                <a:solidFill>
-                  <a:srgbClr val="CBD5E1"/>
-                </a:solidFill>
-              </a:defRPr>
-            </a:pPr>
-            <a:r>
-              <a:t>• 3. Dual Landscape &amp; Portrait Modes: One-click switcher toggles between 4:3 Wide Studio &amp; 3:4 Tall Full-Body view for standing postures.</a:t>
-            </a:r>
-          </a:p>
-          <a:p>
-            <a:pPr>
-              <a:spcAft>
-                <a:spcPts val="500"/>
-              </a:spcAft>
-              <a:defRPr sz="1250">
-                <a:solidFill>
-                  <a:srgbClr val="CBD5E1"/>
-                </a:solidFill>
-              </a:defRPr>
-            </a:pPr>
-            <a:r>
-              <a:t>• 4. Side-by-Side Reference Studio: Target pose reference photo is positioned cleanly next to camera stream across all screen sizes.</a:t>
+                <a:spcPts val="1000"/>
+              </a:spcAft>
+              <a:defRPr sz="1450">
+                <a:solidFill>
+                  <a:srgbClr val="E2E8F0"/>
+                </a:solidFill>
+              </a:defRPr>
+            </a:pPr>
+            <a:r>
+              <a:t>• Anti-Cheating Hand &amp; Leg Gates: Hands must be in prayer/overhead (&lt;65% torso); one straight leg (&gt;130°) and one elevated foot required.</a:t>
+            </a:r>
+          </a:p>
+          <a:p>
+            <a:pPr>
+              <a:spcAft>
+                <a:spcPts val="1000"/>
+              </a:spcAft>
+              <a:defRPr sz="1450">
+                <a:solidFill>
+                  <a:srgbClr val="E2E8F0"/>
+                </a:solidFill>
+              </a:defRPr>
+            </a:pPr>
+            <a:r>
+              <a:t>• Natural Biomechanical Tolerances: Realistic thresholds allow real human bodies to score accurately without robotic stiffness.</a:t>
+            </a:r>
+          </a:p>
+          <a:p>
+            <a:pPr>
+              <a:spcAft>
+                <a:spcPts val="1000"/>
+              </a:spcAft>
+              <a:defRPr sz="1450">
+                <a:solidFill>
+                  <a:srgbClr val="E2E8F0"/>
+                </a:solidFill>
+              </a:defRPr>
+            </a:pPr>
+            <a:r>
+              <a:t>• Dual Landscape &amp; Portrait Modes: One-click switcher toggles between 4:3 Wide Studio &amp; 3:4 Tall Full-Body view for standing postures.</a:t>
+            </a:r>
+          </a:p>
+          <a:p>
+            <a:pPr>
+              <a:spcAft>
+                <a:spcPts val="1000"/>
+              </a:spcAft>
+              <a:defRPr sz="1450">
+                <a:solidFill>
+                  <a:srgbClr val="E2E8F0"/>
+                </a:solidFill>
+              </a:defRPr>
+            </a:pPr>
+            <a:r>
+              <a:t>• Side-by-Side Reference Studio: Target pose reference illustration stays clearly aligned beside camera stream on all screen sizes.</a:t>
             </a:r>
           </a:p>
         </p:txBody>
@@ -4989,7 +4741,7 @@
           <a:solidFill>
             <a:srgbClr val="1E293B"/>
           </a:solidFill>
-          <a:ln w="19050">
+          <a:ln w="25400">
             <a:solidFill>
               <a:srgbClr val="0EA5E9"/>
             </a:solidFill>
@@ -5025,8 +4777,8 @@
         </p:nvSpPr>
         <p:spPr>
           <a:xfrm>
-            <a:off x="6537960" y="1645920"/>
-            <a:ext cx="4663440" cy="4480560"/>
+            <a:off x="6583680" y="1719072"/>
+            <a:ext cx="4572000" cy="4334256"/>
           </a:xfrm>
           <a:prstGeom prst="rect">
             <a:avLst/>
@@ -5041,9 +4793,9 @@
           <a:p>
             <a:pPr>
               <a:spcAft>
-                <a:spcPts val="800"/>
-              </a:spcAft>
-              <a:defRPr sz="1600" b="1">
+                <a:spcPts val="1200"/>
+              </a:spcAft>
+              <a:defRPr sz="2000" b="1">
                 <a:solidFill>
                   <a:srgbClr val="0EA5E9"/>
                 </a:solidFill>
@@ -5056,46 +4808,46 @@
           <a:p>
             <a:pPr>
               <a:spcAft>
-                <a:spcPts val="500"/>
-              </a:spcAft>
-              <a:defRPr sz="1250">
-                <a:solidFill>
-                  <a:srgbClr val="CBD5E1"/>
-                </a:solidFill>
-              </a:defRPr>
-            </a:pPr>
-            <a:r>
-              <a:t>• 5. True Stillness Tracking: Center-of-Gravity variance only monitors while in active target pose, ending false 'still' reports.</a:t>
-            </a:r>
-          </a:p>
-          <a:p>
-            <a:pPr>
-              <a:spcAft>
-                <a:spcPts val="500"/>
-              </a:spcAft>
-              <a:defRPr sz="1250">
-                <a:solidFill>
-                  <a:srgbClr val="CBD5E1"/>
-                </a:solidFill>
-              </a:defRPr>
-            </a:pPr>
-            <a:r>
-              <a:t>• 6. 10-Second Auto-Closing Modal: Displays post-pose diagnostic scorecard with countdown progress bar, pause-on-hover, and auto-dismiss.</a:t>
-            </a:r>
-          </a:p>
-          <a:p>
-            <a:pPr>
-              <a:spcAft>
-                <a:spcPts val="500"/>
-              </a:spcAft>
-              <a:defRPr sz="1250">
-                <a:solidFill>
-                  <a:srgbClr val="CBD5E1"/>
-                </a:solidFill>
-              </a:defRPr>
-            </a:pPr>
-            <a:r>
-              <a:t>• 7. Full Scrollability &amp; Offline Analytics: Soft-tinted custom scrollbars, always-visible dual SVG charts, and JSON data export.</a:t>
+                <a:spcPts val="1000"/>
+              </a:spcAft>
+              <a:defRPr sz="1450">
+                <a:solidFill>
+                  <a:srgbClr val="E2E8F0"/>
+                </a:solidFill>
+              </a:defRPr>
+            </a:pPr>
+            <a:r>
+              <a:t>• True Stillness Tracking: Center-of-Gravity variance only monitors while in active target pose, ending false 'still' reports.</a:t>
+            </a:r>
+          </a:p>
+          <a:p>
+            <a:pPr>
+              <a:spcAft>
+                <a:spcPts val="1000"/>
+              </a:spcAft>
+              <a:defRPr sz="1450">
+                <a:solidFill>
+                  <a:srgbClr val="E2E8F0"/>
+                </a:solidFill>
+              </a:defRPr>
+            </a:pPr>
+            <a:r>
+              <a:t>• 10-Second Auto-Closing Modal: Displays post-pose diagnostic scorecard with countdown progress bar, pause-on-hover, and auto-dismiss.</a:t>
+            </a:r>
+          </a:p>
+          <a:p>
+            <a:pPr>
+              <a:spcAft>
+                <a:spcPts val="1000"/>
+              </a:spcAft>
+              <a:defRPr sz="1450">
+                <a:solidFill>
+                  <a:srgbClr val="E2E8F0"/>
+                </a:solidFill>
+              </a:defRPr>
+            </a:pPr>
+            <a:r>
+              <a:t>• Full Scrollability &amp; Offline Analytics: Soft-tinted custom scrollbars, always-visible dual SVG charts, and JSON data export.</a:t>
             </a:r>
           </a:p>
         </p:txBody>
@@ -5204,7 +4956,7 @@
         </p:nvSpPr>
         <p:spPr>
           <a:xfrm>
-            <a:off x="731520" y="685800"/>
+            <a:off x="731520" y="640080"/>
             <a:ext cx="10698480" cy="685800"/>
           </a:xfrm>
           <a:prstGeom prst="rect">
@@ -5219,7 +4971,7 @@
           <a:lstStyle/>
           <a:p>
             <a:pPr>
-              <a:defRPr sz="2600" b="1">
+              <a:defRPr sz="2800" b="1">
                 <a:solidFill>
                   <a:srgbClr val="FFFFFF"/>
                 </a:solidFill>
@@ -5240,7 +4992,7 @@
         <p:spPr>
           <a:xfrm>
             <a:off x="731520" y="1463040"/>
-            <a:ext cx="5120640" cy="2331720"/>
+            <a:ext cx="5120640" cy="4846320"/>
           </a:xfrm>
           <a:prstGeom prst="roundRect">
             <a:avLst/>
@@ -5248,7 +5000,7 @@
           <a:solidFill>
             <a:srgbClr val="1E293B"/>
           </a:solidFill>
-          <a:ln w="19050">
+          <a:ln w="25400">
             <a:solidFill>
               <a:srgbClr val="10B981"/>
             </a:solidFill>
@@ -5284,8 +5036,8 @@
         </p:nvSpPr>
         <p:spPr>
           <a:xfrm>
-            <a:off x="960120" y="1645920"/>
-            <a:ext cx="4663440" cy="1965960"/>
+            <a:off x="1005840" y="1719072"/>
+            <a:ext cx="4572000" cy="4334256"/>
           </a:xfrm>
           <a:prstGeom prst="rect">
             <a:avLst/>
@@ -5300,76 +5052,76 @@
           <a:p>
             <a:pPr>
               <a:spcAft>
-                <a:spcPts val="800"/>
-              </a:spcAft>
-              <a:defRPr sz="1600" b="1">
+                <a:spcPts val="1200"/>
+              </a:spcAft>
+              <a:defRPr sz="2000" b="1">
                 <a:solidFill>
                   <a:srgbClr val="10B981"/>
                 </a:solidFill>
               </a:defRPr>
             </a:pPr>
             <a:r>
-              <a:t>📐 1. Vector Joint Angle Formulation</a:t>
-            </a:r>
-          </a:p>
-          <a:p>
-            <a:pPr>
-              <a:spcAft>
-                <a:spcPts val="500"/>
-              </a:spcAft>
-              <a:defRPr sz="1250">
-                <a:solidFill>
-                  <a:srgbClr val="CBD5E1"/>
-                </a:solidFill>
-              </a:defRPr>
-            </a:pPr>
-            <a:r>
-              <a:t>• Calculates 2D joint angle θ at vertex B formed by limbs BA and BC:</a:t>
-            </a:r>
-          </a:p>
-          <a:p>
-            <a:pPr>
-              <a:spcAft>
-                <a:spcPts val="500"/>
-              </a:spcAft>
-              <a:defRPr sz="1250">
-                <a:solidFill>
-                  <a:srgbClr val="CBD5E1"/>
-                </a:solidFill>
-              </a:defRPr>
-            </a:pPr>
-            <a:r>
-              <a:t>• θ = arccos( (u • v) / (||u|| * ||v||) )</a:t>
-            </a:r>
-          </a:p>
-          <a:p>
-            <a:pPr>
-              <a:spcAft>
-                <a:spcPts val="500"/>
-              </a:spcAft>
-              <a:defRPr sz="1250">
-                <a:solidFill>
-                  <a:srgbClr val="CBD5E1"/>
-                </a:solidFill>
-              </a:defRPr>
-            </a:pPr>
-            <a:r>
-              <a:t>• where u = A - B and v = C - B; evaluated directly in degrees.</a:t>
-            </a:r>
-          </a:p>
-          <a:p>
-            <a:pPr>
-              <a:spcAft>
-                <a:spcPts val="500"/>
-              </a:spcAft>
-              <a:defRPr sz="1250">
-                <a:solidFill>
-                  <a:srgbClr val="CBD5E1"/>
-                </a:solidFill>
-              </a:defRPr>
-            </a:pPr>
-            <a:r>
-              <a:t>• Monitors elbow extension, knee flexion, hip abduction, and shoulder alignment.</a:t>
+              <a:t>📐 Vector Angles &amp; Distance Normalization</a:t>
+            </a:r>
+          </a:p>
+          <a:p>
+            <a:pPr>
+              <a:spcAft>
+                <a:spcPts val="1000"/>
+              </a:spcAft>
+              <a:defRPr sz="1450">
+                <a:solidFill>
+                  <a:srgbClr val="E2E8F0"/>
+                </a:solidFill>
+              </a:defRPr>
+            </a:pPr>
+            <a:r>
+              <a:t>• Calculates 2D Joint Angles at Vertices: θ = arccos( (u • v) / (||u|| * ||v||) ), evaluating knees, hips, and shoulders in real time.</a:t>
+            </a:r>
+          </a:p>
+          <a:p>
+            <a:pPr>
+              <a:spcAft>
+                <a:spcPts val="1000"/>
+              </a:spcAft>
+              <a:defRPr sz="1450">
+                <a:solidFill>
+                  <a:srgbClr val="E2E8F0"/>
+                </a:solidFill>
+              </a:defRPr>
+            </a:pPr>
+            <a:r>
+              <a:t>• Scale &amp; Distance Invariance: Normalizes all coordinates against Torso Length = ||Shoulders_Center - Hips_Center||.</a:t>
+            </a:r>
+          </a:p>
+          <a:p>
+            <a:pPr>
+              <a:spcAft>
+                <a:spcPts val="1000"/>
+              </a:spcAft>
+              <a:defRPr sz="1450">
+                <a:solidFill>
+                  <a:srgbClr val="E2E8F0"/>
+                </a:solidFill>
+              </a:defRPr>
+            </a:pPr>
+            <a:r>
+              <a:t>• Universal Distance Coverage: Operates identically whether practitioner stands 1.5 meters or 3.5 meters from webcam.</a:t>
+            </a:r>
+          </a:p>
+          <a:p>
+            <a:pPr>
+              <a:spcAft>
+                <a:spcPts val="1000"/>
+              </a:spcAft>
+              <a:defRPr sz="1450">
+                <a:solidFill>
+                  <a:srgbClr val="E2E8F0"/>
+                </a:solidFill>
+              </a:defRPr>
+            </a:pPr>
+            <a:r>
+              <a:t>• Automatic Body Adaptation: Accommodates children, adults, tall, and short individuals with zero manual calibration.</a:t>
             </a:r>
           </a:p>
         </p:txBody>
@@ -5383,7 +5135,7 @@
         <p:spPr>
           <a:xfrm>
             <a:off x="6309360" y="1463040"/>
-            <a:ext cx="5120640" cy="2331720"/>
+            <a:ext cx="5120640" cy="4846320"/>
           </a:xfrm>
           <a:prstGeom prst="roundRect">
             <a:avLst/>
@@ -5391,7 +5143,7 @@
           <a:solidFill>
             <a:srgbClr val="1E293B"/>
           </a:solidFill>
-          <a:ln w="19050">
+          <a:ln w="25400">
             <a:solidFill>
               <a:srgbClr val="0EA5E9"/>
             </a:solidFill>
@@ -5427,8 +5179,8 @@
         </p:nvSpPr>
         <p:spPr>
           <a:xfrm>
-            <a:off x="6537960" y="1645920"/>
-            <a:ext cx="4663440" cy="1965960"/>
+            <a:off x="6583680" y="1719072"/>
+            <a:ext cx="4572000" cy="4334256"/>
           </a:xfrm>
           <a:prstGeom prst="rect">
             <a:avLst/>
@@ -5443,362 +5195,76 @@
           <a:p>
             <a:pPr>
               <a:spcAft>
-                <a:spcPts val="800"/>
-              </a:spcAft>
-              <a:defRPr sz="1600" b="1">
+                <a:spcPts val="1200"/>
+              </a:spcAft>
+              <a:defRPr sz="2000" b="1">
                 <a:solidFill>
                   <a:srgbClr val="0EA5E9"/>
                 </a:solidFill>
               </a:defRPr>
             </a:pPr>
             <a:r>
-              <a:t>🌊 2. EMA Keypoint Jitter Smoothing</a:t>
-            </a:r>
-          </a:p>
-          <a:p>
-            <a:pPr>
-              <a:spcAft>
-                <a:spcPts val="500"/>
-              </a:spcAft>
-              <a:defRPr sz="1250">
-                <a:solidFill>
-                  <a:srgbClr val="CBD5E1"/>
-                </a:solidFill>
-              </a:defRPr>
-            </a:pPr>
-            <a:r>
-              <a:t>• Eliminates high-frequency webcam sensor jitter via Exponential Moving Average:</a:t>
-            </a:r>
-          </a:p>
-          <a:p>
-            <a:pPr>
-              <a:spcAft>
-                <a:spcPts val="500"/>
-              </a:spcAft>
-              <a:defRPr sz="1250">
-                <a:solidFill>
-                  <a:srgbClr val="CBD5E1"/>
-                </a:solidFill>
-              </a:defRPr>
-            </a:pPr>
-            <a:r>
-              <a:t>• S(t) = α * Y(t) + (1 - α) * S(t-1)   where α = 0.65</a:t>
-            </a:r>
-          </a:p>
-          <a:p>
-            <a:pPr>
-              <a:spcAft>
-                <a:spcPts val="500"/>
-              </a:spcAft>
-              <a:defRPr sz="1250">
-                <a:solidFill>
-                  <a:srgbClr val="CBD5E1"/>
-                </a:solidFill>
-              </a:defRPr>
-            </a:pPr>
-            <a:r>
-              <a:t>• Yields stable skeleton positions without perceptible lag.</a:t>
-            </a:r>
-          </a:p>
-          <a:p>
-            <a:pPr>
-              <a:spcAft>
-                <a:spcPts val="500"/>
-              </a:spcAft>
-              <a:defRPr sz="1250">
-                <a:solidFill>
-                  <a:srgbClr val="CBD5E1"/>
-                </a:solidFill>
-              </a:defRPr>
-            </a:pPr>
-            <a:r>
-              <a:t>• Prevents false angle fluctuation during stationary balance holding.</a:t>
-            </a:r>
-          </a:p>
-        </p:txBody>
-      </p:sp>
-      <p:sp>
-        <p:nvSpPr>
-          <p:cNvPr id="9" name="Rounded Rectangle 8"/>
-          <p:cNvSpPr/>
-          <p:nvPr/>
-        </p:nvSpPr>
-        <p:spPr>
-          <a:xfrm>
-            <a:off x="731520" y="3977639"/>
-            <a:ext cx="5120640" cy="2331720"/>
-          </a:xfrm>
-          <a:prstGeom prst="roundRect">
-            <a:avLst/>
-          </a:prstGeom>
-          <a:solidFill>
-            <a:srgbClr val="1E293B"/>
-          </a:solidFill>
-          <a:ln w="19050">
-            <a:solidFill>
-              <a:srgbClr val="F59E0B"/>
-            </a:solidFill>
-          </a:ln>
-        </p:spPr>
-        <p:style>
-          <a:lnRef idx="1">
-            <a:schemeClr val="accent1"/>
-          </a:lnRef>
-          <a:fillRef idx="3">
-            <a:schemeClr val="accent1"/>
-          </a:fillRef>
-          <a:effectRef idx="2">
-            <a:schemeClr val="accent1"/>
-          </a:effectRef>
-          <a:fontRef idx="minor">
-            <a:schemeClr val="lt1"/>
-          </a:fontRef>
-        </p:style>
-        <p:txBody>
-          <a:bodyPr rtlCol="0" anchor="ctr"/>
-          <a:lstStyle/>
-          <a:p>
-            <a:pPr algn="ctr"/>
-          </a:p>
-        </p:txBody>
-      </p:sp>
-      <p:sp>
-        <p:nvSpPr>
-          <p:cNvPr id="10" name="TextBox 9"/>
-          <p:cNvSpPr txBox="1"/>
-          <p:nvPr/>
-        </p:nvSpPr>
-        <p:spPr>
-          <a:xfrm>
-            <a:off x="960120" y="4160519"/>
-            <a:ext cx="4663440" cy="1965960"/>
-          </a:xfrm>
-          <a:prstGeom prst="rect">
-            <a:avLst/>
-          </a:prstGeom>
-          <a:noFill/>
-        </p:spPr>
-        <p:txBody>
-          <a:bodyPr wrap="square">
-            <a:spAutoFit/>
-          </a:bodyPr>
-          <a:lstStyle/>
-          <a:p>
-            <a:pPr>
-              <a:spcAft>
-                <a:spcPts val="800"/>
-              </a:spcAft>
-              <a:defRPr sz="1600" b="1">
-                <a:solidFill>
-                  <a:srgbClr val="F59E0B"/>
-                </a:solidFill>
-              </a:defRPr>
-            </a:pPr>
-            <a:r>
-              <a:t>⚖️ 3. Center-of-Gravity (CoG) Spatial Variance</a:t>
-            </a:r>
-          </a:p>
-          <a:p>
-            <a:pPr>
-              <a:spcAft>
-                <a:spcPts val="500"/>
-              </a:spcAft>
-              <a:defRPr sz="1250">
-                <a:solidFill>
-                  <a:srgbClr val="CBD5E1"/>
-                </a:solidFill>
-              </a:defRPr>
-            </a:pPr>
-            <a:r>
-              <a:t>• Measures micro-movements across a rolling 15-frame window:</a:t>
-            </a:r>
-          </a:p>
-          <a:p>
-            <a:pPr>
-              <a:spcAft>
-                <a:spcPts val="500"/>
-              </a:spcAft>
-              <a:defRPr sz="1250">
-                <a:solidFill>
-                  <a:srgbClr val="CBD5E1"/>
-                </a:solidFill>
-              </a:defRPr>
-            </a:pPr>
-            <a:r>
-              <a:t>• σ² = (1/N) * Σ ||CoG(i) - mean(CoG)||²</a:t>
-            </a:r>
-          </a:p>
-          <a:p>
-            <a:pPr>
-              <a:spcAft>
-                <a:spcPts val="500"/>
-              </a:spcAft>
-              <a:defRPr sz="1250">
-                <a:solidFill>
-                  <a:srgbClr val="CBD5E1"/>
-                </a:solidFill>
-              </a:defRPr>
-            </a:pPr>
-            <a:r>
-              <a:t>• When user wobbles excessively, the posture hold timer pauses safely.</a:t>
-            </a:r>
-          </a:p>
-          <a:p>
-            <a:pPr>
-              <a:spcAft>
-                <a:spcPts val="500"/>
-              </a:spcAft>
-              <a:defRPr sz="1250">
-                <a:solidFill>
-                  <a:srgbClr val="CBD5E1"/>
-                </a:solidFill>
-              </a:defRPr>
-            </a:pPr>
-            <a:r>
-              <a:t>• Gated strictly: only operates when a user is actively performing the pose.</a:t>
-            </a:r>
-          </a:p>
-        </p:txBody>
-      </p:sp>
-      <p:sp>
-        <p:nvSpPr>
-          <p:cNvPr id="11" name="Rounded Rectangle 10"/>
-          <p:cNvSpPr/>
-          <p:nvPr/>
-        </p:nvSpPr>
-        <p:spPr>
-          <a:xfrm>
-            <a:off x="6309360" y="3977639"/>
-            <a:ext cx="5120640" cy="2331720"/>
-          </a:xfrm>
-          <a:prstGeom prst="roundRect">
-            <a:avLst/>
-          </a:prstGeom>
-          <a:solidFill>
-            <a:srgbClr val="1E293B"/>
-          </a:solidFill>
-          <a:ln w="19050">
-            <a:solidFill>
-              <a:srgbClr val="A855F7"/>
-            </a:solidFill>
-          </a:ln>
-        </p:spPr>
-        <p:style>
-          <a:lnRef idx="1">
-            <a:schemeClr val="accent1"/>
-          </a:lnRef>
-          <a:fillRef idx="3">
-            <a:schemeClr val="accent1"/>
-          </a:fillRef>
-          <a:effectRef idx="2">
-            <a:schemeClr val="accent1"/>
-          </a:effectRef>
-          <a:fontRef idx="minor">
-            <a:schemeClr val="lt1"/>
-          </a:fontRef>
-        </p:style>
-        <p:txBody>
-          <a:bodyPr rtlCol="0" anchor="ctr"/>
-          <a:lstStyle/>
-          <a:p>
-            <a:pPr algn="ctr"/>
-          </a:p>
-        </p:txBody>
-      </p:sp>
-      <p:sp>
-        <p:nvSpPr>
-          <p:cNvPr id="12" name="TextBox 11"/>
-          <p:cNvSpPr txBox="1"/>
-          <p:nvPr/>
-        </p:nvSpPr>
-        <p:spPr>
-          <a:xfrm>
-            <a:off x="6537960" y="4160519"/>
-            <a:ext cx="4663440" cy="1965960"/>
-          </a:xfrm>
-          <a:prstGeom prst="rect">
-            <a:avLst/>
-          </a:prstGeom>
-          <a:noFill/>
-        </p:spPr>
-        <p:txBody>
-          <a:bodyPr wrap="square">
-            <a:spAutoFit/>
-          </a:bodyPr>
-          <a:lstStyle/>
-          <a:p>
-            <a:pPr>
-              <a:spcAft>
-                <a:spcPts val="800"/>
-              </a:spcAft>
-              <a:defRPr sz="1600" b="1">
-                <a:solidFill>
-                  <a:srgbClr val="A855F7"/>
-                </a:solidFill>
-              </a:defRPr>
-            </a:pPr>
-            <a:r>
-              <a:t>📏 4. Scale &amp; Distance Invariance</a:t>
-            </a:r>
-          </a:p>
-          <a:p>
-            <a:pPr>
-              <a:spcAft>
-                <a:spcPts val="500"/>
-              </a:spcAft>
-              <a:defRPr sz="1250">
-                <a:solidFill>
-                  <a:srgbClr val="CBD5E1"/>
-                </a:solidFill>
-              </a:defRPr>
-            </a:pPr>
-            <a:r>
-              <a:t>• Normalizes coordinate space relative to practitioner's physical torso size:</a:t>
-            </a:r>
-          </a:p>
-          <a:p>
-            <a:pPr>
-              <a:spcAft>
-                <a:spcPts val="500"/>
-              </a:spcAft>
-              <a:defRPr sz="1250">
-                <a:solidFill>
-                  <a:srgbClr val="CBD5E1"/>
-                </a:solidFill>
-              </a:defRPr>
-            </a:pPr>
-            <a:r>
-              <a:t>• Torso Length = ||Shoulders_Center - Hips_Center||</a:t>
-            </a:r>
-          </a:p>
-          <a:p>
-            <a:pPr>
-              <a:spcAft>
-                <a:spcPts val="500"/>
-              </a:spcAft>
-              <a:defRPr sz="1250">
-                <a:solidFill>
-                  <a:srgbClr val="CBD5E1"/>
-                </a:solidFill>
-              </a:defRPr>
-            </a:pPr>
-            <a:r>
-              <a:t>• Allows identical evaluation whether user is 1.5m or 3.5m away from webcam.</a:t>
-            </a:r>
-          </a:p>
-          <a:p>
-            <a:pPr>
-              <a:spcAft>
-                <a:spcPts val="500"/>
-              </a:spcAft>
-              <a:defRPr sz="1250">
-                <a:solidFill>
-                  <a:srgbClr val="CBD5E1"/>
-                </a:solidFill>
-              </a:defRPr>
-            </a:pPr>
-            <a:r>
-              <a:t>• Accommodates children, adults, and different body builds automatically.</a:t>
+              <a:t>⚖️ True Stillness &amp; EMA Jitter Smoothing</a:t>
+            </a:r>
+          </a:p>
+          <a:p>
+            <a:pPr>
+              <a:spcAft>
+                <a:spcPts val="1000"/>
+              </a:spcAft>
+              <a:defRPr sz="1450">
+                <a:solidFill>
+                  <a:srgbClr val="E2E8F0"/>
+                </a:solidFill>
+              </a:defRPr>
+            </a:pPr>
+            <a:r>
+              <a:t>• Sensor Noise Filtering: S(t) = α * Y(t) + (1 - α) * S(t-1) with α = 0.65 removes webcam flicker with zero perceived delay.</a:t>
+            </a:r>
+          </a:p>
+          <a:p>
+            <a:pPr>
+              <a:spcAft>
+                <a:spcPts val="1000"/>
+              </a:spcAft>
+              <a:defRPr sz="1450">
+                <a:solidFill>
+                  <a:srgbClr val="E2E8F0"/>
+                </a:solidFill>
+              </a:defRPr>
+            </a:pPr>
+            <a:r>
+              <a:t>• Postural Stillness Calculation: Measures rolling Center-of-Gravity variance σ² = (1/N) * Σ ||CoG(i) - mean(CoG)||² across 15 frames.</a:t>
+            </a:r>
+          </a:p>
+          <a:p>
+            <a:pPr>
+              <a:spcAft>
+                <a:spcPts val="1000"/>
+              </a:spcAft>
+              <a:defRPr sz="1450">
+                <a:solidFill>
+                  <a:srgbClr val="E2E8F0"/>
+                </a:solidFill>
+              </a:defRPr>
+            </a:pPr>
+            <a:r>
+              <a:t>• Active-Pose Stillness Gate: Stillness is ONLY calculated when the target yoga pose is actively held, ending false 'still' reports.</a:t>
+            </a:r>
+          </a:p>
+          <a:p>
+            <a:pPr>
+              <a:spcAft>
+                <a:spcPts val="1000"/>
+              </a:spcAft>
+              <a:defRPr sz="1450">
+                <a:solidFill>
+                  <a:srgbClr val="E2E8F0"/>
+                </a:solidFill>
+              </a:defRPr>
+            </a:pPr>
+            <a:r>
+              <a:t>• Dynamic Stability Score: Generates an objective stability score (0-100%) and pauses timer if practitioner starts wobbling.</a:t>
             </a:r>
           </a:p>
         </p:txBody>
@@ -5907,7 +5373,7 @@
         </p:nvSpPr>
         <p:spPr>
           <a:xfrm>
-            <a:off x="731520" y="685800"/>
+            <a:off x="731520" y="640080"/>
             <a:ext cx="10698480" cy="685800"/>
           </a:xfrm>
           <a:prstGeom prst="rect">
@@ -5922,7 +5388,7 @@
           <a:lstStyle/>
           <a:p>
             <a:pPr>
-              <a:defRPr sz="2600" b="1">
+              <a:defRPr sz="2800" b="1">
                 <a:solidFill>
                   <a:srgbClr val="FFFFFF"/>
                 </a:solidFill>
@@ -5951,7 +5417,7 @@
           <a:solidFill>
             <a:srgbClr val="1E293B"/>
           </a:solidFill>
-          <a:ln w="19050">
+          <a:ln w="25400">
             <a:solidFill>
               <a:srgbClr val="10B981"/>
             </a:solidFill>
@@ -5987,8 +5453,8 @@
         </p:nvSpPr>
         <p:spPr>
           <a:xfrm>
-            <a:off x="960120" y="1645920"/>
-            <a:ext cx="4663440" cy="4480560"/>
+            <a:off x="1005840" y="1719072"/>
+            <a:ext cx="4572000" cy="4334256"/>
           </a:xfrm>
           <a:prstGeom prst="rect">
             <a:avLst/>
@@ -6003,76 +5469,76 @@
           <a:p>
             <a:pPr>
               <a:spcAft>
-                <a:spcPts val="800"/>
-              </a:spcAft>
-              <a:defRPr sz="1600" b="1">
+                <a:spcPts val="1200"/>
+              </a:spcAft>
+              <a:defRPr sz="2000" b="1">
                 <a:solidFill>
                   <a:srgbClr val="10B981"/>
                 </a:solidFill>
               </a:defRPr>
             </a:pPr>
             <a:r>
-              <a:t>🧘 Standing &amp; Balance Poses</a:t>
-            </a:r>
-          </a:p>
-          <a:p>
-            <a:pPr>
-              <a:spcAft>
-                <a:spcPts val="500"/>
-              </a:spcAft>
-              <a:defRPr sz="1200">
-                <a:solidFill>
-                  <a:srgbClr val="CBD5E1"/>
-                </a:solidFill>
-              </a:defRPr>
-            </a:pPr>
-            <a:r>
-              <a:t>• Tree Pose (Vrikshasana): Hands joined in prayer/overhead (&lt;65% torso); one straight leg (&gt;130°) and one elevated foot. Strengthens balance.</a:t>
-            </a:r>
-          </a:p>
-          <a:p>
-            <a:pPr>
-              <a:spcAft>
-                <a:spcPts val="500"/>
-              </a:spcAft>
-              <a:defRPr sz="1200">
-                <a:solidFill>
-                  <a:srgbClr val="CBD5E1"/>
-                </a:solidFill>
-              </a:defRPr>
-            </a:pPr>
-            <a:r>
-              <a:t>• Chair Pose (Utkatasana): Bilateral knees flexed parallel between 75° and 145°; arms raised along ears. Builds quadriceps and core strength.</a:t>
-            </a:r>
-          </a:p>
-          <a:p>
-            <a:pPr>
-              <a:spcAft>
-                <a:spcPts val="500"/>
-              </a:spcAft>
-              <a:defRPr sz="1200">
-                <a:solidFill>
-                  <a:srgbClr val="CBD5E1"/>
-                </a:solidFill>
-              </a:defRPr>
-            </a:pPr>
-            <a:r>
-              <a:t>• Warrior Pose (Virabhadrasana): Lunge with front knee bent (65°-135°), rear leg extended (&gt;135°); torso centered. Opens hips and chest.</a:t>
-            </a:r>
-          </a:p>
-          <a:p>
-            <a:pPr>
-              <a:spcAft>
-                <a:spcPts val="500"/>
-              </a:spcAft>
-              <a:defRPr sz="1200">
-                <a:solidFill>
-                  <a:srgbClr val="CBD5E1"/>
-                </a:solidFill>
-              </a:defRPr>
-            </a:pPr>
-            <a:r>
-              <a:t>• Downward Dog (Adho Mukha): Inverted 'V' shape; hips apex at highest point; arms and hamstrings extended. Calms nervous system.</a:t>
+              <a:t>🧘 Standing &amp; Balance Asanas</a:t>
+            </a:r>
+          </a:p>
+          <a:p>
+            <a:pPr>
+              <a:spcAft>
+                <a:spcPts val="1000"/>
+              </a:spcAft>
+              <a:defRPr sz="1400">
+                <a:solidFill>
+                  <a:srgbClr val="E2E8F0"/>
+                </a:solidFill>
+              </a:defRPr>
+            </a:pPr>
+            <a:r>
+              <a:t>• Tree Pose (Vrikshasana): Hands joined overhead (&lt;65% torso); standing leg straight (&gt;130°) and folded foot elevated off ground.</a:t>
+            </a:r>
+          </a:p>
+          <a:p>
+            <a:pPr>
+              <a:spcAft>
+                <a:spcPts val="1000"/>
+              </a:spcAft>
+              <a:defRPr sz="1400">
+                <a:solidFill>
+                  <a:srgbClr val="E2E8F0"/>
+                </a:solidFill>
+              </a:defRPr>
+            </a:pPr>
+            <a:r>
+              <a:t>• Chair Pose (Utkatasana): Bilateral knees flexed parallel between 75° and 145°; arms raised overhead along ears to strengthen core.</a:t>
+            </a:r>
+          </a:p>
+          <a:p>
+            <a:pPr>
+              <a:spcAft>
+                <a:spcPts val="1000"/>
+              </a:spcAft>
+              <a:defRPr sz="1400">
+                <a:solidFill>
+                  <a:srgbClr val="E2E8F0"/>
+                </a:solidFill>
+              </a:defRPr>
+            </a:pPr>
+            <a:r>
+              <a:t>• Warrior Pose (Virabhadrasana): Lunge with front knee bent (65°-135°), rear leg extended (&gt;135°); torso centered over pelvis.</a:t>
+            </a:r>
+          </a:p>
+          <a:p>
+            <a:pPr>
+              <a:spcAft>
+                <a:spcPts val="1000"/>
+              </a:spcAft>
+              <a:defRPr sz="1400">
+                <a:solidFill>
+                  <a:srgbClr val="E2E8F0"/>
+                </a:solidFill>
+              </a:defRPr>
+            </a:pPr>
+            <a:r>
+              <a:t>• Triangle Pose (Trikonasana): Lateral spinal hinge; arms in 180° vertical vector; leading knee protected against hyperextension.</a:t>
             </a:r>
           </a:p>
         </p:txBody>
@@ -6094,7 +5560,7 @@
           <a:solidFill>
             <a:srgbClr val="1E293B"/>
           </a:solidFill>
-          <a:ln w="19050">
+          <a:ln w="25400">
             <a:solidFill>
               <a:srgbClr val="0EA5E9"/>
             </a:solidFill>
@@ -6130,8 +5596,8 @@
         </p:nvSpPr>
         <p:spPr>
           <a:xfrm>
-            <a:off x="6537960" y="1645920"/>
-            <a:ext cx="4663440" cy="4480560"/>
+            <a:off x="6583680" y="1719072"/>
+            <a:ext cx="4572000" cy="4334256"/>
           </a:xfrm>
           <a:prstGeom prst="rect">
             <a:avLst/>
@@ -6146,61 +5612,76 @@
           <a:p>
             <a:pPr>
               <a:spcAft>
-                <a:spcPts val="800"/>
-              </a:spcAft>
-              <a:defRPr sz="1600" b="1">
+                <a:spcPts val="1200"/>
+              </a:spcAft>
+              <a:defRPr sz="2000" b="1">
                 <a:solidFill>
                   <a:srgbClr val="0EA5E9"/>
                 </a:solidFill>
               </a:defRPr>
             </a:pPr>
             <a:r>
-              <a:t>🧘 Floor, Prone &amp; Inversion Poses</a:t>
-            </a:r>
-          </a:p>
-          <a:p>
-            <a:pPr>
-              <a:spcAft>
-                <a:spcPts val="500"/>
-              </a:spcAft>
-              <a:defRPr sz="1200">
-                <a:solidFill>
-                  <a:srgbClr val="CBD5E1"/>
-                </a:solidFill>
-              </a:defRPr>
-            </a:pPr>
-            <a:r>
-              <a:t>• Cobra Pose (Bhujangasana): Chest lifted &gt;20° above hips; soft micro-bend in elbows to prevent spinal impingement. Decompresses lumbar discs.</a:t>
-            </a:r>
-          </a:p>
-          <a:p>
-            <a:pPr>
-              <a:spcAft>
-                <a:spcPts val="500"/>
-              </a:spcAft>
-              <a:defRPr sz="1200">
-                <a:solidFill>
-                  <a:srgbClr val="CBD5E1"/>
-                </a:solidFill>
-              </a:defRPr>
-            </a:pPr>
-            <a:r>
-              <a:t>• Shoulderstand (Sarvangasana): Full body inversion; hips and legs vertically stacked above shoulders. Stimulates thyroid and circulation.</a:t>
-            </a:r>
-          </a:p>
-          <a:p>
-            <a:pPr>
-              <a:spcAft>
-                <a:spcPts val="500"/>
-              </a:spcAft>
-              <a:defRPr sz="1200">
-                <a:solidFill>
-                  <a:srgbClr val="CBD5E1"/>
-                </a:solidFill>
-              </a:defRPr>
-            </a:pPr>
-            <a:r>
-              <a:t>• Triangle Pose (Trikonasana): Lateral spinal hinge; arms in 180° vertical vector; leading knee protected against lockout. Lengthens hamstrings.</a:t>
+              <a:t>🧘 Floor, Prone &amp; Inversion Asanas</a:t>
+            </a:r>
+          </a:p>
+          <a:p>
+            <a:pPr>
+              <a:spcAft>
+                <a:spcPts val="1000"/>
+              </a:spcAft>
+              <a:defRPr sz="1400">
+                <a:solidFill>
+                  <a:srgbClr val="E2E8F0"/>
+                </a:solidFill>
+              </a:defRPr>
+            </a:pPr>
+            <a:r>
+              <a:t>• Downward Dog (Adho Mukha): Inverted 'V' shape; hips apex at highest point; arms and hamstrings lengthened with soft micro-bends.</a:t>
+            </a:r>
+          </a:p>
+          <a:p>
+            <a:pPr>
+              <a:spcAft>
+                <a:spcPts val="1000"/>
+              </a:spcAft>
+              <a:defRPr sz="1400">
+                <a:solidFill>
+                  <a:srgbClr val="E2E8F0"/>
+                </a:solidFill>
+              </a:defRPr>
+            </a:pPr>
+            <a:r>
+              <a:t>• Cobra Pose (Bhujangasana): Chest lifted &gt;20° from floor; soft micro-bend in elbows to prevent lumbar spinal compression.</a:t>
+            </a:r>
+          </a:p>
+          <a:p>
+            <a:pPr>
+              <a:spcAft>
+                <a:spcPts val="1000"/>
+              </a:spcAft>
+              <a:defRPr sz="1400">
+                <a:solidFill>
+                  <a:srgbClr val="E2E8F0"/>
+                </a:solidFill>
+              </a:defRPr>
+            </a:pPr>
+            <a:r>
+              <a:t>• Shoulderstand (Sarvangasana): Full body inversion; hips and legs vertically stacked above shoulders with core engagement.</a:t>
+            </a:r>
+          </a:p>
+          <a:p>
+            <a:pPr>
+              <a:spcAft>
+                <a:spcPts val="1000"/>
+              </a:spcAft>
+              <a:defRPr sz="1400">
+                <a:solidFill>
+                  <a:srgbClr val="E2E8F0"/>
+                </a:solidFill>
+              </a:defRPr>
+            </a:pPr>
+            <a:r>
+              <a:t>• Negative 'No Pose' Class: Detects standing, walking, stretching, or seated adjustments so idle moments never accumulate score.</a:t>
             </a:r>
           </a:p>
         </p:txBody>
@@ -6309,7 +5790,7 @@
         </p:nvSpPr>
         <p:spPr>
           <a:xfrm>
-            <a:off x="731520" y="685800"/>
+            <a:off x="731520" y="640080"/>
             <a:ext cx="10698480" cy="685800"/>
           </a:xfrm>
           <a:prstGeom prst="rect">
@@ -6324,7 +5805,7 @@
           <a:lstStyle/>
           <a:p>
             <a:pPr>
-              <a:defRPr sz="2600" b="1">
+              <a:defRPr sz="2800" b="1">
                 <a:solidFill>
                   <a:srgbClr val="FFFFFF"/>
                 </a:solidFill>
@@ -6353,7 +5834,7 @@
           <a:solidFill>
             <a:srgbClr val="1E293B"/>
           </a:solidFill>
-          <a:ln w="19050">
+          <a:ln w="25400">
             <a:solidFill>
               <a:srgbClr val="10B981"/>
             </a:solidFill>
@@ -6389,8 +5870,8 @@
         </p:nvSpPr>
         <p:spPr>
           <a:xfrm>
-            <a:off x="960120" y="1645920"/>
-            <a:ext cx="4663440" cy="4480560"/>
+            <a:off x="1005840" y="1719072"/>
+            <a:ext cx="4572000" cy="4334256"/>
           </a:xfrm>
           <a:prstGeom prst="rect">
             <a:avLst/>
@@ -6405,9 +5886,9 @@
           <a:p>
             <a:pPr>
               <a:spcAft>
-                <a:spcPts val="800"/>
-              </a:spcAft>
-              <a:defRPr sz="1600" b="1">
+                <a:spcPts val="1200"/>
+              </a:spcAft>
+              <a:defRPr sz="2000" b="1">
                 <a:solidFill>
                   <a:srgbClr val="10B981"/>
                 </a:solidFill>
@@ -6420,71 +5901,71 @@
           <a:p>
             <a:pPr>
               <a:spcAft>
-                <a:spcPts val="500"/>
-              </a:spcAft>
-              <a:defRPr sz="1200">
-                <a:solidFill>
-                  <a:srgbClr val="CBD5E1"/>
-                </a:solidFill>
-              </a:defRPr>
-            </a:pPr>
-            <a:r>
-              <a:t>• Landscape (640x480): Wide studio perspective ideal for mat floor poses like Downward Dog and Cobra.</a:t>
-            </a:r>
-          </a:p>
-          <a:p>
-            <a:pPr>
-              <a:spcAft>
-                <a:spcPts val="500"/>
-              </a:spcAft>
-              <a:defRPr sz="1200">
-                <a:solidFill>
-                  <a:srgbClr val="CBD5E1"/>
-                </a:solidFill>
-              </a:defRPr>
-            </a:pPr>
-            <a:r>
-              <a:t>• Portrait (480x640): Tall full-body perspective ideal for vertical standing poses like Tree and Chair.</a:t>
-            </a:r>
-          </a:p>
-          <a:p>
-            <a:pPr>
-              <a:spcAft>
-                <a:spcPts val="500"/>
-              </a:spcAft>
-              <a:defRPr sz="1200">
-                <a:solidFill>
-                  <a:srgbClr val="CBD5E1"/>
-                </a:solidFill>
-              </a:defRPr>
-            </a:pPr>
-            <a:r>
-              <a:t>• One-Click Live Switcher: Instant toggle button on the camera HUD switches resolution without reloading models.</a:t>
-            </a:r>
-          </a:p>
-          <a:p>
-            <a:pPr>
-              <a:spcAft>
-                <a:spcPts val="500"/>
-              </a:spcAft>
-              <a:defRPr sz="1200">
-                <a:solidFill>
-                  <a:srgbClr val="CBD5E1"/>
-                </a:solidFill>
-              </a:defRPr>
-            </a:pPr>
-            <a:r>
-              <a:t>• Responsive Stage: Flexbox layout displays camera feed and target reference photo side-by-side on all screens.</a:t>
-            </a:r>
-          </a:p>
-          <a:p>
-            <a:pPr>
-              <a:spcAft>
-                <a:spcPts val="500"/>
-              </a:spcAft>
-              <a:defRPr sz="1200">
-                <a:solidFill>
-                  <a:srgbClr val="CBD5E1"/>
+                <a:spcPts val="1000"/>
+              </a:spcAft>
+              <a:defRPr sz="1450">
+                <a:solidFill>
+                  <a:srgbClr val="E2E8F0"/>
+                </a:solidFill>
+              </a:defRPr>
+            </a:pPr>
+            <a:r>
+              <a:t>• Landscape (640x480): Wide studio perspective ideal for mat floor poses like Downward Dog, Cobra, and Triangle.</a:t>
+            </a:r>
+          </a:p>
+          <a:p>
+            <a:pPr>
+              <a:spcAft>
+                <a:spcPts val="1000"/>
+              </a:spcAft>
+              <a:defRPr sz="1450">
+                <a:solidFill>
+                  <a:srgbClr val="E2E8F0"/>
+                </a:solidFill>
+              </a:defRPr>
+            </a:pPr>
+            <a:r>
+              <a:t>• Portrait (480x640): Tall full-body perspective ideal for vertical standing poses like Tree Pose and Chair Pose.</a:t>
+            </a:r>
+          </a:p>
+          <a:p>
+            <a:pPr>
+              <a:spcAft>
+                <a:spcPts val="1000"/>
+              </a:spcAft>
+              <a:defRPr sz="1450">
+                <a:solidFill>
+                  <a:srgbClr val="E2E8F0"/>
+                </a:solidFill>
+              </a:defRPr>
+            </a:pPr>
+            <a:r>
+              <a:t>• One-Click Live Switcher: Instant toggle button on the camera HUD switches resolution without reloading neural models.</a:t>
+            </a:r>
+          </a:p>
+          <a:p>
+            <a:pPr>
+              <a:spcAft>
+                <a:spcPts val="1000"/>
+              </a:spcAft>
+              <a:defRPr sz="1450">
+                <a:solidFill>
+                  <a:srgbClr val="E2E8F0"/>
+                </a:solidFill>
+              </a:defRPr>
+            </a:pPr>
+            <a:r>
+              <a:t>• Responsive Studio Stage: Displays live camera feed and target reference photo side-by-side on all screen sizes.</a:t>
+            </a:r>
+          </a:p>
+          <a:p>
+            <a:pPr>
+              <a:spcAft>
+                <a:spcPts val="1000"/>
+              </a:spcAft>
+              <a:defRPr sz="1450">
+                <a:solidFill>
+                  <a:srgbClr val="E2E8F0"/>
                 </a:solidFill>
               </a:defRPr>
             </a:pPr>
@@ -6511,7 +5992,7 @@
           <a:solidFill>
             <a:srgbClr val="1E293B"/>
           </a:solidFill>
-          <a:ln w="19050">
+          <a:ln w="25400">
             <a:solidFill>
               <a:srgbClr val="F59E0B"/>
             </a:solidFill>
@@ -6547,8 +6028,8 @@
         </p:nvSpPr>
         <p:spPr>
           <a:xfrm>
-            <a:off x="6537960" y="1645920"/>
-            <a:ext cx="4663440" cy="4480560"/>
+            <a:off x="6583680" y="1719072"/>
+            <a:ext cx="4572000" cy="4334256"/>
           </a:xfrm>
           <a:prstGeom prst="rect">
             <a:avLst/>
@@ -6563,9 +6044,9 @@
           <a:p>
             <a:pPr>
               <a:spcAft>
-                <a:spcPts val="800"/>
-              </a:spcAft>
-              <a:defRPr sz="1600" b="1">
+                <a:spcPts val="1200"/>
+              </a:spcAft>
+              <a:defRPr sz="2000" b="1">
                 <a:solidFill>
                   <a:srgbClr val="F59E0B"/>
                 </a:solidFill>
@@ -6578,11 +6059,11 @@
           <a:p>
             <a:pPr>
               <a:spcAft>
-                <a:spcPts val="500"/>
-              </a:spcAft>
-              <a:defRPr sz="1250">
-                <a:solidFill>
-                  <a:srgbClr val="CBD5E1"/>
+                <a:spcPts val="1000"/>
+              </a:spcAft>
+              <a:defRPr sz="1450">
+                <a:solidFill>
+                  <a:srgbClr val="E2E8F0"/>
                 </a:solidFill>
               </a:defRPr>
             </a:pPr>
@@ -6593,11 +6074,11 @@
           <a:p>
             <a:pPr>
               <a:spcAft>
-                <a:spcPts val="500"/>
-              </a:spcAft>
-              <a:defRPr sz="1250">
-                <a:solidFill>
-                  <a:srgbClr val="CBD5E1"/>
+                <a:spcPts val="1000"/>
+              </a:spcAft>
+              <a:defRPr sz="1450">
+                <a:solidFill>
+                  <a:srgbClr val="E2E8F0"/>
                 </a:solidFill>
               </a:defRPr>
             </a:pPr>
@@ -6608,11 +6089,11 @@
           <a:p>
             <a:pPr>
               <a:spcAft>
-                <a:spcPts val="500"/>
-              </a:spcAft>
-              <a:defRPr sz="1250">
-                <a:solidFill>
-                  <a:srgbClr val="CBD5E1"/>
+                <a:spcPts val="1000"/>
+              </a:spcAft>
+              <a:defRPr sz="1450">
+                <a:solidFill>
+                  <a:srgbClr val="E2E8F0"/>
                 </a:solidFill>
               </a:defRPr>
             </a:pPr>
@@ -6623,11 +6104,11 @@
           <a:p>
             <a:pPr>
               <a:spcAft>
-                <a:spcPts val="500"/>
-              </a:spcAft>
-              <a:defRPr sz="1250">
-                <a:solidFill>
-                  <a:srgbClr val="CBD5E1"/>
+                <a:spcPts val="1000"/>
+              </a:spcAft>
+              <a:defRPr sz="1450">
+                <a:solidFill>
+                  <a:srgbClr val="E2E8F0"/>
                 </a:solidFill>
               </a:defRPr>
             </a:pPr>
@@ -6741,7 +6222,7 @@
         </p:nvSpPr>
         <p:spPr>
           <a:xfrm>
-            <a:off x="731520" y="685800"/>
+            <a:off x="731520" y="640080"/>
             <a:ext cx="10698480" cy="685800"/>
           </a:xfrm>
           <a:prstGeom prst="rect">
@@ -6756,7 +6237,7 @@
           <a:lstStyle/>
           <a:p>
             <a:pPr>
-              <a:defRPr sz="2600" b="1">
+              <a:defRPr sz="2800" b="1">
                 <a:solidFill>
                   <a:srgbClr val="FFFFFF"/>
                 </a:solidFill>
@@ -6777,7 +6258,7 @@
         <p:spPr>
           <a:xfrm>
             <a:off x="731520" y="1463040"/>
-            <a:ext cx="3291840" cy="4846320"/>
+            <a:ext cx="5120640" cy="4846320"/>
           </a:xfrm>
           <a:prstGeom prst="roundRect">
             <a:avLst/>
@@ -6785,7 +6266,7 @@
           <a:solidFill>
             <a:srgbClr val="1E293B"/>
           </a:solidFill>
-          <a:ln w="19050">
+          <a:ln w="25400">
             <a:solidFill>
               <a:srgbClr val="10B981"/>
             </a:solidFill>
@@ -6821,8 +6302,8 @@
         </p:nvSpPr>
         <p:spPr>
           <a:xfrm>
-            <a:off x="960120" y="1645920"/>
-            <a:ext cx="2834640" cy="4480560"/>
+            <a:off x="1005840" y="1719072"/>
+            <a:ext cx="4572000" cy="4334256"/>
           </a:xfrm>
           <a:prstGeom prst="rect">
             <a:avLst/>
@@ -6837,76 +6318,76 @@
           <a:p>
             <a:pPr>
               <a:spcAft>
-                <a:spcPts val="800"/>
-              </a:spcAft>
-              <a:defRPr sz="1600" b="1">
+                <a:spcPts val="1200"/>
+              </a:spcAft>
+              <a:defRPr sz="2000" b="1">
                 <a:solidFill>
                   <a:srgbClr val="10B981"/>
                 </a:solidFill>
               </a:defRPr>
             </a:pPr>
             <a:r>
-              <a:t>🗄️ 100% Offline Database</a:t>
-            </a:r>
-          </a:p>
-          <a:p>
-            <a:pPr>
-              <a:spcAft>
-                <a:spcPts val="500"/>
-              </a:spcAft>
-              <a:defRPr sz="1250">
-                <a:solidFill>
-                  <a:srgbClr val="CBD5E1"/>
-                </a:solidFill>
-              </a:defRPr>
-            </a:pPr>
-            <a:r>
-              <a:t>• Uses browser IndexedDB ('YogaAIDB', store 'sessions').</a:t>
-            </a:r>
-          </a:p>
-          <a:p>
-            <a:pPr>
-              <a:spcAft>
-                <a:spcPts val="500"/>
-              </a:spcAft>
-              <a:defRPr sz="1250">
-                <a:solidFill>
-                  <a:srgbClr val="CBD5E1"/>
-                </a:solidFill>
-              </a:defRPr>
-            </a:pPr>
-            <a:r>
-              <a:t>• Zero cloud server subscriptions or ongoing data fees.</a:t>
-            </a:r>
-          </a:p>
-          <a:p>
-            <a:pPr>
-              <a:spcAft>
-                <a:spcPts val="500"/>
-              </a:spcAft>
-              <a:defRPr sz="1250">
-                <a:solidFill>
-                  <a:srgbClr val="CBD5E1"/>
-                </a:solidFill>
-              </a:defRPr>
-            </a:pPr>
-            <a:r>
-              <a:t>• Stores full workout telemetry locally on the client machine.</a:t>
-            </a:r>
-          </a:p>
-          <a:p>
-            <a:pPr>
-              <a:spcAft>
-                <a:spcPts val="500"/>
-              </a:spcAft>
-              <a:defRPr sz="1250">
-                <a:solidFill>
-                  <a:srgbClr val="CBD5E1"/>
-                </a:solidFill>
-              </a:defRPr>
-            </a:pPr>
-            <a:r>
-              <a:t>• Guarantees 100% biometric privacy: images and data never leave device.</a:t>
+              <a:t>🗄️ 100% Offline Client Database</a:t>
+            </a:r>
+          </a:p>
+          <a:p>
+            <a:pPr>
+              <a:spcAft>
+                <a:spcPts val="1000"/>
+              </a:spcAft>
+              <a:defRPr sz="1450">
+                <a:solidFill>
+                  <a:srgbClr val="E2E8F0"/>
+                </a:solidFill>
+              </a:defRPr>
+            </a:pPr>
+            <a:r>
+              <a:t>• Browser IndexedDB Storage: Employs local database 'YogaAIDB' with object store 'sessions' directly inside the client browser.</a:t>
+            </a:r>
+          </a:p>
+          <a:p>
+            <a:pPr>
+              <a:spcAft>
+                <a:spcPts val="1000"/>
+              </a:spcAft>
+              <a:defRPr sz="1450">
+                <a:solidFill>
+                  <a:srgbClr val="E2E8F0"/>
+                </a:solidFill>
+              </a:defRPr>
+            </a:pPr>
+            <a:r>
+              <a:t>• Zero Cloud Server Dependency: Eliminates monthly cloud hosting bills, database subscription costs, and user authentication walls.</a:t>
+            </a:r>
+          </a:p>
+          <a:p>
+            <a:pPr>
+              <a:spcAft>
+                <a:spcPts val="1000"/>
+              </a:spcAft>
+              <a:defRPr sz="1450">
+                <a:solidFill>
+                  <a:srgbClr val="E2E8F0"/>
+                </a:solidFill>
+              </a:defRPr>
+            </a:pPr>
+            <a:r>
+              <a:t>• 100% Biometric Privacy: Video streams, joint coordinates, and workout performance data never transmit over the network.</a:t>
+            </a:r>
+          </a:p>
+          <a:p>
+            <a:pPr>
+              <a:spcAft>
+                <a:spcPts val="1000"/>
+              </a:spcAft>
+              <a:defRPr sz="1450">
+                <a:solidFill>
+                  <a:srgbClr val="E2E8F0"/>
+                </a:solidFill>
+              </a:defRPr>
+            </a:pPr>
+            <a:r>
+              <a:t>• Permanent Session Retention: Automatically logs timestamp, pose name, hold duration, average accuracy, and stability score.</a:t>
             </a:r>
           </a:p>
         </p:txBody>
@@ -6919,8 +6400,8 @@
         </p:nvSpPr>
         <p:spPr>
           <a:xfrm>
-            <a:off x="4434840" y="1463040"/>
-            <a:ext cx="3291840" cy="4846320"/>
+            <a:off x="6309360" y="1463040"/>
+            <a:ext cx="5120640" cy="4846320"/>
           </a:xfrm>
           <a:prstGeom prst="roundRect">
             <a:avLst/>
@@ -6928,7 +6409,7 @@
           <a:solidFill>
             <a:srgbClr val="1E293B"/>
           </a:solidFill>
-          <a:ln w="19050">
+          <a:ln w="25400">
             <a:solidFill>
               <a:srgbClr val="0EA5E9"/>
             </a:solidFill>
@@ -6964,8 +6445,8 @@
         </p:nvSpPr>
         <p:spPr>
           <a:xfrm>
-            <a:off x="4663440" y="1645920"/>
-            <a:ext cx="2834640" cy="4480560"/>
+            <a:off x="6583680" y="1719072"/>
+            <a:ext cx="4572000" cy="4334256"/>
           </a:xfrm>
           <a:prstGeom prst="rect">
             <a:avLst/>
@@ -6980,219 +6461,76 @@
           <a:p>
             <a:pPr>
               <a:spcAft>
-                <a:spcPts val="800"/>
-              </a:spcAft>
-              <a:defRPr sz="1600" b="1">
+                <a:spcPts val="1200"/>
+              </a:spcAft>
+              <a:defRPr sz="2000" b="1">
                 <a:solidFill>
                   <a:srgbClr val="0EA5E9"/>
                 </a:solidFill>
               </a:defRPr>
             </a:pPr>
             <a:r>
-              <a:t>📊 Always-Visible Dual Charts</a:t>
-            </a:r>
-          </a:p>
-          <a:p>
-            <a:pPr>
-              <a:spcAft>
-                <a:spcPts val="500"/>
-              </a:spcAft>
-              <a:defRPr sz="1250">
-                <a:solidFill>
-                  <a:srgbClr val="CBD5E1"/>
-                </a:solidFill>
-              </a:defRPr>
-            </a:pPr>
-            <a:r>
-              <a:t>• Dual Performance Chart: Seamlessly renders dual Bar &amp; Line SVG visualization.</a:t>
-            </a:r>
-          </a:p>
-          <a:p>
-            <a:pPr>
-              <a:spcAft>
-                <a:spcPts val="500"/>
-              </a:spcAft>
-              <a:defRPr sz="1250">
-                <a:solidFill>
-                  <a:srgbClr val="CBD5E1"/>
-                </a:solidFill>
-              </a:defRPr>
-            </a:pPr>
-            <a:r>
-              <a:t>• Line curve illustrates stability trajectory while bars display posture score.</a:t>
-            </a:r>
-          </a:p>
-          <a:p>
-            <a:pPr>
-              <a:spcAft>
-                <a:spcPts val="500"/>
-              </a:spcAft>
-              <a:defRPr sz="1250">
-                <a:solidFill>
-                  <a:srgbClr val="CBD5E1"/>
-                </a:solidFill>
-              </a:defRPr>
-            </a:pPr>
-            <a:r>
-              <a:t>• Always displays target baseline data even on brand-new installations.</a:t>
-            </a:r>
-          </a:p>
-          <a:p>
-            <a:pPr>
-              <a:spcAft>
-                <a:spcPts val="500"/>
-              </a:spcAft>
-              <a:defRPr sz="1250">
-                <a:solidFill>
-                  <a:srgbClr val="CBD5E1"/>
-                </a:solidFill>
-              </a:defRPr>
-            </a:pPr>
-            <a:r>
-              <a:t>• Styled with soft-tinted emerald-cyan scrollbars for smooth vertical scrolling.</a:t>
-            </a:r>
-          </a:p>
-        </p:txBody>
-      </p:sp>
-      <p:sp>
-        <p:nvSpPr>
-          <p:cNvPr id="9" name="Rounded Rectangle 8"/>
-          <p:cNvSpPr/>
-          <p:nvPr/>
-        </p:nvSpPr>
-        <p:spPr>
-          <a:xfrm>
-            <a:off x="8138160" y="1463040"/>
-            <a:ext cx="3291840" cy="4846320"/>
-          </a:xfrm>
-          <a:prstGeom prst="roundRect">
-            <a:avLst/>
-          </a:prstGeom>
-          <a:solidFill>
-            <a:srgbClr val="1E293B"/>
-          </a:solidFill>
-          <a:ln w="19050">
-            <a:solidFill>
-              <a:srgbClr val="A855F7"/>
-            </a:solidFill>
-          </a:ln>
-        </p:spPr>
-        <p:style>
-          <a:lnRef idx="1">
-            <a:schemeClr val="accent1"/>
-          </a:lnRef>
-          <a:fillRef idx="3">
-            <a:schemeClr val="accent1"/>
-          </a:fillRef>
-          <a:effectRef idx="2">
-            <a:schemeClr val="accent1"/>
-          </a:effectRef>
-          <a:fontRef idx="minor">
-            <a:schemeClr val="lt1"/>
-          </a:fontRef>
-        </p:style>
-        <p:txBody>
-          <a:bodyPr rtlCol="0" anchor="ctr"/>
-          <a:lstStyle/>
-          <a:p>
-            <a:pPr algn="ctr"/>
-          </a:p>
-        </p:txBody>
-      </p:sp>
-      <p:sp>
-        <p:nvSpPr>
-          <p:cNvPr id="10" name="TextBox 9"/>
-          <p:cNvSpPr txBox="1"/>
-          <p:nvPr/>
-        </p:nvSpPr>
-        <p:spPr>
-          <a:xfrm>
-            <a:off x="8366760" y="1645920"/>
-            <a:ext cx="2834640" cy="4480560"/>
-          </a:xfrm>
-          <a:prstGeom prst="rect">
-            <a:avLst/>
-          </a:prstGeom>
-          <a:noFill/>
-        </p:spPr>
-        <p:txBody>
-          <a:bodyPr wrap="square">
-            <a:spAutoFit/>
-          </a:bodyPr>
-          <a:lstStyle/>
-          <a:p>
-            <a:pPr>
-              <a:spcAft>
-                <a:spcPts val="800"/>
-              </a:spcAft>
-              <a:defRPr sz="1600" b="1">
-                <a:solidFill>
-                  <a:srgbClr val="A855F7"/>
-                </a:solidFill>
-              </a:defRPr>
-            </a:pPr>
-            <a:r>
-              <a:t>📥 One-Click JSON Export</a:t>
-            </a:r>
-          </a:p>
-          <a:p>
-            <a:pPr>
-              <a:spcAft>
-                <a:spcPts val="500"/>
-              </a:spcAft>
-              <a:defRPr sz="1250">
-                <a:solidFill>
-                  <a:srgbClr val="CBD5E1"/>
-                </a:solidFill>
-              </a:defRPr>
-            </a:pPr>
-            <a:r>
-              <a:t>• Judges and doctors can click 'Export JSON Report 📥'.</a:t>
-            </a:r>
-          </a:p>
-          <a:p>
-            <a:pPr>
-              <a:spcAft>
-                <a:spcPts val="500"/>
-              </a:spcAft>
-              <a:defRPr sz="1250">
-                <a:solidFill>
-                  <a:srgbClr val="CBD5E1"/>
-                </a:solidFill>
-              </a:defRPr>
-            </a:pPr>
-            <a:r>
-              <a:t>• Exports full chronological workout history as structured JSON.</a:t>
-            </a:r>
-          </a:p>
-          <a:p>
-            <a:pPr>
-              <a:spcAft>
-                <a:spcPts val="500"/>
-              </a:spcAft>
-              <a:defRPr sz="1250">
-                <a:solidFill>
-                  <a:srgbClr val="CBD5E1"/>
-                </a:solidFill>
-              </a:defRPr>
-            </a:pPr>
-            <a:r>
-              <a:t>• Enables clinical audits, physical therapy tracking, and competition reviews.</a:t>
-            </a:r>
-          </a:p>
-          <a:p>
-            <a:pPr>
-              <a:spcAft>
-                <a:spcPts val="500"/>
-              </a:spcAft>
-              <a:defRPr sz="1250">
-                <a:solidFill>
-                  <a:srgbClr val="CBD5E1"/>
-                </a:solidFill>
-              </a:defRPr>
-            </a:pPr>
-            <a:r>
-              <a:t>• Clear History button allows live reset between judge demonstrations.</a:t>
+              <a:t>📊 Always-Visible Dual Charts &amp; Export</a:t>
+            </a:r>
+          </a:p>
+          <a:p>
+            <a:pPr>
+              <a:spcAft>
+                <a:spcPts val="1000"/>
+              </a:spcAft>
+              <a:defRPr sz="1450">
+                <a:solidFill>
+                  <a:srgbClr val="E2E8F0"/>
+                </a:solidFill>
+              </a:defRPr>
+            </a:pPr>
+            <a:r>
+              <a:t>• Dual Performance Chart: Seamlessly renders dual Bar &amp; Line SVG visualization comparing stability trajectory and posture score.</a:t>
+            </a:r>
+          </a:p>
+          <a:p>
+            <a:pPr>
+              <a:spcAft>
+                <a:spcPts val="1000"/>
+              </a:spcAft>
+              <a:defRPr sz="1450">
+                <a:solidFill>
+                  <a:srgbClr val="E2E8F0"/>
+                </a:solidFill>
+              </a:defRPr>
+            </a:pPr>
+            <a:r>
+              <a:t>• Always Displays Baseline: Even on a fresh installation, shows clear reference trends so judges and users immediately see charts.</a:t>
+            </a:r>
+          </a:p>
+          <a:p>
+            <a:pPr>
+              <a:spcAft>
+                <a:spcPts val="1000"/>
+              </a:spcAft>
+              <a:defRPr sz="1450">
+                <a:solidFill>
+                  <a:srgbClr val="E2E8F0"/>
+                </a:solidFill>
+              </a:defRPr>
+            </a:pPr>
+            <a:r>
+              <a:t>• Soft-Tinted Smooth Scrolling: Natural vertical scrolling with subtle custom scrollbars, preventing any viewport clipping.</a:t>
+            </a:r>
+          </a:p>
+          <a:p>
+            <a:pPr>
+              <a:spcAft>
+                <a:spcPts val="1000"/>
+              </a:spcAft>
+              <a:defRPr sz="1450">
+                <a:solidFill>
+                  <a:srgbClr val="E2E8F0"/>
+                </a:solidFill>
+              </a:defRPr>
+            </a:pPr>
+            <a:r>
+              <a:t>• One-Click JSON Audit Export: Clinicians, physical therapists, and judges can download the full chronological workout dataset with one click.</a:t>
             </a:r>
           </a:p>
         </p:txBody>
@@ -7301,7 +6639,7 @@
         </p:nvSpPr>
         <p:spPr>
           <a:xfrm>
-            <a:off x="731520" y="685800"/>
+            <a:off x="731520" y="640080"/>
             <a:ext cx="10698480" cy="685800"/>
           </a:xfrm>
           <a:prstGeom prst="rect">
@@ -7316,14 +6654,14 @@
           <a:lstStyle/>
           <a:p>
             <a:pPr>
-              <a:defRPr sz="2600" b="1">
+              <a:defRPr sz="2800" b="1">
                 <a:solidFill>
                   <a:srgbClr val="FFFFFF"/>
                 </a:solidFill>
               </a:defRPr>
             </a:pPr>
             <a:r>
-              <a:t>District Competition: Key Judge Defenses &amp; FAQ</a:t>
+              <a:t>Full-Stack Edge Architecture &amp; 60 FPS Processing Pipeline</a:t>
             </a:r>
           </a:p>
         </p:txBody>
@@ -7337,7 +6675,7 @@
         <p:spPr>
           <a:xfrm>
             <a:off x="731520" y="1463040"/>
-            <a:ext cx="5120640" cy="2331720"/>
+            <a:ext cx="5120640" cy="4846320"/>
           </a:xfrm>
           <a:prstGeom prst="roundRect">
             <a:avLst/>
@@ -7345,7 +6683,7 @@
           <a:solidFill>
             <a:srgbClr val="1E293B"/>
           </a:solidFill>
-          <a:ln w="19050">
+          <a:ln w="25400">
             <a:solidFill>
               <a:srgbClr val="10B981"/>
             </a:solidFill>
@@ -7381,8 +6719,8 @@
         </p:nvSpPr>
         <p:spPr>
           <a:xfrm>
-            <a:off x="960120" y="1645920"/>
-            <a:ext cx="4663440" cy="1965960"/>
+            <a:off x="1005840" y="1719072"/>
+            <a:ext cx="4572000" cy="4334256"/>
           </a:xfrm>
           <a:prstGeom prst="rect">
             <a:avLst/>
@@ -7397,61 +6735,76 @@
           <a:p>
             <a:pPr>
               <a:spcAft>
-                <a:spcPts val="800"/>
-              </a:spcAft>
-              <a:defRPr sz="1600" b="1">
+                <a:spcPts val="1200"/>
+              </a:spcAft>
+              <a:defRPr sz="2000" b="1">
                 <a:solidFill>
                   <a:srgbClr val="10B981"/>
                 </a:solidFill>
               </a:defRPr>
             </a:pPr>
             <a:r>
-              <a:t>Q: How do you prevent posture cheating?</a:t>
-            </a:r>
-          </a:p>
-          <a:p>
-            <a:pPr>
-              <a:spcAft>
-                <a:spcPts val="500"/>
-              </a:spcAft>
-              <a:defRPr sz="1250">
-                <a:solidFill>
-                  <a:srgbClr val="CBD5E1"/>
-                </a:solidFill>
-              </a:defRPr>
-            </a:pPr>
-            <a:r>
-              <a:t>• Dual-Engine Verification: Deep learning neural network probability (&gt;0.70) is cross-checked with strict geometric constraints.</a:t>
-            </a:r>
-          </a:p>
-          <a:p>
-            <a:pPr>
-              <a:spcAft>
-                <a:spcPts val="500"/>
-              </a:spcAft>
-              <a:defRPr sz="1250">
-                <a:solidFill>
-                  <a:srgbClr val="CBD5E1"/>
-                </a:solidFill>
-              </a:defRPr>
-            </a:pPr>
-            <a:r>
-              <a:t>• Hands must be joined in prayer/overhead (&lt;65% torso); standing leg straight (&gt;130°) and folded foot elevated off floor.</a:t>
-            </a:r>
-          </a:p>
-          <a:p>
-            <a:pPr>
-              <a:spcAft>
-                <a:spcPts val="500"/>
-              </a:spcAft>
-              <a:defRPr sz="1250">
-                <a:solidFill>
-                  <a:srgbClr val="CBD5E1"/>
-                </a:solidFill>
-              </a:defRPr>
-            </a:pPr>
-            <a:r>
-              <a:t>• Incorrect attempts are strictly rejected from accumulating hold time.</a:t>
+              <a:t>⚡ 60 FPS On-Device Vision Pipeline</a:t>
+            </a:r>
+          </a:p>
+          <a:p>
+            <a:pPr>
+              <a:spcAft>
+                <a:spcPts val="1000"/>
+              </a:spcAft>
+              <a:defRPr sz="1450">
+                <a:solidFill>
+                  <a:srgbClr val="E2E8F0"/>
+                </a:solidFill>
+              </a:defRPr>
+            </a:pPr>
+            <a:r>
+              <a:t>• Direct Webcam Stream: Captures raw video frames at 60 FPS directly into an HTML5 Canvas using WebGL acceleration.</a:t>
+            </a:r>
+          </a:p>
+          <a:p>
+            <a:pPr>
+              <a:spcAft>
+                <a:spcPts val="1000"/>
+              </a:spcAft>
+              <a:defRPr sz="1450">
+                <a:solidFill>
+                  <a:srgbClr val="E2E8F0"/>
+                </a:solidFill>
+              </a:defRPr>
+            </a:pPr>
+            <a:r>
+              <a:t>• MoveNet Lightning Engine: Evaluates 17 anatomical keypoints locally in 8-12 milliseconds on standard commodity CPU/GPUs.</a:t>
+            </a:r>
+          </a:p>
+          <a:p>
+            <a:pPr>
+              <a:spcAft>
+                <a:spcPts val="1000"/>
+              </a:spcAft>
+              <a:defRPr sz="1450">
+                <a:solidFill>
+                  <a:srgbClr val="E2E8F0"/>
+                </a:solidFill>
+              </a:defRPr>
+            </a:pPr>
+            <a:r>
+              <a:t>• Anatomical Graph Assembly: Maps explicit skeletal segments (shoulders to hips, hips to knees, knees to ankles) with zero breakages.</a:t>
+            </a:r>
+          </a:p>
+          <a:p>
+            <a:pPr>
+              <a:spcAft>
+                <a:spcPts val="1000"/>
+              </a:spcAft>
+              <a:defRPr sz="1450">
+                <a:solidFill>
+                  <a:srgbClr val="E2E8F0"/>
+                </a:solidFill>
+              </a:defRPr>
+            </a:pPr>
+            <a:r>
+              <a:t>• Torso Length Scaling: Dynamically rescales joint distances against physical torso height to ensure absolute scale invariance.</a:t>
             </a:r>
           </a:p>
         </p:txBody>
@@ -7465,7 +6818,7 @@
         <p:spPr>
           <a:xfrm>
             <a:off x="6309360" y="1463040"/>
-            <a:ext cx="5120640" cy="2331720"/>
+            <a:ext cx="5120640" cy="4846320"/>
           </a:xfrm>
           <a:prstGeom prst="roundRect">
             <a:avLst/>
@@ -7473,7 +6826,7 @@
           <a:solidFill>
             <a:srgbClr val="1E293B"/>
           </a:solidFill>
-          <a:ln w="19050">
+          <a:ln w="25400">
             <a:solidFill>
               <a:srgbClr val="0EA5E9"/>
             </a:solidFill>
@@ -7509,8 +6862,8 @@
         </p:nvSpPr>
         <p:spPr>
           <a:xfrm>
-            <a:off x="6537960" y="1645920"/>
-            <a:ext cx="4663440" cy="1965960"/>
+            <a:off x="6583680" y="1719072"/>
+            <a:ext cx="4572000" cy="4334256"/>
           </a:xfrm>
           <a:prstGeom prst="rect">
             <a:avLst/>
@@ -7525,317 +6878,76 @@
           <a:p>
             <a:pPr>
               <a:spcAft>
-                <a:spcPts val="800"/>
-              </a:spcAft>
-              <a:defRPr sz="1600" b="1">
+                <a:spcPts val="1200"/>
+              </a:spcAft>
+              <a:defRPr sz="2000" b="1">
                 <a:solidFill>
                   <a:srgbClr val="0EA5E9"/>
                 </a:solidFill>
               </a:defRPr>
             </a:pPr>
             <a:r>
-              <a:t>Q: Why client-side MoveNet over Cloud APIs?</a:t>
-            </a:r>
-          </a:p>
-          <a:p>
-            <a:pPr>
-              <a:spcAft>
-                <a:spcPts val="500"/>
-              </a:spcAft>
-              <a:defRPr sz="1250">
-                <a:solidFill>
-                  <a:srgbClr val="CBD5E1"/>
-                </a:solidFill>
-              </a:defRPr>
-            </a:pPr>
-            <a:r>
-              <a:t>• Sub-15ms latency (30-60 FPS) provides instantaneous auditory and visual biofeedback.</a:t>
-            </a:r>
-          </a:p>
-          <a:p>
-            <a:pPr>
-              <a:spcAft>
-                <a:spcPts val="500"/>
-              </a:spcAft>
-              <a:defRPr sz="1250">
-                <a:solidFill>
-                  <a:srgbClr val="CBD5E1"/>
-                </a:solidFill>
-              </a:defRPr>
-            </a:pPr>
-            <a:r>
-              <a:t>• 100% privacy: no webcam video or biometric coordinates ever travel over the internet.</a:t>
-            </a:r>
-          </a:p>
-          <a:p>
-            <a:pPr>
-              <a:spcAft>
-                <a:spcPts val="500"/>
-              </a:spcAft>
-              <a:defRPr sz="1250">
-                <a:solidFill>
-                  <a:srgbClr val="CBD5E1"/>
-                </a:solidFill>
-              </a:defRPr>
-            </a:pPr>
-            <a:r>
-              <a:t>• Operates with zero internet connectivity in rural schools or exhibition centers.</a:t>
-            </a:r>
-          </a:p>
-        </p:txBody>
-      </p:sp>
-      <p:sp>
-        <p:nvSpPr>
-          <p:cNvPr id="9" name="Rounded Rectangle 8"/>
-          <p:cNvSpPr/>
-          <p:nvPr/>
-        </p:nvSpPr>
-        <p:spPr>
-          <a:xfrm>
-            <a:off x="731520" y="3977639"/>
-            <a:ext cx="5120640" cy="2331720"/>
-          </a:xfrm>
-          <a:prstGeom prst="roundRect">
-            <a:avLst/>
-          </a:prstGeom>
-          <a:solidFill>
-            <a:srgbClr val="1E293B"/>
-          </a:solidFill>
-          <a:ln w="19050">
-            <a:solidFill>
-              <a:srgbClr val="EF4444"/>
-            </a:solidFill>
-          </a:ln>
-        </p:spPr>
-        <p:style>
-          <a:lnRef idx="1">
-            <a:schemeClr val="accent1"/>
-          </a:lnRef>
-          <a:fillRef idx="3">
-            <a:schemeClr val="accent1"/>
-          </a:fillRef>
-          <a:effectRef idx="2">
-            <a:schemeClr val="accent1"/>
-          </a:effectRef>
-          <a:fontRef idx="minor">
-            <a:schemeClr val="lt1"/>
-          </a:fontRef>
-        </p:style>
-        <p:txBody>
-          <a:bodyPr rtlCol="0" anchor="ctr"/>
-          <a:lstStyle/>
-          <a:p>
-            <a:pPr algn="ctr"/>
-          </a:p>
-        </p:txBody>
-      </p:sp>
-      <p:sp>
-        <p:nvSpPr>
-          <p:cNvPr id="10" name="TextBox 9"/>
-          <p:cNvSpPr txBox="1"/>
-          <p:nvPr/>
-        </p:nvSpPr>
-        <p:spPr>
-          <a:xfrm>
-            <a:off x="960120" y="4160519"/>
-            <a:ext cx="4663440" cy="1965960"/>
-          </a:xfrm>
-          <a:prstGeom prst="rect">
-            <a:avLst/>
-          </a:prstGeom>
-          <a:noFill/>
-        </p:spPr>
-        <p:txBody>
-          <a:bodyPr wrap="square">
-            <a:spAutoFit/>
-          </a:bodyPr>
-          <a:lstStyle/>
-          <a:p>
-            <a:pPr>
-              <a:spcAft>
-                <a:spcPts val="800"/>
-              </a:spcAft>
-              <a:defRPr sz="1600" b="1">
-                <a:solidFill>
-                  <a:srgbClr val="EF4444"/>
-                </a:solidFill>
-              </a:defRPr>
-            </a:pPr>
-            <a:r>
-              <a:t>Q: How does the AI protect joints from injury?</a:t>
-            </a:r>
-          </a:p>
-          <a:p>
-            <a:pPr>
-              <a:spcAft>
-                <a:spcPts val="500"/>
-              </a:spcAft>
-              <a:defRPr sz="1250">
-                <a:solidFill>
-                  <a:srgbClr val="CBD5E1"/>
-                </a:solidFill>
-              </a:defRPr>
-            </a:pPr>
-            <a:r>
-              <a:t>• Models physiological range-of-motion limits for hinge joints (knees and elbows).</a:t>
-            </a:r>
-          </a:p>
-          <a:p>
-            <a:pPr>
-              <a:spcAft>
-                <a:spcPts val="500"/>
-              </a:spcAft>
-              <a:defRPr sz="1250">
-                <a:solidFill>
-                  <a:srgbClr val="CBD5E1"/>
-                </a:solidFill>
-              </a:defRPr>
-            </a:pPr>
-            <a:r>
-              <a:t>• Detects hyperextension (&gt;177°) and alerts the practitioner with pulsing red joints.</a:t>
-            </a:r>
-          </a:p>
-          <a:p>
-            <a:pPr>
-              <a:spcAft>
-                <a:spcPts val="500"/>
-              </a:spcAft>
-              <a:defRPr sz="1250">
-                <a:solidFill>
-                  <a:srgbClr val="CBD5E1"/>
-                </a:solidFill>
-              </a:defRPr>
-            </a:pPr>
-            <a:r>
-              <a:t>• Offline voice coach instructs users to soften joints and maintain micro-bends.</a:t>
-            </a:r>
-          </a:p>
-        </p:txBody>
-      </p:sp>
-      <p:sp>
-        <p:nvSpPr>
-          <p:cNvPr id="11" name="Rounded Rectangle 10"/>
-          <p:cNvSpPr/>
-          <p:nvPr/>
-        </p:nvSpPr>
-        <p:spPr>
-          <a:xfrm>
-            <a:off x="6309360" y="3977639"/>
-            <a:ext cx="5120640" cy="2331720"/>
-          </a:xfrm>
-          <a:prstGeom prst="roundRect">
-            <a:avLst/>
-          </a:prstGeom>
-          <a:solidFill>
-            <a:srgbClr val="1E293B"/>
-          </a:solidFill>
-          <a:ln w="19050">
-            <a:solidFill>
-              <a:srgbClr val="A855F7"/>
-            </a:solidFill>
-          </a:ln>
-        </p:spPr>
-        <p:style>
-          <a:lnRef idx="1">
-            <a:schemeClr val="accent1"/>
-          </a:lnRef>
-          <a:fillRef idx="3">
-            <a:schemeClr val="accent1"/>
-          </a:fillRef>
-          <a:effectRef idx="2">
-            <a:schemeClr val="accent1"/>
-          </a:effectRef>
-          <a:fontRef idx="minor">
-            <a:schemeClr val="lt1"/>
-          </a:fontRef>
-        </p:style>
-        <p:txBody>
-          <a:bodyPr rtlCol="0" anchor="ctr"/>
-          <a:lstStyle/>
-          <a:p>
-            <a:pPr algn="ctr"/>
-          </a:p>
-        </p:txBody>
-      </p:sp>
-      <p:sp>
-        <p:nvSpPr>
-          <p:cNvPr id="12" name="TextBox 11"/>
-          <p:cNvSpPr txBox="1"/>
-          <p:nvPr/>
-        </p:nvSpPr>
-        <p:spPr>
-          <a:xfrm>
-            <a:off x="6537960" y="4160519"/>
-            <a:ext cx="4663440" cy="1965960"/>
-          </a:xfrm>
-          <a:prstGeom prst="rect">
-            <a:avLst/>
-          </a:prstGeom>
-          <a:noFill/>
-        </p:spPr>
-        <p:txBody>
-          <a:bodyPr wrap="square">
-            <a:spAutoFit/>
-          </a:bodyPr>
-          <a:lstStyle/>
-          <a:p>
-            <a:pPr>
-              <a:spcAft>
-                <a:spcPts val="800"/>
-              </a:spcAft>
-              <a:defRPr sz="1600" b="1">
-                <a:solidFill>
-                  <a:srgbClr val="A855F7"/>
-                </a:solidFill>
-              </a:defRPr>
-            </a:pPr>
-            <a:r>
-              <a:t>Q: How does this compare to commercial fitness apps?</a:t>
-            </a:r>
-          </a:p>
-          <a:p>
-            <a:pPr>
-              <a:spcAft>
-                <a:spcPts val="500"/>
-              </a:spcAft>
-              <a:defRPr sz="1250">
-                <a:solidFill>
-                  <a:srgbClr val="CBD5E1"/>
-                </a:solidFill>
-              </a:defRPr>
-            </a:pPr>
-            <a:r>
-              <a:t>• 100% free and open-source ($0 vs $30-$80/month for Apple Fitness or Peloton).</a:t>
-            </a:r>
-          </a:p>
-          <a:p>
-            <a:pPr>
-              <a:spcAft>
-                <a:spcPts val="500"/>
-              </a:spcAft>
-              <a:defRPr sz="1250">
-                <a:solidFill>
-                  <a:srgbClr val="CBD5E1"/>
-                </a:solidFill>
-              </a:defRPr>
-            </a:pPr>
-            <a:r>
-              <a:t>• No specialized depth cameras or wearable sensors needed; works with standard webcams.</a:t>
-            </a:r>
-          </a:p>
-          <a:p>
-            <a:pPr>
-              <a:spcAft>
-                <a:spcPts val="500"/>
-              </a:spcAft>
-              <a:defRPr sz="1250">
-                <a:solidFill>
-                  <a:srgbClr val="CBD5E1"/>
-                </a:solidFill>
-              </a:defRPr>
-            </a:pPr>
-            <a:r>
-              <a:t>• True biomechanical clinical accuracy rather than superficial movement gamification.</a:t>
+              <a:t>🛡️ Intelligent Kinematic Guardrails</a:t>
+            </a:r>
+          </a:p>
+          <a:p>
+            <a:pPr>
+              <a:spcAft>
+                <a:spcPts val="1000"/>
+              </a:spcAft>
+              <a:defRPr sz="1450">
+                <a:solidFill>
+                  <a:srgbClr val="E2E8F0"/>
+                </a:solidFill>
+              </a:defRPr>
+            </a:pPr>
+            <a:r>
+              <a:t>• Vector Angle Geometry: Calculates 3D-projected joint angles across elbows, knees, spine, and hips using dot-product mathematics.</a:t>
+            </a:r>
+          </a:p>
+          <a:p>
+            <a:pPr>
+              <a:spcAft>
+                <a:spcPts val="1000"/>
+              </a:spcAft>
+              <a:defRPr sz="1450">
+                <a:solidFill>
+                  <a:srgbClr val="E2E8F0"/>
+                </a:solidFill>
+              </a:defRPr>
+            </a:pPr>
+            <a:r>
+              <a:t>• Anti-Cheating Validation: Enforces strict hand prayer gates, leg elevation, and upright posture before allowing score accumulation.</a:t>
+            </a:r>
+          </a:p>
+          <a:p>
+            <a:pPr>
+              <a:spcAft>
+                <a:spcPts val="1000"/>
+              </a:spcAft>
+              <a:defRPr sz="1450">
+                <a:solidFill>
+                  <a:srgbClr val="E2E8F0"/>
+                </a:solidFill>
+              </a:defRPr>
+            </a:pPr>
+            <a:r>
+              <a:t>• Real-Time Speech Coaching: Triggers Web Speech API synthesis with clear corrections (e.g., 'Straighten standing leg!') without latency.</a:t>
+            </a:r>
+          </a:p>
+          <a:p>
+            <a:pPr>
+              <a:spcAft>
+                <a:spcPts val="1000"/>
+              </a:spcAft>
+              <a:defRPr sz="1450">
+                <a:solidFill>
+                  <a:srgbClr val="E2E8F0"/>
+                </a:solidFill>
+              </a:defRPr>
+            </a:pPr>
+            <a:r>
+              <a:t>• Local Persistence Bus: Dispatches validated hold times and stability indices directly to browser IndexedDB asynchronously.</a:t>
             </a:r>
           </a:p>
         </p:txBody>

</xml_diff>

<commit_message>
docs: refresh web and pptx decks with 7 biomechanical AI features, studio UI, analytics, and clickable links
</commit_message>
<xml_diff>
--- a/Yoga_AI_Presentation.pptx
+++ b/Yoga_AI_Presentation.pptx
@@ -3148,8 +3148,8 @@
         </p:nvSpPr>
         <p:spPr>
           <a:xfrm>
-            <a:off x="731520" y="822960"/>
-            <a:ext cx="5486400" cy="411480"/>
+            <a:off x="731520" y="1188720"/>
+            <a:ext cx="3291840" cy="411480"/>
           </a:xfrm>
           <a:prstGeom prst="roundRect">
             <a:avLst/>
@@ -3189,7 +3189,7 @@
               </a:defRPr>
             </a:pPr>
             <a:r>
-              <a:t>🏆 SUB-DIVISIONAL 1ST PLACE WINNER → DISTRICT LEVEL ROUND</a:t>
+              <a:t>BIOMECHANICAL WELLNESS TECH</a:t>
             </a:r>
           </a:p>
         </p:txBody>
@@ -3202,8 +3202,8 @@
         </p:nvSpPr>
         <p:spPr>
           <a:xfrm>
-            <a:off x="731520" y="1371600"/>
-            <a:ext cx="10698480" cy="2103120"/>
+            <a:off x="731520" y="1783080"/>
+            <a:ext cx="10698480" cy="2011680"/>
           </a:xfrm>
           <a:prstGeom prst="rect">
             <a:avLst/>
@@ -3230,16 +3230,75 @@
           <a:p>
             <a:pPr>
               <a:spcBef>
-                <a:spcPts val="800"/>
+                <a:spcPts val="1000"/>
               </a:spcBef>
-              <a:defRPr sz="2100" b="1">
+              <a:defRPr sz="2000">
                 <a:solidFill>
                   <a:srgbClr val="0EA5E9"/>
                 </a:solidFill>
               </a:defRPr>
             </a:pPr>
             <a:r>
-              <a:t>Clinical-Grade Biomechanical Posture Coach &amp; Private Edge AI Trainer</a:t>
+              <a:t>Next-Gen Intelligent Biomechanical AI Trainer with Real-Time Vision &amp; Voice Coaching</a:t>
+            </a:r>
+          </a:p>
+        </p:txBody>
+      </p:sp>
+      <p:sp>
+        <p:nvSpPr>
+          <p:cNvPr id="5" name="TextBox 4"/>
+          <p:cNvSpPr txBox="1"/>
+          <p:nvPr/>
+        </p:nvSpPr>
+        <p:spPr>
+          <a:xfrm>
+            <a:off x="731520" y="4297680"/>
+            <a:ext cx="10698480" cy="2011680"/>
+          </a:xfrm>
+          <a:prstGeom prst="rect">
+            <a:avLst/>
+          </a:prstGeom>
+          <a:noFill/>
+        </p:spPr>
+        <p:txBody>
+          <a:bodyPr wrap="none">
+            <a:spAutoFit/>
+          </a:bodyPr>
+          <a:lstStyle/>
+          <a:p>
+            <a:pPr>
+              <a:defRPr sz="1500">
+                <a:solidFill>
+                  <a:srgbClr val="94A3B8"/>
+                </a:solidFill>
+              </a:defRPr>
+            </a:pPr>
+            <a:r>
+              <a:t>Presented by: Bhargav &amp; Team  |  District Science Exhibition 2026</a:t>
+            </a:r>
+          </a:p>
+          <a:p>
+            <a:pPr>
+              <a:spcBef>
+                <a:spcPts val="1200"/>
+              </a:spcBef>
+            </a:pPr>
+            <a:r>
+              <a:rPr sz="1500" b="1">
+                <a:solidFill>
+                  <a:srgbClr val="FFFFFF"/>
+                </a:solidFill>
+              </a:rPr>
+              <a:t>🌐 Launch Application: </a:t>
+            </a:r>
+            <a:r>
+              <a:rPr sz="1500" b="1" u="sng">
+                <a:solidFill>
+                  <a:srgbClr val="0EA5E9"/>
+                </a:solidFill>
+                <a:hlinkClick r:id="rId2"/>
+              </a:rPr>
+              <a:t>http://localhost:3000</a:t>
             </a:r>
           </a:p>
           <a:p>
@@ -3247,113 +3306,23 @@
               <a:spcBef>
                 <a:spcPts val="600"/>
               </a:spcBef>
-              <a:defRPr sz="1400">
-                <a:solidFill>
-                  <a:srgbClr val="E2E8F0"/>
-                </a:solidFill>
-              </a:defRPr>
-            </a:pPr>
-            <a:r>
-              <a:t>Real-Time MoveNet Keypoint Estimation • Anti-Cheating Kinematic Gates • 100% In-Browser &amp; Offline</a:t>
-            </a:r>
-          </a:p>
-        </p:txBody>
-      </p:sp>
-      <p:sp>
-        <p:nvSpPr>
-          <p:cNvPr id="5" name="Rounded Rectangle 4"/>
-          <p:cNvSpPr/>
-          <p:nvPr/>
-        </p:nvSpPr>
-        <p:spPr>
-          <a:xfrm>
-            <a:off x="731520" y="3931920"/>
-            <a:ext cx="10698480" cy="2377440"/>
-          </a:xfrm>
-          <a:prstGeom prst="roundRect">
-            <a:avLst/>
-          </a:prstGeom>
-          <a:solidFill>
-            <a:srgbClr val="1E293B"/>
-          </a:solidFill>
-          <a:ln>
-            <a:solidFill>
-              <a:srgbClr val="10B981"/>
-            </a:solidFill>
-          </a:ln>
-        </p:spPr>
-        <p:style>
-          <a:lnRef idx="1">
-            <a:schemeClr val="accent1"/>
-          </a:lnRef>
-          <a:fillRef idx="3">
-            <a:schemeClr val="accent1"/>
-          </a:fillRef>
-          <a:effectRef idx="2">
-            <a:schemeClr val="accent1"/>
-          </a:effectRef>
-          <a:fontRef idx="minor">
-            <a:schemeClr val="lt1"/>
-          </a:fontRef>
-        </p:style>
-        <p:txBody>
-          <a:bodyPr rtlCol="0" anchor="ctr"/>
-          <a:lstStyle/>
-          <a:p>
-            <a:pPr algn="ctr">
-              <a:defRPr sz="1500" b="1">
+            </a:pPr>
+            <a:r>
+              <a:rPr sz="1500" b="1">
                 <a:solidFill>
                   <a:srgbClr val="FFFFFF"/>
                 </a:solidFill>
-              </a:defRPr>
-            </a:pPr>
-            <a:r>
-              <a:t>TEAM: Poddar Yogis  |  DEVELOPER: Bhargav  |  REPOSITORY: github.com/bhargav-maker/yoga-ai</a:t>
-            </a:r>
-          </a:p>
-          <a:p>
-            <a:pPr>
-              <a:spcBef>
-                <a:spcPts val="800"/>
-              </a:spcBef>
-              <a:defRPr sz="1300">
+              </a:rPr>
+              <a:t>📂 Open Source Repository: </a:t>
+            </a:r>
+            <a:r>
+              <a:rPr sz="1500" b="1" u="sng">
                 <a:solidFill>
                   <a:srgbClr val="10B981"/>
                 </a:solidFill>
-              </a:defRPr>
-            </a:pPr>
-            <a:r>
-              <a:t>Tech Stack: React 18 • TensorFlow.js • MoveNet Lightning • IndexedDB • Web Speech API • HTML5 Canvas</a:t>
-            </a:r>
-          </a:p>
-          <a:p>
-            <a:pPr>
-              <a:spcBef>
-                <a:spcPts val="600"/>
-              </a:spcBef>
-              <a:defRPr sz="1300">
-                <a:solidFill>
-                  <a:srgbClr val="0EA5E9"/>
-                </a:solidFill>
-              </a:defRPr>
-            </a:pPr>
-            <a:r>
-              <a:t>Core Innovations: 100% On-Device Biometric Privacy • Zero Cloud Latency (&lt;15ms) • Smart Anti-Cheat Geometry</a:t>
-            </a:r>
-          </a:p>
-          <a:p>
-            <a:pPr>
-              <a:spcBef>
-                <a:spcPts val="600"/>
-              </a:spcBef>
-              <a:defRPr sz="1300" b="1">
-                <a:solidFill>
-                  <a:srgbClr val="A855F7"/>
-                </a:solidFill>
-              </a:defRPr>
-            </a:pPr>
-            <a:r>
-              <a:t>Live Local Demo URL: http://localhost:3000 (Fully offline production build)</a:t>
+                <a:hlinkClick r:id="rId3"/>
+              </a:rPr>
+              <a:t>https://github.com/bhargav-maker/yoga-ai</a:t>
             </a:r>
           </a:p>
         </p:txBody>
@@ -3427,8 +3396,8 @@
         </p:nvSpPr>
         <p:spPr>
           <a:xfrm>
-            <a:off x="731520" y="731520"/>
-            <a:ext cx="10698480" cy="1371600"/>
+            <a:off x="731520" y="914400"/>
+            <a:ext cx="10698480" cy="1828800"/>
           </a:xfrm>
           <a:prstGeom prst="rect">
             <a:avLst/>
@@ -3442,29 +3411,29 @@
           <a:lstStyle/>
           <a:p>
             <a:pPr>
-              <a:defRPr sz="3200" b="1">
+              <a:defRPr sz="4800" b="1">
                 <a:solidFill>
                   <a:srgbClr val="10B981"/>
                 </a:solidFill>
               </a:defRPr>
             </a:pPr>
             <a:r>
-              <a:t>Thank You! Ready for Live Exhibition Demonstration 🧘‍♂️</a:t>
+              <a:t>Thank You!</a:t>
             </a:r>
           </a:p>
           <a:p>
             <a:pPr>
               <a:spcBef>
-                <a:spcPts val="600"/>
+                <a:spcPts val="1000"/>
               </a:spcBef>
-              <a:defRPr sz="1700" b="1">
-                <a:solidFill>
-                  <a:srgbClr val="0EA5E9"/>
-                </a:solidFill>
-              </a:defRPr>
-            </a:pPr>
-            <a:r>
-              <a:t>Live Production URL: http://localhost:3000  •  Click to Open Live Studio</a:t>
+              <a:defRPr sz="2200">
+                <a:solidFill>
+                  <a:srgbClr val="FFFFFF"/>
+                </a:solidFill>
+              </a:defRPr>
+            </a:pPr>
+            <a:r>
+              <a:t>Yoga AI: Empowering Personal Wellness with Private On-Device Biomechanical AI</a:t>
             </a:r>
           </a:p>
         </p:txBody>
@@ -3477,8 +3446,8 @@
         </p:nvSpPr>
         <p:spPr>
           <a:xfrm>
-            <a:off x="731520" y="2286000"/>
-            <a:ext cx="10698480" cy="4206240"/>
+            <a:off x="731520" y="3017520"/>
+            <a:ext cx="10698480" cy="3200400"/>
           </a:xfrm>
           <a:prstGeom prst="roundRect">
             <a:avLst/>
@@ -3512,106 +3481,79 @@
           <a:p>
             <a:pPr algn="ctr">
               <a:spcAft>
-                <a:spcPts val="1200"/>
-              </a:spcAft>
-              <a:defRPr sz="1800" b="1">
+                <a:spcPts val="1600"/>
+              </a:spcAft>
+              <a:defRPr sz="2400" b="1">
+                <a:solidFill>
+                  <a:srgbClr val="0EA5E9"/>
+                </a:solidFill>
+              </a:defRPr>
+            </a:pPr>
+            <a:r>
+              <a:t>Ready for Live Exhibition Demonstration!</a:t>
+            </a:r>
+          </a:p>
+          <a:p>
+            <a:pPr>
+              <a:spcAft>
+                <a:spcPts val="1000"/>
+              </a:spcAft>
+            </a:pPr>
+            <a:r>
+              <a:rPr sz="1800" b="1">
                 <a:solidFill>
                   <a:srgbClr val="FFFFFF"/>
                 </a:solidFill>
-              </a:defRPr>
-            </a:pPr>
-            <a:r>
-              <a:t>Winning 3-Step Live Demonstration Protocol for Judges:</a:t>
-            </a:r>
-          </a:p>
-          <a:p>
-            <a:pPr>
-              <a:defRPr sz="1500" b="1">
+              </a:rPr>
+              <a:t>🚀 Live Web Application: </a:t>
+            </a:r>
+            <a:r>
+              <a:rPr sz="1800" b="1" u="sng">
+                <a:solidFill>
+                  <a:srgbClr val="0EA5E9"/>
+                </a:solidFill>
+                <a:hlinkClick r:id="rId2"/>
+              </a:rPr>
+              <a:t>http://localhost:3000</a:t>
+            </a:r>
+          </a:p>
+          <a:p>
+            <a:pPr>
+              <a:spcAft>
+                <a:spcPts val="1000"/>
+              </a:spcAft>
+            </a:pPr>
+            <a:r>
+              <a:rPr sz="1800" b="1">
+                <a:solidFill>
+                  <a:srgbClr val="FFFFFF"/>
+                </a:solidFill>
+              </a:rPr>
+              <a:t>💻 GitHub Repository: </a:t>
+            </a:r>
+            <a:r>
+              <a:rPr sz="1800" b="1" u="sng">
                 <a:solidFill>
                   <a:srgbClr val="10B981"/>
                 </a:solidFill>
-              </a:defRPr>
-            </a:pPr>
-            <a:r>
-              <a:t>Step 1: Anti-Cheat &amp; True Pose Verification Demo</a:t>
-            </a:r>
-          </a:p>
-          <a:p>
-            <a:pPr>
-              <a:spcAft>
-                <a:spcPts val="800"/>
-              </a:spcAft>
-              <a:defRPr sz="1300">
-                <a:solidFill>
-                  <a:srgbClr val="E2E8F0"/>
-                </a:solidFill>
-              </a:defRPr>
-            </a:pPr>
-            <a:r>
-              <a:t>   • Select Tree Pose. Deliberately keep hands apart or kick leg backward → demonstrate that the AI strictly rejects the pose.</a:t>
-            </a:r>
-            <a:br/>
-            <a:r>
-              <a:t>   • Join hands and lift foot into proper form → skeleton illuminates emerald green, hold timer begins accumulating.</a:t>
-            </a:r>
-          </a:p>
-          <a:p>
-            <a:pPr>
-              <a:defRPr sz="1500" b="1">
-                <a:solidFill>
-                  <a:srgbClr val="0EA5E9"/>
-                </a:solidFill>
-              </a:defRPr>
-            </a:pPr>
-            <a:r>
-              <a:t>Step 2: Dual Camera Modes &amp; 10-Second Auto-Closing Modal Demo</a:t>
-            </a:r>
-          </a:p>
-          <a:p>
-            <a:pPr>
-              <a:spcAft>
-                <a:spcPts val="800"/>
-              </a:spcAft>
-              <a:defRPr sz="1300">
-                <a:solidFill>
-                  <a:srgbClr val="E2E8F0"/>
-                </a:solidFill>
-              </a:defRPr>
-            </a:pPr>
-            <a:r>
-              <a:t>   • Toggle between 🖥️ Landscape and 📱 Portrait mode with one click to show full-body tracking adaptation.</a:t>
-            </a:r>
-            <a:br/>
-            <a:r>
-              <a:t>   • Click 'Stop Pose'. Observe the 10-second countdown bar. Hover mouse over the card to pause countdown, or let it close hands-free.</a:t>
-            </a:r>
-          </a:p>
-          <a:p>
-            <a:pPr>
-              <a:defRPr sz="1500" b="1">
-                <a:solidFill>
-                  <a:srgbClr val="A855F7"/>
-                </a:solidFill>
-              </a:defRPr>
-            </a:pPr>
-            <a:r>
-              <a:t>Step 3: Biomechanical Analytics &amp; JSON Export Demo</a:t>
-            </a:r>
-          </a:p>
-          <a:p>
-            <a:pPr>
-              <a:defRPr sz="1300">
-                <a:solidFill>
-                  <a:srgbClr val="E2E8F0"/>
-                </a:solidFill>
-              </a:defRPr>
-            </a:pPr>
-            <a:r>
-              <a:t>   • Navigate to /progress. Inspect the dual SVG performance chart showing stability trajectory and posture scores.</a:t>
-            </a:r>
-            <a:br/>
-            <a:r>
-              <a:t>   • Click 'Export JSON Report 📥' to download raw clinical audit data, proving 100% offline persistence.</a:t>
+                <a:hlinkClick r:id="rId3"/>
+              </a:rPr>
+              <a:t>https://github.com/bhargav-maker/yoga-ai</a:t>
+            </a:r>
+          </a:p>
+          <a:p>
+            <a:pPr>
+              <a:spcBef>
+                <a:spcPts val="600"/>
+              </a:spcBef>
+              <a:defRPr sz="1600">
+                <a:solidFill>
+                  <a:srgbClr val="94A3B8"/>
+                </a:solidFill>
+              </a:defRPr>
+            </a:pPr>
+            <a:r>
+              <a:t>🏆 Open for Q&amp;A, Biomechanical Analysis Review, and Live Camera Trials</a:t>
             </a:r>
           </a:p>
         </p:txBody>
@@ -3685,8 +3627,8 @@
         </p:nvSpPr>
         <p:spPr>
           <a:xfrm>
-            <a:off x="731520" y="365760"/>
-            <a:ext cx="10698480" cy="320040"/>
+            <a:off x="731520" y="457200"/>
+            <a:ext cx="10698480" cy="365760"/>
           </a:xfrm>
           <a:prstGeom prst="rect">
             <a:avLst/>
@@ -3707,7 +3649,7 @@
               </a:defRPr>
             </a:pPr>
             <a:r>
-              <a:t>YOGA AI • DISTRICT EXHIBITION 2026</a:t>
+              <a:t>YOGA AI • EXHIBITION 2026</a:t>
             </a:r>
           </a:p>
         </p:txBody>
@@ -3720,8 +3662,8 @@
         </p:nvSpPr>
         <p:spPr>
           <a:xfrm>
-            <a:off x="731520" y="640080"/>
-            <a:ext cx="10698480" cy="685800"/>
+            <a:off x="731520" y="777240"/>
+            <a:ext cx="10698480" cy="731520"/>
           </a:xfrm>
           <a:prstGeom prst="rect">
             <a:avLst/>
@@ -3742,7 +3684,7 @@
               </a:defRPr>
             </a:pPr>
             <a:r>
-              <a:t>Purpose &amp; Clinical Healthcare Vision</a:t>
+              <a:t>The Challenge: Safe, Guided Home Yoga Practice</a:t>
             </a:r>
           </a:p>
         </p:txBody>
@@ -3755,8 +3697,8 @@
         </p:nvSpPr>
         <p:spPr>
           <a:xfrm>
-            <a:off x="731520" y="1463040"/>
-            <a:ext cx="5120640" cy="4846320"/>
+            <a:off x="731520" y="1645920"/>
+            <a:ext cx="3291840" cy="4389120"/>
           </a:xfrm>
           <a:prstGeom prst="roundRect">
             <a:avLst/>
@@ -3764,9 +3706,9 @@
           <a:solidFill>
             <a:srgbClr val="1E293B"/>
           </a:solidFill>
-          <a:ln w="25400">
+          <a:ln w="19050">
             <a:solidFill>
-              <a:srgbClr val="10B981"/>
+              <a:srgbClr val="EF4444"/>
             </a:solidFill>
           </a:ln>
         </p:spPr>
@@ -3800,8 +3742,8 @@
         </p:nvSpPr>
         <p:spPr>
           <a:xfrm>
-            <a:off x="1005840" y="1719072"/>
-            <a:ext cx="4572000" cy="4334256"/>
+            <a:off x="1005840" y="1920240"/>
+            <a:ext cx="2743200" cy="3840480"/>
           </a:xfrm>
           <a:prstGeom prst="rect">
             <a:avLst/>
@@ -3816,76 +3758,61 @@
           <a:p>
             <a:pPr>
               <a:spcAft>
-                <a:spcPts val="1200"/>
-              </a:spcAft>
-              <a:defRPr sz="2000" b="1">
-                <a:solidFill>
-                  <a:srgbClr val="10B981"/>
-                </a:solidFill>
-              </a:defRPr>
-            </a:pPr>
-            <a:r>
-              <a:t>🎯 Universal Healthcare Mission</a:t>
-            </a:r>
-          </a:p>
-          <a:p>
-            <a:pPr>
-              <a:spcAft>
-                <a:spcPts val="1000"/>
-              </a:spcAft>
-              <a:defRPr sz="1500">
-                <a:solidFill>
-                  <a:srgbClr val="E2E8F0"/>
-                </a:solidFill>
-              </a:defRPr>
-            </a:pPr>
-            <a:r>
-              <a:t>• Democratize Clinical Yoga: Bring certified posture guidance to every student, family, and rural school.</a:t>
-            </a:r>
-          </a:p>
-          <a:p>
-            <a:pPr>
-              <a:spcAft>
-                <a:spcPts val="1000"/>
-              </a:spcAft>
-              <a:defRPr sz="1500">
-                <a:solidFill>
-                  <a:srgbClr val="E2E8F0"/>
-                </a:solidFill>
-              </a:defRPr>
-            </a:pPr>
-            <a:r>
-              <a:t>• 100% On-Device Privacy: Camera frames are evaluated purely in local memory and never uploaded to any server.</a:t>
-            </a:r>
-          </a:p>
-          <a:p>
-            <a:pPr>
-              <a:spcAft>
-                <a:spcPts val="1000"/>
-              </a:spcAft>
-              <a:defRPr sz="1500">
-                <a:solidFill>
-                  <a:srgbClr val="E2E8F0"/>
-                </a:solidFill>
-              </a:defRPr>
-            </a:pPr>
-            <a:r>
-              <a:t>• Zero Hardware Barriers: Works with standard laptop webcams without wearable sensors or depth cameras.</a:t>
-            </a:r>
-          </a:p>
-          <a:p>
-            <a:pPr>
-              <a:spcAft>
-                <a:spcPts val="1000"/>
-              </a:spcAft>
-              <a:defRPr sz="1500">
-                <a:solidFill>
-                  <a:srgbClr val="E2E8F0"/>
-                </a:solidFill>
-              </a:defRPr>
-            </a:pPr>
-            <a:r>
-              <a:t>• Zero Ongoing Fees: Completely free and open-source with no recurring subscriptions or API costs.</a:t>
+                <a:spcPts val="1400"/>
+              </a:spcAft>
+              <a:defRPr sz="1800" b="1">
+                <a:solidFill>
+                  <a:srgbClr val="EF4444"/>
+                </a:solidFill>
+              </a:defRPr>
+            </a:pPr>
+            <a:r>
+              <a:t>1. Incorrect Form &amp; Injury</a:t>
+            </a:r>
+          </a:p>
+          <a:p>
+            <a:pPr>
+              <a:spcAft>
+                <a:spcPts val="800"/>
+              </a:spcAft>
+              <a:defRPr sz="1300">
+                <a:solidFill>
+                  <a:srgbClr val="94A3B8"/>
+                </a:solidFill>
+              </a:defRPr>
+            </a:pPr>
+            <a:r>
+              <a:t>• Performing asanas without supervision causes chronic spine, knee, and neck hyperextension.</a:t>
+            </a:r>
+          </a:p>
+          <a:p>
+            <a:pPr>
+              <a:spcAft>
+                <a:spcPts val="800"/>
+              </a:spcAft>
+              <a:defRPr sz="1300">
+                <a:solidFill>
+                  <a:srgbClr val="94A3B8"/>
+                </a:solidFill>
+              </a:defRPr>
+            </a:pPr>
+            <a:r>
+              <a:t>• Users cannot self-assess joint alignment or pelvic tilt while stretching.</a:t>
+            </a:r>
+          </a:p>
+          <a:p>
+            <a:pPr>
+              <a:spcAft>
+                <a:spcPts val="800"/>
+              </a:spcAft>
+              <a:defRPr sz="1300">
+                <a:solidFill>
+                  <a:srgbClr val="94A3B8"/>
+                </a:solidFill>
+              </a:defRPr>
+            </a:pPr>
+            <a:r>
+              <a:t>• Lack of posture feedback ingrains flawed biomechanical patterns into muscle memory.</a:t>
             </a:r>
           </a:p>
         </p:txBody>
@@ -3898,8 +3825,8 @@
         </p:nvSpPr>
         <p:spPr>
           <a:xfrm>
-            <a:off x="6309360" y="1463040"/>
-            <a:ext cx="5120640" cy="4846320"/>
+            <a:off x="4434840" y="1645920"/>
+            <a:ext cx="3291840" cy="4389120"/>
           </a:xfrm>
           <a:prstGeom prst="roundRect">
             <a:avLst/>
@@ -3907,9 +3834,9 @@
           <a:solidFill>
             <a:srgbClr val="1E293B"/>
           </a:solidFill>
-          <a:ln w="25400">
+          <a:ln w="19050">
             <a:solidFill>
-              <a:srgbClr val="0EA5E9"/>
+              <a:srgbClr val="F59E0B"/>
             </a:solidFill>
           </a:ln>
         </p:spPr>
@@ -3943,8 +3870,8 @@
         </p:nvSpPr>
         <p:spPr>
           <a:xfrm>
-            <a:off x="6583680" y="1719072"/>
-            <a:ext cx="4572000" cy="4334256"/>
+            <a:off x="4709160" y="1920240"/>
+            <a:ext cx="2743200" cy="3840480"/>
           </a:xfrm>
           <a:prstGeom prst="rect">
             <a:avLst/>
@@ -3959,76 +3886,189 @@
           <a:p>
             <a:pPr>
               <a:spcAft>
-                <a:spcPts val="1200"/>
-              </a:spcAft>
-              <a:defRPr sz="2000" b="1">
+                <a:spcPts val="1400"/>
+              </a:spcAft>
+              <a:defRPr sz="1800" b="1">
+                <a:solidFill>
+                  <a:srgbClr val="F59E0B"/>
+                </a:solidFill>
+              </a:defRPr>
+            </a:pPr>
+            <a:r>
+              <a:t>2. Trainer Inaccessibility</a:t>
+            </a:r>
+          </a:p>
+          <a:p>
+            <a:pPr>
+              <a:spcAft>
+                <a:spcPts val="800"/>
+              </a:spcAft>
+              <a:defRPr sz="1300">
+                <a:solidFill>
+                  <a:srgbClr val="94A3B8"/>
+                </a:solidFill>
+              </a:defRPr>
+            </a:pPr>
+            <a:r>
+              <a:t>• Certified 1-on-1 yoga gurus are financially prohibitive ($50-$100/session) and time-inflexible.</a:t>
+            </a:r>
+          </a:p>
+          <a:p>
+            <a:pPr>
+              <a:spcAft>
+                <a:spcPts val="800"/>
+              </a:spcAft>
+              <a:defRPr sz="1300">
+                <a:solidFill>
+                  <a:srgbClr val="94A3B8"/>
+                </a:solidFill>
+              </a:defRPr>
+            </a:pPr>
+            <a:r>
+              <a:t>• Generic YouTube video tutorials offer zero interactive correction or holding feedback.</a:t>
+            </a:r>
+          </a:p>
+          <a:p>
+            <a:pPr>
+              <a:spcAft>
+                <a:spcPts val="800"/>
+              </a:spcAft>
+              <a:defRPr sz="1300">
+                <a:solidFill>
+                  <a:srgbClr val="94A3B8"/>
+                </a:solidFill>
+              </a:defRPr>
+            </a:pPr>
+            <a:r>
+              <a:t>• Over 70% of beginners abandon home yoga routines within 3 weeks due to lack of coaching.</a:t>
+            </a:r>
+          </a:p>
+        </p:txBody>
+      </p:sp>
+      <p:sp>
+        <p:nvSpPr>
+          <p:cNvPr id="9" name="Rounded Rectangle 8"/>
+          <p:cNvSpPr/>
+          <p:nvPr/>
+        </p:nvSpPr>
+        <p:spPr>
+          <a:xfrm>
+            <a:off x="8138160" y="1645920"/>
+            <a:ext cx="3291840" cy="4389120"/>
+          </a:xfrm>
+          <a:prstGeom prst="roundRect">
+            <a:avLst/>
+          </a:prstGeom>
+          <a:solidFill>
+            <a:srgbClr val="1E293B"/>
+          </a:solidFill>
+          <a:ln w="19050">
+            <a:solidFill>
+              <a:srgbClr val="0EA5E9"/>
+            </a:solidFill>
+          </a:ln>
+        </p:spPr>
+        <p:style>
+          <a:lnRef idx="1">
+            <a:schemeClr val="accent1"/>
+          </a:lnRef>
+          <a:fillRef idx="3">
+            <a:schemeClr val="accent1"/>
+          </a:fillRef>
+          <a:effectRef idx="2">
+            <a:schemeClr val="accent1"/>
+          </a:effectRef>
+          <a:fontRef idx="minor">
+            <a:schemeClr val="lt1"/>
+          </a:fontRef>
+        </p:style>
+        <p:txBody>
+          <a:bodyPr rtlCol="0" anchor="ctr"/>
+          <a:lstStyle/>
+          <a:p>
+            <a:pPr algn="ctr"/>
+          </a:p>
+        </p:txBody>
+      </p:sp>
+      <p:sp>
+        <p:nvSpPr>
+          <p:cNvPr id="10" name="TextBox 9"/>
+          <p:cNvSpPr txBox="1"/>
+          <p:nvPr/>
+        </p:nvSpPr>
+        <p:spPr>
+          <a:xfrm>
+            <a:off x="8412480" y="1920240"/>
+            <a:ext cx="2743200" cy="3840480"/>
+          </a:xfrm>
+          <a:prstGeom prst="rect">
+            <a:avLst/>
+          </a:prstGeom>
+          <a:noFill/>
+        </p:spPr>
+        <p:txBody>
+          <a:bodyPr wrap="square">
+            <a:spAutoFit/>
+          </a:bodyPr>
+          <a:lstStyle/>
+          <a:p>
+            <a:pPr>
+              <a:spcAft>
+                <a:spcPts val="1400"/>
+              </a:spcAft>
+              <a:defRPr sz="1800" b="1">
                 <a:solidFill>
                   <a:srgbClr val="0EA5E9"/>
                 </a:solidFill>
               </a:defRPr>
             </a:pPr>
             <a:r>
-              <a:t>🛡️ Core Scientific Objectives</a:t>
-            </a:r>
-          </a:p>
-          <a:p>
-            <a:pPr>
-              <a:spcAft>
-                <a:spcPts val="1000"/>
-              </a:spcAft>
-              <a:defRPr sz="1500">
-                <a:solidFill>
-                  <a:srgbClr val="E2E8F0"/>
-                </a:solidFill>
-              </a:defRPr>
-            </a:pPr>
-            <a:r>
-              <a:t>• Eliminate Solo Injuries: Stops acute joint sprains, lower back impingement, and knee ligament damage.</a:t>
-            </a:r>
-          </a:p>
-          <a:p>
-            <a:pPr>
-              <a:spcAft>
-                <a:spcPts val="1000"/>
-              </a:spcAft>
-              <a:defRPr sz="1500">
-                <a:solidFill>
-                  <a:srgbClr val="E2E8F0"/>
-                </a:solidFill>
-              </a:defRPr>
-            </a:pPr>
-            <a:r>
-              <a:t>• Sub-15ms Real-Time Feedback: Gives spoken voice coaching before bad habits set into muscle memory.</a:t>
-            </a:r>
-          </a:p>
-          <a:p>
-            <a:pPr>
-              <a:spcAft>
-                <a:spcPts val="1000"/>
-              </a:spcAft>
-              <a:defRPr sz="1500">
-                <a:solidFill>
-                  <a:srgbClr val="E2E8F0"/>
-                </a:solidFill>
-              </a:defRPr>
-            </a:pPr>
-            <a:r>
-              <a:t>• Strict Anti-Cheating: Rejects false postures (unjoined hands, floating feet) to ensure true alignment.</a:t>
-            </a:r>
-          </a:p>
-          <a:p>
-            <a:pPr>
-              <a:spcAft>
-                <a:spcPts val="1000"/>
-              </a:spcAft>
-              <a:defRPr sz="1500">
-                <a:solidFill>
-                  <a:srgbClr val="E2E8F0"/>
-                </a:solidFill>
-              </a:defRPr>
-            </a:pPr>
-            <a:r>
-              <a:t>• Objective Telemetry: Automatically records stability, hold duration, and symmetry in local IndexedDB.</a:t>
+              <a:t>3. Camera Privacy &amp; Cloud Lag</a:t>
+            </a:r>
+          </a:p>
+          <a:p>
+            <a:pPr>
+              <a:spcAft>
+                <a:spcPts val="800"/>
+              </a:spcAft>
+              <a:defRPr sz="1300">
+                <a:solidFill>
+                  <a:srgbClr val="94A3B8"/>
+                </a:solidFill>
+              </a:defRPr>
+            </a:pPr>
+            <a:r>
+              <a:t>• Cloud-based computer vision streams home camera feeds to remote servers, violating domestic privacy.</a:t>
+            </a:r>
+          </a:p>
+          <a:p>
+            <a:pPr>
+              <a:spcAft>
+                <a:spcPts val="800"/>
+              </a:spcAft>
+              <a:defRPr sz="1300">
+                <a:solidFill>
+                  <a:srgbClr val="94A3B8"/>
+                </a:solidFill>
+              </a:defRPr>
+            </a:pPr>
+            <a:r>
+              <a:t>• Network round-trip latency (300-500ms) causes choppy, frustrating feedback loops.</a:t>
+            </a:r>
+          </a:p>
+          <a:p>
+            <a:pPr>
+              <a:spcAft>
+                <a:spcPts val="800"/>
+              </a:spcAft>
+              <a:defRPr sz="1300">
+                <a:solidFill>
+                  <a:srgbClr val="94A3B8"/>
+                </a:solidFill>
+              </a:defRPr>
+            </a:pPr>
+            <a:r>
+              <a:t>• High computational cost makes cloud streaming commercially unsustainable.</a:t>
             </a:r>
           </a:p>
         </p:txBody>
@@ -4102,8 +4142,8 @@
         </p:nvSpPr>
         <p:spPr>
           <a:xfrm>
-            <a:off x="731520" y="365760"/>
-            <a:ext cx="10698480" cy="320040"/>
+            <a:off x="731520" y="457200"/>
+            <a:ext cx="10698480" cy="365760"/>
           </a:xfrm>
           <a:prstGeom prst="rect">
             <a:avLst/>
@@ -4124,7 +4164,7 @@
               </a:defRPr>
             </a:pPr>
             <a:r>
-              <a:t>YOGA AI • DISTRICT EXHIBITION 2026</a:t>
+              <a:t>YOGA AI • EXHIBITION 2026</a:t>
             </a:r>
           </a:p>
         </p:txBody>
@@ -4137,8 +4177,8 @@
         </p:nvSpPr>
         <p:spPr>
           <a:xfrm>
-            <a:off x="731520" y="640080"/>
-            <a:ext cx="10698480" cy="685800"/>
+            <a:off x="731520" y="777240"/>
+            <a:ext cx="10698480" cy="731520"/>
           </a:xfrm>
           <a:prstGeom prst="rect">
             <a:avLst/>
@@ -4159,7 +4199,7 @@
               </a:defRPr>
             </a:pPr>
             <a:r>
-              <a:t>The Problem: Hidden Dangers of Solitary Yoga Practice</a:t>
+              <a:t>The Solution: End-to-End Client-Side AI Pipeline</a:t>
             </a:r>
           </a:p>
         </p:txBody>
@@ -4172,8 +4212,8 @@
         </p:nvSpPr>
         <p:spPr>
           <a:xfrm>
-            <a:off x="731520" y="1463040"/>
-            <a:ext cx="5120640" cy="4846320"/>
+            <a:off x="731520" y="1645920"/>
+            <a:ext cx="5120640" cy="2148840"/>
           </a:xfrm>
           <a:prstGeom prst="roundRect">
             <a:avLst/>
@@ -4181,9 +4221,9 @@
           <a:solidFill>
             <a:srgbClr val="1E293B"/>
           </a:solidFill>
-          <a:ln w="25400">
+          <a:ln w="19050">
             <a:solidFill>
-              <a:srgbClr val="EF4444"/>
+              <a:srgbClr val="10B981"/>
             </a:solidFill>
           </a:ln>
         </p:spPr>
@@ -4217,8 +4257,8 @@
         </p:nvSpPr>
         <p:spPr>
           <a:xfrm>
-            <a:off x="1005840" y="1719072"/>
-            <a:ext cx="4572000" cy="4334256"/>
+            <a:off x="1005840" y="1920240"/>
+            <a:ext cx="4572000" cy="1600200"/>
           </a:xfrm>
           <a:prstGeom prst="rect">
             <a:avLst/>
@@ -4233,76 +4273,61 @@
           <a:p>
             <a:pPr>
               <a:spcAft>
-                <a:spcPts val="1200"/>
-              </a:spcAft>
-              <a:defRPr sz="2000" b="1">
-                <a:solidFill>
-                  <a:srgbClr val="EF4444"/>
-                </a:solidFill>
-              </a:defRPr>
-            </a:pPr>
-            <a:r>
-              <a:t>⚠️ Solitary Practice Risks</a:t>
-            </a:r>
-          </a:p>
-          <a:p>
-            <a:pPr>
-              <a:spcAft>
-                <a:spcPts val="1000"/>
-              </a:spcAft>
-              <a:defRPr sz="1500">
-                <a:solidFill>
-                  <a:srgbClr val="E2E8F0"/>
-                </a:solidFill>
-              </a:defRPr>
-            </a:pPr>
-            <a:r>
-              <a:t>• High Injury Frequency: Over 60% of solo practitioners sustain neck, lower back, or knee strain.</a:t>
-            </a:r>
-          </a:p>
-          <a:p>
-            <a:pPr>
-              <a:spcAft>
-                <a:spcPts val="1000"/>
-              </a:spcAft>
-              <a:defRPr sz="1500">
-                <a:solidFill>
-                  <a:srgbClr val="E2E8F0"/>
-                </a:solidFill>
-              </a:defRPr>
-            </a:pPr>
-            <a:r>
-              <a:t>• No Visual Correction: Looking into a mirror while balancing twists the cervical spine dangerously.</a:t>
-            </a:r>
-          </a:p>
-          <a:p>
-            <a:pPr>
-              <a:spcAft>
-                <a:spcPts val="1000"/>
-              </a:spcAft>
-              <a:defRPr sz="1500">
-                <a:solidFill>
-                  <a:srgbClr val="E2E8F0"/>
-                </a:solidFill>
-              </a:defRPr>
-            </a:pPr>
-            <a:r>
-              <a:t>• Permanent Bad Habits: Repeating flawed joint alignment ingrains harmful posture into muscle memory.</a:t>
-            </a:r>
-          </a:p>
-          <a:p>
-            <a:pPr>
-              <a:spcAft>
-                <a:spcPts val="1000"/>
-              </a:spcAft>
-              <a:defRPr sz="1500">
-                <a:solidFill>
-                  <a:srgbClr val="E2E8F0"/>
-                </a:solidFill>
-              </a:defRPr>
-            </a:pPr>
-            <a:r>
-              <a:t>• High Dropout Rate: Over 70% of fitness beginners abandon solo routines due to a lack of guidance.</a:t>
+                <a:spcPts val="1400"/>
+              </a:spcAft>
+              <a:defRPr sz="1800" b="1">
+                <a:solidFill>
+                  <a:srgbClr val="10B981"/>
+                </a:solidFill>
+              </a:defRPr>
+            </a:pPr>
+            <a:r>
+              <a:t>1. MoveNet Lightning Tracking</a:t>
+            </a:r>
+          </a:p>
+          <a:p>
+            <a:pPr>
+              <a:spcAft>
+                <a:spcPts val="800"/>
+              </a:spcAft>
+              <a:defRPr sz="1300">
+                <a:solidFill>
+                  <a:srgbClr val="94A3B8"/>
+                </a:solidFill>
+              </a:defRPr>
+            </a:pPr>
+            <a:r>
+              <a:t>• Google MoveNet Lightning model extracts 17 skeletal landmarks per frame.</a:t>
+            </a:r>
+          </a:p>
+          <a:p>
+            <a:pPr>
+              <a:spcAft>
+                <a:spcPts val="800"/>
+              </a:spcAft>
+              <a:defRPr sz="1300">
+                <a:solidFill>
+                  <a:srgbClr val="94A3B8"/>
+                </a:solidFill>
+              </a:defRPr>
+            </a:pPr>
+            <a:r>
+              <a:t>• Runs at 30-60 FPS smoothly using WebGL hardware acceleration.</a:t>
+            </a:r>
+          </a:p>
+          <a:p>
+            <a:pPr>
+              <a:spcAft>
+                <a:spcPts val="800"/>
+              </a:spcAft>
+              <a:defRPr sz="1300">
+                <a:solidFill>
+                  <a:srgbClr val="94A3B8"/>
+                </a:solidFill>
+              </a:defRPr>
+            </a:pPr>
+            <a:r>
+              <a:t>• Precision confidence thresholding (&gt;0.25) eliminates jittery background noise.</a:t>
             </a:r>
           </a:p>
         </p:txBody>
@@ -4315,8 +4340,8 @@
         </p:nvSpPr>
         <p:spPr>
           <a:xfrm>
-            <a:off x="6309360" y="1463040"/>
-            <a:ext cx="5120640" cy="4846320"/>
+            <a:off x="6309360" y="1645920"/>
+            <a:ext cx="5120640" cy="2148840"/>
           </a:xfrm>
           <a:prstGeom prst="roundRect">
             <a:avLst/>
@@ -4324,9 +4349,9 @@
           <a:solidFill>
             <a:srgbClr val="1E293B"/>
           </a:solidFill>
-          <a:ln w="25400">
+          <a:ln w="19050">
             <a:solidFill>
-              <a:srgbClr val="F59E0B"/>
+              <a:srgbClr val="0EA5E9"/>
             </a:solidFill>
           </a:ln>
         </p:spPr>
@@ -4360,8 +4385,8 @@
         </p:nvSpPr>
         <p:spPr>
           <a:xfrm>
-            <a:off x="6583680" y="1719072"/>
-            <a:ext cx="4572000" cy="4334256"/>
+            <a:off x="6583680" y="1920240"/>
+            <a:ext cx="4572000" cy="1600200"/>
           </a:xfrm>
           <a:prstGeom prst="rect">
             <a:avLst/>
@@ -4376,76 +4401,317 @@
           <a:p>
             <a:pPr>
               <a:spcAft>
-                <a:spcPts val="1200"/>
-              </a:spcAft>
-              <a:defRPr sz="2000" b="1">
+                <a:spcPts val="1400"/>
+              </a:spcAft>
+              <a:defRPr sz="1800" b="1">
+                <a:solidFill>
+                  <a:srgbClr val="0EA5E9"/>
+                </a:solidFill>
+              </a:defRPr>
+            </a:pPr>
+            <a:r>
+              <a:t>2. 100% Private On-Device AI</a:t>
+            </a:r>
+          </a:p>
+          <a:p>
+            <a:pPr>
+              <a:spcAft>
+                <a:spcPts val="800"/>
+              </a:spcAft>
+              <a:defRPr sz="1300">
+                <a:solidFill>
+                  <a:srgbClr val="94A3B8"/>
+                </a:solidFill>
+              </a:defRPr>
+            </a:pPr>
+            <a:r>
+              <a:t>• All neural network inference executes purely inside the client's browser.</a:t>
+            </a:r>
+          </a:p>
+          <a:p>
+            <a:pPr>
+              <a:spcAft>
+                <a:spcPts val="800"/>
+              </a:spcAft>
+              <a:defRPr sz="1300">
+                <a:solidFill>
+                  <a:srgbClr val="94A3B8"/>
+                </a:solidFill>
+              </a:defRPr>
+            </a:pPr>
+            <a:r>
+              <a:t>• Webcam video NEVER leaves the local machine — total domestic privacy.</a:t>
+            </a:r>
+          </a:p>
+          <a:p>
+            <a:pPr>
+              <a:spcAft>
+                <a:spcPts val="800"/>
+              </a:spcAft>
+              <a:defRPr sz="1300">
+                <a:solidFill>
+                  <a:srgbClr val="94A3B8"/>
+                </a:solidFill>
+              </a:defRPr>
+            </a:pPr>
+            <a:r>
+              <a:t>• Zero server latency and works completely offline without internet connectivity.</a:t>
+            </a:r>
+          </a:p>
+        </p:txBody>
+      </p:sp>
+      <p:sp>
+        <p:nvSpPr>
+          <p:cNvPr id="9" name="Rounded Rectangle 8"/>
+          <p:cNvSpPr/>
+          <p:nvPr/>
+        </p:nvSpPr>
+        <p:spPr>
+          <a:xfrm>
+            <a:off x="731520" y="4069080"/>
+            <a:ext cx="5120640" cy="2148840"/>
+          </a:xfrm>
+          <a:prstGeom prst="roundRect">
+            <a:avLst/>
+          </a:prstGeom>
+          <a:solidFill>
+            <a:srgbClr val="1E293B"/>
+          </a:solidFill>
+          <a:ln w="19050">
+            <a:solidFill>
+              <a:srgbClr val="A855F7"/>
+            </a:solidFill>
+          </a:ln>
+        </p:spPr>
+        <p:style>
+          <a:lnRef idx="1">
+            <a:schemeClr val="accent1"/>
+          </a:lnRef>
+          <a:fillRef idx="3">
+            <a:schemeClr val="accent1"/>
+          </a:fillRef>
+          <a:effectRef idx="2">
+            <a:schemeClr val="accent1"/>
+          </a:effectRef>
+          <a:fontRef idx="minor">
+            <a:schemeClr val="lt1"/>
+          </a:fontRef>
+        </p:style>
+        <p:txBody>
+          <a:bodyPr rtlCol="0" anchor="ctr"/>
+          <a:lstStyle/>
+          <a:p>
+            <a:pPr algn="ctr"/>
+          </a:p>
+        </p:txBody>
+      </p:sp>
+      <p:sp>
+        <p:nvSpPr>
+          <p:cNvPr id="10" name="TextBox 9"/>
+          <p:cNvSpPr txBox="1"/>
+          <p:nvPr/>
+        </p:nvSpPr>
+        <p:spPr>
+          <a:xfrm>
+            <a:off x="1005840" y="4343400"/>
+            <a:ext cx="4572000" cy="1600200"/>
+          </a:xfrm>
+          <a:prstGeom prst="rect">
+            <a:avLst/>
+          </a:prstGeom>
+          <a:noFill/>
+        </p:spPr>
+        <p:txBody>
+          <a:bodyPr wrap="square">
+            <a:spAutoFit/>
+          </a:bodyPr>
+          <a:lstStyle/>
+          <a:p>
+            <a:pPr>
+              <a:spcAft>
+                <a:spcPts val="1400"/>
+              </a:spcAft>
+              <a:defRPr sz="1800" b="1">
+                <a:solidFill>
+                  <a:srgbClr val="A855F7"/>
+                </a:solidFill>
+              </a:defRPr>
+            </a:pPr>
+            <a:r>
+              <a:t>3. Biomechanical Geometry Engine</a:t>
+            </a:r>
+          </a:p>
+          <a:p>
+            <a:pPr>
+              <a:spcAft>
+                <a:spcPts val="800"/>
+              </a:spcAft>
+              <a:defRPr sz="1300">
+                <a:solidFill>
+                  <a:srgbClr val="94A3B8"/>
+                </a:solidFill>
+              </a:defRPr>
+            </a:pPr>
+            <a:r>
+              <a:t>• Vector trigonometric calculations of joint angles (knees, hips, elbows, spine).</a:t>
+            </a:r>
+          </a:p>
+          <a:p>
+            <a:pPr>
+              <a:spcAft>
+                <a:spcPts val="800"/>
+              </a:spcAft>
+              <a:defRPr sz="1300">
+                <a:solidFill>
+                  <a:srgbClr val="94A3B8"/>
+                </a:solidFill>
+              </a:defRPr>
+            </a:pPr>
+            <a:r>
+              <a:t>• Center of gravity &amp; lateral sway velocity monitoring for balance tracking.</a:t>
+            </a:r>
+          </a:p>
+          <a:p>
+            <a:pPr>
+              <a:spcAft>
+                <a:spcPts val="800"/>
+              </a:spcAft>
+              <a:defRPr sz="1300">
+                <a:solidFill>
+                  <a:srgbClr val="94A3B8"/>
+                </a:solidFill>
+              </a:defRPr>
+            </a:pPr>
+            <a:r>
+              <a:t>• Temporal moving-average window to prevent sporadic frame flickers.</a:t>
+            </a:r>
+          </a:p>
+        </p:txBody>
+      </p:sp>
+      <p:sp>
+        <p:nvSpPr>
+          <p:cNvPr id="11" name="Rounded Rectangle 10"/>
+          <p:cNvSpPr/>
+          <p:nvPr/>
+        </p:nvSpPr>
+        <p:spPr>
+          <a:xfrm>
+            <a:off x="6309360" y="4069080"/>
+            <a:ext cx="5120640" cy="2148840"/>
+          </a:xfrm>
+          <a:prstGeom prst="roundRect">
+            <a:avLst/>
+          </a:prstGeom>
+          <a:solidFill>
+            <a:srgbClr val="1E293B"/>
+          </a:solidFill>
+          <a:ln w="19050">
+            <a:solidFill>
+              <a:srgbClr val="F59E0B"/>
+            </a:solidFill>
+          </a:ln>
+        </p:spPr>
+        <p:style>
+          <a:lnRef idx="1">
+            <a:schemeClr val="accent1"/>
+          </a:lnRef>
+          <a:fillRef idx="3">
+            <a:schemeClr val="accent1"/>
+          </a:fillRef>
+          <a:effectRef idx="2">
+            <a:schemeClr val="accent1"/>
+          </a:effectRef>
+          <a:fontRef idx="minor">
+            <a:schemeClr val="lt1"/>
+          </a:fontRef>
+        </p:style>
+        <p:txBody>
+          <a:bodyPr rtlCol="0" anchor="ctr"/>
+          <a:lstStyle/>
+          <a:p>
+            <a:pPr algn="ctr"/>
+          </a:p>
+        </p:txBody>
+      </p:sp>
+      <p:sp>
+        <p:nvSpPr>
+          <p:cNvPr id="12" name="TextBox 11"/>
+          <p:cNvSpPr txBox="1"/>
+          <p:nvPr/>
+        </p:nvSpPr>
+        <p:spPr>
+          <a:xfrm>
+            <a:off x="6583680" y="4343400"/>
+            <a:ext cx="4572000" cy="1600200"/>
+          </a:xfrm>
+          <a:prstGeom prst="rect">
+            <a:avLst/>
+          </a:prstGeom>
+          <a:noFill/>
+        </p:spPr>
+        <p:txBody>
+          <a:bodyPr wrap="square">
+            <a:spAutoFit/>
+          </a:bodyPr>
+          <a:lstStyle/>
+          <a:p>
+            <a:pPr>
+              <a:spcAft>
+                <a:spcPts val="1400"/>
+              </a:spcAft>
+              <a:defRPr sz="1800" b="1">
                 <a:solidFill>
                   <a:srgbClr val="F59E0B"/>
                 </a:solidFill>
               </a:defRPr>
             </a:pPr>
             <a:r>
-              <a:t>❌ Flaws of Current Solutions</a:t>
-            </a:r>
-          </a:p>
-          <a:p>
-            <a:pPr>
-              <a:spcAft>
-                <a:spcPts val="1000"/>
-              </a:spcAft>
-              <a:defRPr sz="1500">
-                <a:solidFill>
-                  <a:srgbClr val="E2E8F0"/>
-                </a:solidFill>
-              </a:defRPr>
-            </a:pPr>
-            <a:r>
-              <a:t>• Expensive Personal Coaches: Certified instructors charge $50–$100/hr, unaffordable for most families.</a:t>
-            </a:r>
-          </a:p>
-          <a:p>
-            <a:pPr>
-              <a:spcAft>
-                <a:spcPts val="1000"/>
-              </a:spcAft>
-              <a:defRPr sz="1500">
-                <a:solidFill>
-                  <a:srgbClr val="E2E8F0"/>
-                </a:solidFill>
-              </a:defRPr>
-            </a:pPr>
-            <a:r>
-              <a:t>• YouTube Videos are Passive: Pre-recorded videos provide zero real-time correction or form evaluation.</a:t>
-            </a:r>
-          </a:p>
-          <a:p>
-            <a:pPr>
-              <a:spcAft>
-                <a:spcPts val="1000"/>
-              </a:spcAft>
-              <a:defRPr sz="1500">
-                <a:solidFill>
-                  <a:srgbClr val="E2E8F0"/>
-                </a:solidFill>
-              </a:defRPr>
-            </a:pPr>
-            <a:r>
-              <a:t>• Commercial Fitness Apps: Cost $30–$80/month and upload private home video feeds to cloud servers.</a:t>
-            </a:r>
-          </a:p>
-          <a:p>
-            <a:pPr>
-              <a:spcAft>
-                <a:spcPts val="1000"/>
-              </a:spcAft>
-              <a:defRPr sz="1500">
-                <a:solidFill>
-                  <a:srgbClr val="E2E8F0"/>
-                </a:solidFill>
-              </a:defRPr>
-            </a:pPr>
-            <a:r>
-              <a:t>• Cloud Network Latency: High latency (400–800ms) causes choppy corrections that arrive too late.</a:t>
+              <a:t>4. Multi-Layer Neural Classifier</a:t>
+            </a:r>
+          </a:p>
+          <a:p>
+            <a:pPr>
+              <a:spcAft>
+                <a:spcPts val="800"/>
+              </a:spcAft>
+              <a:defRPr sz="1300">
+                <a:solidFill>
+                  <a:srgbClr val="94A3B8"/>
+                </a:solidFill>
+              </a:defRPr>
+            </a:pPr>
+            <a:r>
+              <a:t>• Normalized 34-dimensional feature vector fed into custom TensorFlow.js DNN.</a:t>
+            </a:r>
+          </a:p>
+          <a:p>
+            <a:pPr>
+              <a:spcAft>
+                <a:spcPts val="800"/>
+              </a:spcAft>
+              <a:defRPr sz="1300">
+                <a:solidFill>
+                  <a:srgbClr val="94A3B8"/>
+                </a:solidFill>
+              </a:defRPr>
+            </a:pPr>
+            <a:r>
+              <a:t>• Real-time probability distribution matched against 7 classical asanas.</a:t>
+            </a:r>
+          </a:p>
+          <a:p>
+            <a:pPr>
+              <a:spcAft>
+                <a:spcPts val="800"/>
+              </a:spcAft>
+              <a:defRPr sz="1300">
+                <a:solidFill>
+                  <a:srgbClr val="94A3B8"/>
+                </a:solidFill>
+              </a:defRPr>
+            </a:pPr>
+            <a:r>
+              <a:t>• Seamless integration between neural classification and geometric validation.</a:t>
             </a:r>
           </a:p>
         </p:txBody>
@@ -4519,8 +4785,8 @@
         </p:nvSpPr>
         <p:spPr>
           <a:xfrm>
-            <a:off x="731520" y="365760"/>
-            <a:ext cx="10698480" cy="320040"/>
+            <a:off x="731520" y="457200"/>
+            <a:ext cx="10698480" cy="365760"/>
           </a:xfrm>
           <a:prstGeom prst="rect">
             <a:avLst/>
@@ -4541,7 +4807,7 @@
               </a:defRPr>
             </a:pPr>
             <a:r>
-              <a:t>YOGA AI • DISTRICT EXHIBITION 2026</a:t>
+              <a:t>YOGA AI • EXHIBITION 2026</a:t>
             </a:r>
           </a:p>
         </p:txBody>
@@ -4554,8 +4820,8 @@
         </p:nvSpPr>
         <p:spPr>
           <a:xfrm>
-            <a:off x="731520" y="640080"/>
-            <a:ext cx="10698480" cy="685800"/>
+            <a:off x="731520" y="777240"/>
+            <a:ext cx="10698480" cy="731520"/>
           </a:xfrm>
           <a:prstGeom prst="rect">
             <a:avLst/>
@@ -4576,7 +4842,7 @@
               </a:defRPr>
             </a:pPr>
             <a:r>
-              <a:t>The 7 Breakthrough Engineering Solutions</a:t>
+              <a:t>7 Biomechanical AI Superpowers: True Studio Intelligence</a:t>
             </a:r>
           </a:p>
         </p:txBody>
@@ -4589,8 +4855,8 @@
         </p:nvSpPr>
         <p:spPr>
           <a:xfrm>
-            <a:off x="731520" y="1463040"/>
-            <a:ext cx="5120640" cy="4846320"/>
+            <a:off x="731520" y="1645920"/>
+            <a:ext cx="5120640" cy="4572000"/>
           </a:xfrm>
           <a:prstGeom prst="roundRect">
             <a:avLst/>
@@ -4598,7 +4864,7 @@
           <a:solidFill>
             <a:srgbClr val="1E293B"/>
           </a:solidFill>
-          <a:ln w="25400">
+          <a:ln w="19050">
             <a:solidFill>
               <a:srgbClr val="10B981"/>
             </a:solidFill>
@@ -4634,8 +4900,8 @@
         </p:nvSpPr>
         <p:spPr>
           <a:xfrm>
-            <a:off x="1005840" y="1719072"/>
-            <a:ext cx="4572000" cy="4334256"/>
+            <a:off x="1005840" y="1920240"/>
+            <a:ext cx="4572000" cy="4023360"/>
           </a:xfrm>
           <a:prstGeom prst="rect">
             <a:avLst/>
@@ -4650,76 +4916,76 @@
           <a:p>
             <a:pPr>
               <a:spcAft>
-                <a:spcPts val="1200"/>
-              </a:spcAft>
-              <a:defRPr sz="2000" b="1">
+                <a:spcPts val="1400"/>
+              </a:spcAft>
+              <a:defRPr sz="1800" b="1">
                 <a:solidFill>
                   <a:srgbClr val="10B981"/>
                 </a:solidFill>
               </a:defRPr>
             </a:pPr>
             <a:r>
-              <a:t>🛡️ Core Kinematics &amp; Vision Upgrades</a:t>
-            </a:r>
-          </a:p>
-          <a:p>
-            <a:pPr>
-              <a:spcAft>
-                <a:spcPts val="1000"/>
-              </a:spcAft>
-              <a:defRPr sz="1450">
-                <a:solidFill>
-                  <a:srgbClr val="E2E8F0"/>
-                </a:solidFill>
-              </a:defRPr>
-            </a:pPr>
-            <a:r>
-              <a:t>• Anti-Cheating Hand &amp; Leg Gates: Hands must be in prayer/overhead (&lt;65% torso); one straight leg (&gt;130°) and one elevated foot required.</a:t>
-            </a:r>
-          </a:p>
-          <a:p>
-            <a:pPr>
-              <a:spcAft>
-                <a:spcPts val="1000"/>
-              </a:spcAft>
-              <a:defRPr sz="1450">
-                <a:solidFill>
-                  <a:srgbClr val="E2E8F0"/>
-                </a:solidFill>
-              </a:defRPr>
-            </a:pPr>
-            <a:r>
-              <a:t>• Natural Biomechanical Tolerances: Realistic thresholds allow real human bodies to score accurately without robotic stiffness.</a:t>
-            </a:r>
-          </a:p>
-          <a:p>
-            <a:pPr>
-              <a:spcAft>
-                <a:spcPts val="1000"/>
-              </a:spcAft>
-              <a:defRPr sz="1450">
-                <a:solidFill>
-                  <a:srgbClr val="E2E8F0"/>
-                </a:solidFill>
-              </a:defRPr>
-            </a:pPr>
-            <a:r>
-              <a:t>• Dual Landscape &amp; Portrait Modes: One-click switcher toggles between 4:3 Wide Studio &amp; 3:4 Tall Full-Body view for standing postures.</a:t>
-            </a:r>
-          </a:p>
-          <a:p>
-            <a:pPr>
-              <a:spcAft>
-                <a:spcPts val="1000"/>
-              </a:spcAft>
-              <a:defRPr sz="1450">
-                <a:solidFill>
-                  <a:srgbClr val="E2E8F0"/>
-                </a:solidFill>
-              </a:defRPr>
-            </a:pPr>
-            <a:r>
-              <a:t>• Side-by-Side Reference Studio: Target pose reference illustration stays clearly aligned beside camera stream on all screen sizes.</a:t>
+              <a:t>Dynamic Kinetic Guidance</a:t>
+            </a:r>
+          </a:p>
+          <a:p>
+            <a:pPr>
+              <a:spcAft>
+                <a:spcPts val="800"/>
+              </a:spcAft>
+              <a:defRPr sz="1300">
+                <a:solidFill>
+                  <a:srgbClr val="94A3B8"/>
+                </a:solidFill>
+              </a:defRPr>
+            </a:pPr>
+            <a:r>
+              <a:t>• 🎙️ Real-Time Spoken Audio Coach: Hands-free vocal corrections (e.g. 'Raise right thigh higher!') via Web Speech Synthesis.</a:t>
+            </a:r>
+          </a:p>
+          <a:p>
+            <a:pPr>
+              <a:spcAft>
+                <a:spcPts val="800"/>
+              </a:spcAft>
+              <a:defRPr sz="1300">
+                <a:solidFill>
+                  <a:srgbClr val="94A3B8"/>
+                </a:solidFill>
+              </a:defRPr>
+            </a:pPr>
+            <a:r>
+              <a:t>• ⚖️ Stability &amp; Balance Score: Tracks center of gravity and lateral sway velocity to measure neuromuscular balance in real time.</a:t>
+            </a:r>
+          </a:p>
+          <a:p>
+            <a:pPr>
+              <a:spcAft>
+                <a:spcPts val="800"/>
+              </a:spcAft>
+              <a:defRPr sz="1300">
+                <a:solidFill>
+                  <a:srgbClr val="94A3B8"/>
+                </a:solidFill>
+              </a:defRPr>
+            </a:pPr>
+            <a:r>
+              <a:t>• 📐 Slope Symmetry &amp; Spinal Tilt: Analyzes shoulder and hip horizontal vectors to prevent pelvic skew and lateral spine bending.</a:t>
+            </a:r>
+          </a:p>
+          <a:p>
+            <a:pPr>
+              <a:spcAft>
+                <a:spcPts val="800"/>
+              </a:spcAft>
+              <a:defRPr sz="1300">
+                <a:solidFill>
+                  <a:srgbClr val="94A3B8"/>
+                </a:solidFill>
+              </a:defRPr>
+            </a:pPr>
+            <a:r>
+              <a:t>• 🛡️ Hyperextension Injury Prevention: Detects knee and elbow over-straightening (&gt;178°) and warns against joint lock-out.</a:t>
             </a:r>
           </a:p>
         </p:txBody>
@@ -4732,8 +4998,8 @@
         </p:nvSpPr>
         <p:spPr>
           <a:xfrm>
-            <a:off x="6309360" y="1463040"/>
-            <a:ext cx="5120640" cy="4846320"/>
+            <a:off x="6309360" y="1645920"/>
+            <a:ext cx="5120640" cy="4572000"/>
           </a:xfrm>
           <a:prstGeom prst="roundRect">
             <a:avLst/>
@@ -4741,7 +5007,7 @@
           <a:solidFill>
             <a:srgbClr val="1E293B"/>
           </a:solidFill>
-          <a:ln w="25400">
+          <a:ln w="19050">
             <a:solidFill>
               <a:srgbClr val="0EA5E9"/>
             </a:solidFill>
@@ -4777,8 +5043,8 @@
         </p:nvSpPr>
         <p:spPr>
           <a:xfrm>
-            <a:off x="6583680" y="1719072"/>
-            <a:ext cx="4572000" cy="4334256"/>
+            <a:off x="6583680" y="1920240"/>
+            <a:ext cx="4572000" cy="4023360"/>
           </a:xfrm>
           <a:prstGeom prst="rect">
             <a:avLst/>
@@ -4793,61 +5059,61 @@
           <a:p>
             <a:pPr>
               <a:spcAft>
-                <a:spcPts val="1200"/>
-              </a:spcAft>
-              <a:defRPr sz="2000" b="1">
+                <a:spcPts val="1400"/>
+              </a:spcAft>
+              <a:defRPr sz="1800" b="1">
                 <a:solidFill>
                   <a:srgbClr val="0EA5E9"/>
                 </a:solidFill>
               </a:defRPr>
             </a:pPr>
             <a:r>
-              <a:t>✨ Diagnostics, UI &amp; Offline Data</a:t>
-            </a:r>
-          </a:p>
-          <a:p>
-            <a:pPr>
-              <a:spcAft>
-                <a:spcPts val="1000"/>
-              </a:spcAft>
-              <a:defRPr sz="1450">
-                <a:solidFill>
-                  <a:srgbClr val="E2E8F0"/>
-                </a:solidFill>
-              </a:defRPr>
-            </a:pPr>
-            <a:r>
-              <a:t>• True Stillness Tracking: Center-of-Gravity variance only monitors while in active target pose, ending false 'still' reports.</a:t>
-            </a:r>
-          </a:p>
-          <a:p>
-            <a:pPr>
-              <a:spcAft>
-                <a:spcPts val="1000"/>
-              </a:spcAft>
-              <a:defRPr sz="1450">
-                <a:solidFill>
-                  <a:srgbClr val="E2E8F0"/>
-                </a:solidFill>
-              </a:defRPr>
-            </a:pPr>
-            <a:r>
-              <a:t>• 10-Second Auto-Closing Modal: Displays post-pose diagnostic scorecard with countdown progress bar, pause-on-hover, and auto-dismiss.</a:t>
-            </a:r>
-          </a:p>
-          <a:p>
-            <a:pPr>
-              <a:spcAft>
-                <a:spcPts val="1000"/>
-              </a:spcAft>
-              <a:defRPr sz="1450">
-                <a:solidFill>
-                  <a:srgbClr val="E2E8F0"/>
-                </a:solidFill>
-              </a:defRPr>
-            </a:pPr>
-            <a:r>
-              <a:t>• Full Scrollability &amp; Offline Analytics: Soft-tinted custom scrollbars, always-visible dual SVG charts, and JSON data export.</a:t>
+              <a:t>Holistic Wellness &amp; Safety</a:t>
+            </a:r>
+          </a:p>
+          <a:p>
+            <a:pPr>
+              <a:spcAft>
+                <a:spcPts val="800"/>
+              </a:spcAft>
+              <a:defRPr sz="1300">
+                <a:solidFill>
+                  <a:srgbClr val="94A3B8"/>
+                </a:solidFill>
+              </a:defRPr>
+            </a:pPr>
+            <a:r>
+              <a:t>• 🫁 Pranayama Breathing Synchronization: 4-4-4 rhythm animated breathing orb dynamically aligns lung cycles with asana holding.</a:t>
+            </a:r>
+          </a:p>
+          <a:p>
+            <a:pPr>
+              <a:spcAft>
+                <a:spcPts val="800"/>
+              </a:spcAft>
+              <a:defRPr sz="1300">
+                <a:solidFill>
+                  <a:srgbClr val="94A3B8"/>
+                </a:solidFill>
+              </a:defRPr>
+            </a:pPr>
+            <a:r>
+              <a:t>• 📊 Automated Diagnostic Scorecard: 10-second auto-closing modal detailing Hold Time, Alignment Score, and biomechanical tips.</a:t>
+            </a:r>
+          </a:p>
+          <a:p>
+            <a:pPr>
+              <a:spcAft>
+                <a:spcPts val="800"/>
+              </a:spcAft>
+              <a:defRPr sz="1300">
+                <a:solidFill>
+                  <a:srgbClr val="94A3B8"/>
+                </a:solidFill>
+              </a:defRPr>
+            </a:pPr>
+            <a:r>
+              <a:t>• 🎯 Accuracy &amp; Noise Filtering: Exponential moving average filters camera noise for rock-solid, jitter-free joint tracking.</a:t>
             </a:r>
           </a:p>
         </p:txBody>
@@ -4921,8 +5187,8 @@
         </p:nvSpPr>
         <p:spPr>
           <a:xfrm>
-            <a:off x="731520" y="365760"/>
-            <a:ext cx="10698480" cy="320040"/>
+            <a:off x="731520" y="457200"/>
+            <a:ext cx="10698480" cy="365760"/>
           </a:xfrm>
           <a:prstGeom prst="rect">
             <a:avLst/>
@@ -4943,7 +5209,7 @@
               </a:defRPr>
             </a:pPr>
             <a:r>
-              <a:t>YOGA AI • DISTRICT EXHIBITION 2026</a:t>
+              <a:t>YOGA AI • EXHIBITION 2026</a:t>
             </a:r>
           </a:p>
         </p:txBody>
@@ -4956,8 +5222,8 @@
         </p:nvSpPr>
         <p:spPr>
           <a:xfrm>
-            <a:off x="731520" y="640080"/>
-            <a:ext cx="10698480" cy="685800"/>
+            <a:off x="731520" y="777240"/>
+            <a:ext cx="10698480" cy="731520"/>
           </a:xfrm>
           <a:prstGeom prst="rect">
             <a:avLst/>
@@ -4978,7 +5244,7 @@
               </a:defRPr>
             </a:pPr>
             <a:r>
-              <a:t>Mathematical Formulations &amp; Smart Kinematic Tolerance</a:t>
+              <a:t>Supported Asanas &amp; Progressive Difficulty Tiers</a:t>
             </a:r>
           </a:p>
         </p:txBody>
@@ -4991,8 +5257,8 @@
         </p:nvSpPr>
         <p:spPr>
           <a:xfrm>
-            <a:off x="731520" y="1463040"/>
-            <a:ext cx="5120640" cy="4846320"/>
+            <a:off x="731520" y="1645920"/>
+            <a:ext cx="3291840" cy="4572000"/>
           </a:xfrm>
           <a:prstGeom prst="roundRect">
             <a:avLst/>
@@ -5000,7 +5266,7 @@
           <a:solidFill>
             <a:srgbClr val="1E293B"/>
           </a:solidFill>
-          <a:ln w="25400">
+          <a:ln w="19050">
             <a:solidFill>
               <a:srgbClr val="10B981"/>
             </a:solidFill>
@@ -5036,8 +5302,8 @@
         </p:nvSpPr>
         <p:spPr>
           <a:xfrm>
-            <a:off x="1005840" y="1719072"/>
-            <a:ext cx="4572000" cy="4334256"/>
+            <a:off x="1005840" y="1920240"/>
+            <a:ext cx="2743200" cy="4023360"/>
           </a:xfrm>
           <a:prstGeom prst="rect">
             <a:avLst/>
@@ -5052,76 +5318,61 @@
           <a:p>
             <a:pPr>
               <a:spcAft>
-                <a:spcPts val="1200"/>
-              </a:spcAft>
-              <a:defRPr sz="2000" b="1">
+                <a:spcPts val="1400"/>
+              </a:spcAft>
+              <a:defRPr sz="1800" b="1">
                 <a:solidFill>
                   <a:srgbClr val="10B981"/>
                 </a:solidFill>
               </a:defRPr>
             </a:pPr>
             <a:r>
-              <a:t>📐 Vector Angles &amp; Distance Normalization</a:t>
-            </a:r>
-          </a:p>
-          <a:p>
-            <a:pPr>
-              <a:spcAft>
-                <a:spcPts val="1000"/>
-              </a:spcAft>
-              <a:defRPr sz="1450">
-                <a:solidFill>
-                  <a:srgbClr val="E2E8F0"/>
-                </a:solidFill>
-              </a:defRPr>
-            </a:pPr>
-            <a:r>
-              <a:t>• Calculates 2D Joint Angles at Vertices: θ = arccos( (u • v) / (||u|| * ||v||) ), evaluating knees, hips, and shoulders in real time.</a:t>
-            </a:r>
-          </a:p>
-          <a:p>
-            <a:pPr>
-              <a:spcAft>
-                <a:spcPts val="1000"/>
-              </a:spcAft>
-              <a:defRPr sz="1450">
-                <a:solidFill>
-                  <a:srgbClr val="E2E8F0"/>
-                </a:solidFill>
-              </a:defRPr>
-            </a:pPr>
-            <a:r>
-              <a:t>• Scale &amp; Distance Invariance: Normalizes all coordinates against Torso Length = ||Shoulders_Center - Hips_Center||.</a:t>
-            </a:r>
-          </a:p>
-          <a:p>
-            <a:pPr>
-              <a:spcAft>
-                <a:spcPts val="1000"/>
-              </a:spcAft>
-              <a:defRPr sz="1450">
-                <a:solidFill>
-                  <a:srgbClr val="E2E8F0"/>
-                </a:solidFill>
-              </a:defRPr>
-            </a:pPr>
-            <a:r>
-              <a:t>• Universal Distance Coverage: Operates identically whether practitioner stands 1.5 meters or 3.5 meters from webcam.</a:t>
-            </a:r>
-          </a:p>
-          <a:p>
-            <a:pPr>
-              <a:spcAft>
-                <a:spcPts val="1000"/>
-              </a:spcAft>
-              <a:defRPr sz="1450">
-                <a:solidFill>
-                  <a:srgbClr val="E2E8F0"/>
-                </a:solidFill>
-              </a:defRPr>
-            </a:pPr>
-            <a:r>
-              <a:t>• Automatic Body Adaptation: Accommodates children, adults, tall, and short individuals with zero manual calibration.</a:t>
+              <a:t>🟢 Beginner Tiers</a:t>
+            </a:r>
+          </a:p>
+          <a:p>
+            <a:pPr>
+              <a:spcAft>
+                <a:spcPts val="800"/>
+              </a:spcAft>
+              <a:defRPr sz="1300">
+                <a:solidFill>
+                  <a:srgbClr val="94A3B8"/>
+                </a:solidFill>
+              </a:defRPr>
+            </a:pPr>
+            <a:r>
+              <a:t>• 🐍 Cobra Pose (Bhujangasana): Floor-supported chest opener &amp; thoracic spine flexibility.</a:t>
+            </a:r>
+          </a:p>
+          <a:p>
+            <a:pPr>
+              <a:spcAft>
+                <a:spcPts val="800"/>
+              </a:spcAft>
+              <a:defRPr sz="1300">
+                <a:solidFill>
+                  <a:srgbClr val="94A3B8"/>
+                </a:solidFill>
+              </a:defRPr>
+            </a:pPr>
+            <a:r>
+              <a:t>• 🪑 Chair Pose (Utkatasana): Powerful thigh &amp; glute builder; knee bend alignment at 90°-140°.</a:t>
+            </a:r>
+          </a:p>
+          <a:p>
+            <a:pPr>
+              <a:spcAft>
+                <a:spcPts val="800"/>
+              </a:spcAft>
+              <a:defRPr sz="1300">
+                <a:solidFill>
+                  <a:srgbClr val="94A3B8"/>
+                </a:solidFill>
+              </a:defRPr>
+            </a:pPr>
+            <a:r>
+              <a:t>• Focus: Foundational posture grounding, spine awakening, and deep breathing.</a:t>
             </a:r>
           </a:p>
         </p:txBody>
@@ -5134,8 +5385,8 @@
         </p:nvSpPr>
         <p:spPr>
           <a:xfrm>
-            <a:off x="6309360" y="1463040"/>
-            <a:ext cx="5120640" cy="4846320"/>
+            <a:off x="4434840" y="1645920"/>
+            <a:ext cx="3291840" cy="4572000"/>
           </a:xfrm>
           <a:prstGeom prst="roundRect">
             <a:avLst/>
@@ -5143,9 +5394,9 @@
           <a:solidFill>
             <a:srgbClr val="1E293B"/>
           </a:solidFill>
-          <a:ln w="25400">
+          <a:ln w="19050">
             <a:solidFill>
-              <a:srgbClr val="0EA5E9"/>
+              <a:srgbClr val="F59E0B"/>
             </a:solidFill>
           </a:ln>
         </p:spPr>
@@ -5179,8 +5430,8 @@
         </p:nvSpPr>
         <p:spPr>
           <a:xfrm>
-            <a:off x="6583680" y="1719072"/>
-            <a:ext cx="4572000" cy="4334256"/>
+            <a:off x="4709160" y="1920240"/>
+            <a:ext cx="2743200" cy="4023360"/>
           </a:xfrm>
           <a:prstGeom prst="rect">
             <a:avLst/>
@@ -5195,76 +5446,189 @@
           <a:p>
             <a:pPr>
               <a:spcAft>
-                <a:spcPts val="1200"/>
-              </a:spcAft>
-              <a:defRPr sz="2000" b="1">
-                <a:solidFill>
-                  <a:srgbClr val="0EA5E9"/>
-                </a:solidFill>
-              </a:defRPr>
-            </a:pPr>
-            <a:r>
-              <a:t>⚖️ True Stillness &amp; EMA Jitter Smoothing</a:t>
-            </a:r>
-          </a:p>
-          <a:p>
-            <a:pPr>
-              <a:spcAft>
-                <a:spcPts val="1000"/>
-              </a:spcAft>
-              <a:defRPr sz="1450">
-                <a:solidFill>
-                  <a:srgbClr val="E2E8F0"/>
-                </a:solidFill>
-              </a:defRPr>
-            </a:pPr>
-            <a:r>
-              <a:t>• Sensor Noise Filtering: S(t) = α * Y(t) + (1 - α) * S(t-1) with α = 0.65 removes webcam flicker with zero perceived delay.</a:t>
-            </a:r>
-          </a:p>
-          <a:p>
-            <a:pPr>
-              <a:spcAft>
-                <a:spcPts val="1000"/>
-              </a:spcAft>
-              <a:defRPr sz="1450">
-                <a:solidFill>
-                  <a:srgbClr val="E2E8F0"/>
-                </a:solidFill>
-              </a:defRPr>
-            </a:pPr>
-            <a:r>
-              <a:t>• Postural Stillness Calculation: Measures rolling Center-of-Gravity variance σ² = (1/N) * Σ ||CoG(i) - mean(CoG)||² across 15 frames.</a:t>
-            </a:r>
-          </a:p>
-          <a:p>
-            <a:pPr>
-              <a:spcAft>
-                <a:spcPts val="1000"/>
-              </a:spcAft>
-              <a:defRPr sz="1450">
-                <a:solidFill>
-                  <a:srgbClr val="E2E8F0"/>
-                </a:solidFill>
-              </a:defRPr>
-            </a:pPr>
-            <a:r>
-              <a:t>• Active-Pose Stillness Gate: Stillness is ONLY calculated when the target yoga pose is actively held, ending false 'still' reports.</a:t>
-            </a:r>
-          </a:p>
-          <a:p>
-            <a:pPr>
-              <a:spcAft>
-                <a:spcPts val="1000"/>
-              </a:spcAft>
-              <a:defRPr sz="1450">
-                <a:solidFill>
-                  <a:srgbClr val="E2E8F0"/>
-                </a:solidFill>
-              </a:defRPr>
-            </a:pPr>
-            <a:r>
-              <a:t>• Dynamic Stability Score: Generates an objective stability score (0-100%) and pauses timer if practitioner starts wobbling.</a:t>
+                <a:spcPts val="1400"/>
+              </a:spcAft>
+              <a:defRPr sz="1800" b="1">
+                <a:solidFill>
+                  <a:srgbClr val="F59E0B"/>
+                </a:solidFill>
+              </a:defRPr>
+            </a:pPr>
+            <a:r>
+              <a:t>🟡 Intermediate Tiers</a:t>
+            </a:r>
+          </a:p>
+          <a:p>
+            <a:pPr>
+              <a:spcAft>
+                <a:spcPts val="800"/>
+              </a:spcAft>
+              <a:defRPr sz="1300">
+                <a:solidFill>
+                  <a:srgbClr val="94A3B8"/>
+                </a:solidFill>
+              </a:defRPr>
+            </a:pPr>
+            <a:r>
+              <a:t>• 🌳 Tree Pose (Vrikshasana): Single-leg unipedal balance; hip abduction and pelvic leveling.</a:t>
+            </a:r>
+          </a:p>
+          <a:p>
+            <a:pPr>
+              <a:spcAft>
+                <a:spcPts val="800"/>
+              </a:spcAft>
+              <a:defRPr sz="1300">
+                <a:solidFill>
+                  <a:srgbClr val="94A3B8"/>
+                </a:solidFill>
+              </a:defRPr>
+            </a:pPr>
+            <a:r>
+              <a:t>• ⚔️ Warrior Pose (Virabhadrasana): Deep lunge stability, square hips, and horizontal arms.</a:t>
+            </a:r>
+          </a:p>
+          <a:p>
+            <a:pPr>
+              <a:spcAft>
+                <a:spcPts val="800"/>
+              </a:spcAft>
+              <a:defRPr sz="1300">
+                <a:solidFill>
+                  <a:srgbClr val="94A3B8"/>
+                </a:solidFill>
+              </a:defRPr>
+            </a:pPr>
+            <a:r>
+              <a:t>• 🐕 Downward Dog (Adho Mukha): Inversion stretch decompressing spine and lengthening hamstrings.</a:t>
+            </a:r>
+          </a:p>
+        </p:txBody>
+      </p:sp>
+      <p:sp>
+        <p:nvSpPr>
+          <p:cNvPr id="9" name="Rounded Rectangle 8"/>
+          <p:cNvSpPr/>
+          <p:nvPr/>
+        </p:nvSpPr>
+        <p:spPr>
+          <a:xfrm>
+            <a:off x="8138160" y="1645920"/>
+            <a:ext cx="3291840" cy="4572000"/>
+          </a:xfrm>
+          <a:prstGeom prst="roundRect">
+            <a:avLst/>
+          </a:prstGeom>
+          <a:solidFill>
+            <a:srgbClr val="1E293B"/>
+          </a:solidFill>
+          <a:ln w="19050">
+            <a:solidFill>
+              <a:srgbClr val="A855F7"/>
+            </a:solidFill>
+          </a:ln>
+        </p:spPr>
+        <p:style>
+          <a:lnRef idx="1">
+            <a:schemeClr val="accent1"/>
+          </a:lnRef>
+          <a:fillRef idx="3">
+            <a:schemeClr val="accent1"/>
+          </a:fillRef>
+          <a:effectRef idx="2">
+            <a:schemeClr val="accent1"/>
+          </a:effectRef>
+          <a:fontRef idx="minor">
+            <a:schemeClr val="lt1"/>
+          </a:fontRef>
+        </p:style>
+        <p:txBody>
+          <a:bodyPr rtlCol="0" anchor="ctr"/>
+          <a:lstStyle/>
+          <a:p>
+            <a:pPr algn="ctr"/>
+          </a:p>
+        </p:txBody>
+      </p:sp>
+      <p:sp>
+        <p:nvSpPr>
+          <p:cNvPr id="10" name="TextBox 9"/>
+          <p:cNvSpPr txBox="1"/>
+          <p:nvPr/>
+        </p:nvSpPr>
+        <p:spPr>
+          <a:xfrm>
+            <a:off x="8412480" y="1920240"/>
+            <a:ext cx="2743200" cy="4023360"/>
+          </a:xfrm>
+          <a:prstGeom prst="rect">
+            <a:avLst/>
+          </a:prstGeom>
+          <a:noFill/>
+        </p:spPr>
+        <p:txBody>
+          <a:bodyPr wrap="square">
+            <a:spAutoFit/>
+          </a:bodyPr>
+          <a:lstStyle/>
+          <a:p>
+            <a:pPr>
+              <a:spcAft>
+                <a:spcPts val="1400"/>
+              </a:spcAft>
+              <a:defRPr sz="1800" b="1">
+                <a:solidFill>
+                  <a:srgbClr val="A855F7"/>
+                </a:solidFill>
+              </a:defRPr>
+            </a:pPr>
+            <a:r>
+              <a:t>🔴 Advanced Tiers</a:t>
+            </a:r>
+          </a:p>
+          <a:p>
+            <a:pPr>
+              <a:spcAft>
+                <a:spcPts val="800"/>
+              </a:spcAft>
+              <a:defRPr sz="1300">
+                <a:solidFill>
+                  <a:srgbClr val="94A3B8"/>
+                </a:solidFill>
+              </a:defRPr>
+            </a:pPr>
+            <a:r>
+              <a:t>• 🤸 Shoulderstand (Sarvangasana): Full inverted shoulder stand; thyroid stimulation &amp; circulation.</a:t>
+            </a:r>
+          </a:p>
+          <a:p>
+            <a:pPr>
+              <a:spcAft>
+                <a:spcPts val="800"/>
+              </a:spcAft>
+              <a:defRPr sz="1300">
+                <a:solidFill>
+                  <a:srgbClr val="94A3B8"/>
+                </a:solidFill>
+              </a:defRPr>
+            </a:pPr>
+            <a:r>
+              <a:t>• 📐 Triangle Pose (Trikonasana): Compound lateral hamstring stretch &amp; core rotational stability.</a:t>
+            </a:r>
+          </a:p>
+          <a:p>
+            <a:pPr>
+              <a:spcAft>
+                <a:spcPts val="800"/>
+              </a:spcAft>
+              <a:defRPr sz="1300">
+                <a:solidFill>
+                  <a:srgbClr val="94A3B8"/>
+                </a:solidFill>
+              </a:defRPr>
+            </a:pPr>
+            <a:r>
+              <a:t>• Focus: Advanced neuromuscular balance, deep core stabilization, and inverted endurance.</a:t>
             </a:r>
           </a:p>
         </p:txBody>
@@ -5338,8 +5702,8 @@
         </p:nvSpPr>
         <p:spPr>
           <a:xfrm>
-            <a:off x="731520" y="365760"/>
-            <a:ext cx="10698480" cy="320040"/>
+            <a:off x="731520" y="457200"/>
+            <a:ext cx="10698480" cy="365760"/>
           </a:xfrm>
           <a:prstGeom prst="rect">
             <a:avLst/>
@@ -5360,7 +5724,7 @@
               </a:defRPr>
             </a:pPr>
             <a:r>
-              <a:t>YOGA AI • DISTRICT EXHIBITION 2026</a:t>
+              <a:t>YOGA AI • EXHIBITION 2026</a:t>
             </a:r>
           </a:p>
         </p:txBody>
@@ -5373,8 +5737,8 @@
         </p:nvSpPr>
         <p:spPr>
           <a:xfrm>
-            <a:off x="731520" y="640080"/>
-            <a:ext cx="10698480" cy="685800"/>
+            <a:off x="731520" y="777240"/>
+            <a:ext cx="10698480" cy="731520"/>
           </a:xfrm>
           <a:prstGeom prst="rect">
             <a:avLst/>
@@ -5395,7 +5759,7 @@
               </a:defRPr>
             </a:pPr>
             <a:r>
-              <a:t>7 Supported Classical Asanas &amp; Biomechanical Targets</a:t>
+              <a:t>Modern Dark Studio Experience &amp; Heads-Up Display (HUD)</a:t>
             </a:r>
           </a:p>
         </p:txBody>
@@ -5408,8 +5772,8 @@
         </p:nvSpPr>
         <p:spPr>
           <a:xfrm>
-            <a:off x="731520" y="1463040"/>
-            <a:ext cx="5120640" cy="4846320"/>
+            <a:off x="731520" y="1645920"/>
+            <a:ext cx="5120640" cy="2148840"/>
           </a:xfrm>
           <a:prstGeom prst="roundRect">
             <a:avLst/>
@@ -5417,9 +5781,9 @@
           <a:solidFill>
             <a:srgbClr val="1E293B"/>
           </a:solidFill>
-          <a:ln w="25400">
+          <a:ln w="19050">
             <a:solidFill>
-              <a:srgbClr val="10B981"/>
+              <a:srgbClr val="0EA5E9"/>
             </a:solidFill>
           </a:ln>
         </p:spPr>
@@ -5453,8 +5817,8 @@
         </p:nvSpPr>
         <p:spPr>
           <a:xfrm>
-            <a:off x="1005840" y="1719072"/>
-            <a:ext cx="4572000" cy="4334256"/>
+            <a:off x="1005840" y="1920240"/>
+            <a:ext cx="4572000" cy="1600200"/>
           </a:xfrm>
           <a:prstGeom prst="rect">
             <a:avLst/>
@@ -5469,76 +5833,61 @@
           <a:p>
             <a:pPr>
               <a:spcAft>
-                <a:spcPts val="1200"/>
-              </a:spcAft>
-              <a:defRPr sz="2000" b="1">
-                <a:solidFill>
-                  <a:srgbClr val="10B981"/>
-                </a:solidFill>
-              </a:defRPr>
-            </a:pPr>
-            <a:r>
-              <a:t>🧘 Standing &amp; Balance Asanas</a:t>
-            </a:r>
-          </a:p>
-          <a:p>
-            <a:pPr>
-              <a:spcAft>
-                <a:spcPts val="1000"/>
-              </a:spcAft>
-              <a:defRPr sz="1400">
-                <a:solidFill>
-                  <a:srgbClr val="E2E8F0"/>
-                </a:solidFill>
-              </a:defRPr>
-            </a:pPr>
-            <a:r>
-              <a:t>• Tree Pose (Vrikshasana): Hands joined overhead (&lt;65% torso); standing leg straight (&gt;130°) and folded foot elevated off ground.</a:t>
-            </a:r>
-          </a:p>
-          <a:p>
-            <a:pPr>
-              <a:spcAft>
-                <a:spcPts val="1000"/>
-              </a:spcAft>
-              <a:defRPr sz="1400">
-                <a:solidFill>
-                  <a:srgbClr val="E2E8F0"/>
-                </a:solidFill>
-              </a:defRPr>
-            </a:pPr>
-            <a:r>
-              <a:t>• Chair Pose (Utkatasana): Bilateral knees flexed parallel between 75° and 145°; arms raised overhead along ears to strengthen core.</a:t>
-            </a:r>
-          </a:p>
-          <a:p>
-            <a:pPr>
-              <a:spcAft>
-                <a:spcPts val="1000"/>
-              </a:spcAft>
-              <a:defRPr sz="1400">
-                <a:solidFill>
-                  <a:srgbClr val="E2E8F0"/>
-                </a:solidFill>
-              </a:defRPr>
-            </a:pPr>
-            <a:r>
-              <a:t>• Warrior Pose (Virabhadrasana): Lunge with front knee bent (65°-135°), rear leg extended (&gt;135°); torso centered over pelvis.</a:t>
-            </a:r>
-          </a:p>
-          <a:p>
-            <a:pPr>
-              <a:spcAft>
-                <a:spcPts val="1000"/>
-              </a:spcAft>
-              <a:defRPr sz="1400">
-                <a:solidFill>
-                  <a:srgbClr val="E2E8F0"/>
-                </a:solidFill>
-              </a:defRPr>
-            </a:pPr>
-            <a:r>
-              <a:t>• Triangle Pose (Trikonasana): Lateral spinal hinge; arms in 180° vertical vector; leading knee protected against hyperextension.</a:t>
+                <a:spcPts val="1400"/>
+              </a:spcAft>
+              <a:defRPr sz="1800" b="1">
+                <a:solidFill>
+                  <a:srgbClr val="0EA5E9"/>
+                </a:solidFill>
+              </a:defRPr>
+            </a:pPr>
+            <a:r>
+              <a:t>Heads-Up Camera Overlay</a:t>
+            </a:r>
+          </a:p>
+          <a:p>
+            <a:pPr>
+              <a:spcAft>
+                <a:spcPts val="800"/>
+              </a:spcAft>
+              <a:defRPr sz="1300">
+                <a:solidFill>
+                  <a:srgbClr val="94A3B8"/>
+                </a:solidFill>
+              </a:defRPr>
+            </a:pPr>
+            <a:r>
+              <a:t>• Translucent glassmorphism pill floating directly on the live camera canvas.</a:t>
+            </a:r>
+          </a:p>
+          <a:p>
+            <a:pPr>
+              <a:spcAft>
+                <a:spcPts val="800"/>
+              </a:spcAft>
+              <a:defRPr sz="1300">
+                <a:solidFill>
+                  <a:srgbClr val="94A3B8"/>
+                </a:solidFill>
+              </a:defRPr>
+            </a:pPr>
+            <a:r>
+              <a:t>• Real-time FPS telemetry, Accuracy Percentage, and Stability gauge.</a:t>
+            </a:r>
+          </a:p>
+          <a:p>
+            <a:pPr>
+              <a:spcAft>
+                <a:spcPts val="800"/>
+              </a:spcAft>
+              <a:defRPr sz="1300">
+                <a:solidFill>
+                  <a:srgbClr val="94A3B8"/>
+                </a:solidFill>
+              </a:defRPr>
+            </a:pPr>
+            <a:r>
+              <a:t>• Live In-Frame Guidance Toast alerting user to angle adjustments.</a:t>
             </a:r>
           </a:p>
         </p:txBody>
@@ -5551,8 +5900,8 @@
         </p:nvSpPr>
         <p:spPr>
           <a:xfrm>
-            <a:off x="6309360" y="1463040"/>
-            <a:ext cx="5120640" cy="4846320"/>
+            <a:off x="6309360" y="1645920"/>
+            <a:ext cx="5120640" cy="2148840"/>
           </a:xfrm>
           <a:prstGeom prst="roundRect">
             <a:avLst/>
@@ -5560,9 +5909,9 @@
           <a:solidFill>
             <a:srgbClr val="1E293B"/>
           </a:solidFill>
-          <a:ln w="25400">
+          <a:ln w="19050">
             <a:solidFill>
-              <a:srgbClr val="0EA5E9"/>
+              <a:srgbClr val="10B981"/>
             </a:solidFill>
           </a:ln>
         </p:spPr>
@@ -5596,8 +5945,8 @@
         </p:nvSpPr>
         <p:spPr>
           <a:xfrm>
-            <a:off x="6583680" y="1719072"/>
-            <a:ext cx="4572000" cy="4334256"/>
+            <a:off x="6583680" y="1920240"/>
+            <a:ext cx="4572000" cy="1600200"/>
           </a:xfrm>
           <a:prstGeom prst="rect">
             <a:avLst/>
@@ -5612,76 +5961,317 @@
           <a:p>
             <a:pPr>
               <a:spcAft>
-                <a:spcPts val="1200"/>
-              </a:spcAft>
-              <a:defRPr sz="2000" b="1">
-                <a:solidFill>
-                  <a:srgbClr val="0EA5E9"/>
-                </a:solidFill>
-              </a:defRPr>
-            </a:pPr>
-            <a:r>
-              <a:t>🧘 Floor, Prone &amp; Inversion Asanas</a:t>
-            </a:r>
-          </a:p>
-          <a:p>
-            <a:pPr>
-              <a:spcAft>
-                <a:spcPts val="1000"/>
-              </a:spcAft>
-              <a:defRPr sz="1400">
-                <a:solidFill>
-                  <a:srgbClr val="E2E8F0"/>
-                </a:solidFill>
-              </a:defRPr>
-            </a:pPr>
-            <a:r>
-              <a:t>• Downward Dog (Adho Mukha): Inverted 'V' shape; hips apex at highest point; arms and hamstrings lengthened with soft micro-bends.</a:t>
-            </a:r>
-          </a:p>
-          <a:p>
-            <a:pPr>
-              <a:spcAft>
-                <a:spcPts val="1000"/>
-              </a:spcAft>
-              <a:defRPr sz="1400">
-                <a:solidFill>
-                  <a:srgbClr val="E2E8F0"/>
-                </a:solidFill>
-              </a:defRPr>
-            </a:pPr>
-            <a:r>
-              <a:t>• Cobra Pose (Bhujangasana): Chest lifted &gt;20° from floor; soft micro-bend in elbows to prevent lumbar spinal compression.</a:t>
-            </a:r>
-          </a:p>
-          <a:p>
-            <a:pPr>
-              <a:spcAft>
-                <a:spcPts val="1000"/>
-              </a:spcAft>
-              <a:defRPr sz="1400">
-                <a:solidFill>
-                  <a:srgbClr val="E2E8F0"/>
-                </a:solidFill>
-              </a:defRPr>
-            </a:pPr>
-            <a:r>
-              <a:t>• Shoulderstand (Sarvangasana): Full body inversion; hips and legs vertically stacked above shoulders with core engagement.</a:t>
-            </a:r>
-          </a:p>
-          <a:p>
-            <a:pPr>
-              <a:spcAft>
-                <a:spcPts val="1000"/>
-              </a:spcAft>
-              <a:defRPr sz="1400">
-                <a:solidFill>
-                  <a:srgbClr val="E2E8F0"/>
-                </a:solidFill>
-              </a:defRPr>
-            </a:pPr>
-            <a:r>
-              <a:t>• Negative 'No Pose' Class: Detects standing, walking, stretching, or seated adjustments so idle moments never accumulate score.</a:t>
+                <a:spcPts val="1400"/>
+              </a:spcAft>
+              <a:defRPr sz="1800" b="1">
+                <a:solidFill>
+                  <a:srgbClr val="10B981"/>
+                </a:solidFill>
+              </a:defRPr>
+            </a:pPr>
+            <a:r>
+              <a:t>Uncropped Reference Studio</a:t>
+            </a:r>
+          </a:p>
+          <a:p>
+            <a:pPr>
+              <a:spcAft>
+                <a:spcPts val="800"/>
+              </a:spcAft>
+              <a:defRPr sz="1300">
+                <a:solidFill>
+                  <a:srgbClr val="94A3B8"/>
+                </a:solidFill>
+              </a:defRPr>
+            </a:pPr>
+            <a:r>
+              <a:t>• Reference pose card maintains complete aspect ratio (object-fit: contain).</a:t>
+            </a:r>
+          </a:p>
+          <a:p>
+            <a:pPr>
+              <a:spcAft>
+                <a:spcPts val="800"/>
+              </a:spcAft>
+              <a:defRPr sz="1300">
+                <a:solidFill>
+                  <a:srgbClr val="94A3B8"/>
+                </a:solidFill>
+              </a:defRPr>
+            </a:pPr>
+            <a:r>
+              <a:t>• Users see full target body silhouette without any clipped limbs or cut-off heads.</a:t>
+            </a:r>
+          </a:p>
+          <a:p>
+            <a:pPr>
+              <a:spcAft>
+                <a:spcPts val="800"/>
+              </a:spcAft>
+              <a:defRPr sz="1300">
+                <a:solidFill>
+                  <a:srgbClr val="94A3B8"/>
+                </a:solidFill>
+              </a:defRPr>
+            </a:pPr>
+            <a:r>
+              <a:t>• Target angle guidelines visually explained next to the video feed.</a:t>
+            </a:r>
+          </a:p>
+        </p:txBody>
+      </p:sp>
+      <p:sp>
+        <p:nvSpPr>
+          <p:cNvPr id="9" name="Rounded Rectangle 8"/>
+          <p:cNvSpPr/>
+          <p:nvPr/>
+        </p:nvSpPr>
+        <p:spPr>
+          <a:xfrm>
+            <a:off x="731520" y="4069080"/>
+            <a:ext cx="5120640" cy="2148840"/>
+          </a:xfrm>
+          <a:prstGeom prst="roundRect">
+            <a:avLst/>
+          </a:prstGeom>
+          <a:solidFill>
+            <a:srgbClr val="1E293B"/>
+          </a:solidFill>
+          <a:ln w="19050">
+            <a:solidFill>
+              <a:srgbClr val="A855F7"/>
+            </a:solidFill>
+          </a:ln>
+        </p:spPr>
+        <p:style>
+          <a:lnRef idx="1">
+            <a:schemeClr val="accent1"/>
+          </a:lnRef>
+          <a:fillRef idx="3">
+            <a:schemeClr val="accent1"/>
+          </a:fillRef>
+          <a:effectRef idx="2">
+            <a:schemeClr val="accent1"/>
+          </a:effectRef>
+          <a:fontRef idx="minor">
+            <a:schemeClr val="lt1"/>
+          </a:fontRef>
+        </p:style>
+        <p:txBody>
+          <a:bodyPr rtlCol="0" anchor="ctr"/>
+          <a:lstStyle/>
+          <a:p>
+            <a:pPr algn="ctr"/>
+          </a:p>
+        </p:txBody>
+      </p:sp>
+      <p:sp>
+        <p:nvSpPr>
+          <p:cNvPr id="10" name="TextBox 9"/>
+          <p:cNvSpPr txBox="1"/>
+          <p:nvPr/>
+        </p:nvSpPr>
+        <p:spPr>
+          <a:xfrm>
+            <a:off x="1005840" y="4343400"/>
+            <a:ext cx="4572000" cy="1600200"/>
+          </a:xfrm>
+          <a:prstGeom prst="rect">
+            <a:avLst/>
+          </a:prstGeom>
+          <a:noFill/>
+        </p:spPr>
+        <p:txBody>
+          <a:bodyPr wrap="square">
+            <a:spAutoFit/>
+          </a:bodyPr>
+          <a:lstStyle/>
+          <a:p>
+            <a:pPr>
+              <a:spcAft>
+                <a:spcPts val="1400"/>
+              </a:spcAft>
+              <a:defRPr sz="1800" b="1">
+                <a:solidFill>
+                  <a:srgbClr val="A855F7"/>
+                </a:solidFill>
+              </a:defRPr>
+            </a:pPr>
+            <a:r>
+              <a:t>Safe Frame-Delta Timer</a:t>
+            </a:r>
+          </a:p>
+          <a:p>
+            <a:pPr>
+              <a:spcAft>
+                <a:spcPts val="800"/>
+              </a:spcAft>
+              <a:defRPr sz="1300">
+                <a:solidFill>
+                  <a:srgbClr val="94A3B8"/>
+                </a:solidFill>
+              </a:defRPr>
+            </a:pPr>
+            <a:r>
+              <a:t>• Precision performance timer using frame-delta timestamp accumulation.</a:t>
+            </a:r>
+          </a:p>
+          <a:p>
+            <a:pPr>
+              <a:spcAft>
+                <a:spcPts val="800"/>
+              </a:spcAft>
+              <a:defRPr sz="1300">
+                <a:solidFill>
+                  <a:srgbClr val="94A3B8"/>
+                </a:solidFill>
+              </a:defRPr>
+            </a:pPr>
+            <a:r>
+              <a:t>• Eliminated uninitialized Unix epoch subtraction bugs (no 1793358968s glitch).</a:t>
+            </a:r>
+          </a:p>
+          <a:p>
+            <a:pPr>
+              <a:spcAft>
+                <a:spcPts val="800"/>
+              </a:spcAft>
+              <a:defRPr sz="1300">
+                <a:solidFill>
+                  <a:srgbClr val="94A3B8"/>
+                </a:solidFill>
+              </a:defRPr>
+            </a:pPr>
+            <a:r>
+              <a:t>• Strict hold timer only advances when posture satisfies biomechanical criteria.</a:t>
+            </a:r>
+          </a:p>
+        </p:txBody>
+      </p:sp>
+      <p:sp>
+        <p:nvSpPr>
+          <p:cNvPr id="11" name="Rounded Rectangle 10"/>
+          <p:cNvSpPr/>
+          <p:nvPr/>
+        </p:nvSpPr>
+        <p:spPr>
+          <a:xfrm>
+            <a:off x="6309360" y="4069080"/>
+            <a:ext cx="5120640" cy="2148840"/>
+          </a:xfrm>
+          <a:prstGeom prst="roundRect">
+            <a:avLst/>
+          </a:prstGeom>
+          <a:solidFill>
+            <a:srgbClr val="1E293B"/>
+          </a:solidFill>
+          <a:ln w="19050">
+            <a:solidFill>
+              <a:srgbClr val="F59E0B"/>
+            </a:solidFill>
+          </a:ln>
+        </p:spPr>
+        <p:style>
+          <a:lnRef idx="1">
+            <a:schemeClr val="accent1"/>
+          </a:lnRef>
+          <a:fillRef idx="3">
+            <a:schemeClr val="accent1"/>
+          </a:fillRef>
+          <a:effectRef idx="2">
+            <a:schemeClr val="accent1"/>
+          </a:effectRef>
+          <a:fontRef idx="minor">
+            <a:schemeClr val="lt1"/>
+          </a:fontRef>
+        </p:style>
+        <p:txBody>
+          <a:bodyPr rtlCol="0" anchor="ctr"/>
+          <a:lstStyle/>
+          <a:p>
+            <a:pPr algn="ctr"/>
+          </a:p>
+        </p:txBody>
+      </p:sp>
+      <p:sp>
+        <p:nvSpPr>
+          <p:cNvPr id="12" name="TextBox 11"/>
+          <p:cNvSpPr txBox="1"/>
+          <p:nvPr/>
+        </p:nvSpPr>
+        <p:spPr>
+          <a:xfrm>
+            <a:off x="6583680" y="4343400"/>
+            <a:ext cx="4572000" cy="1600200"/>
+          </a:xfrm>
+          <a:prstGeom prst="rect">
+            <a:avLst/>
+          </a:prstGeom>
+          <a:noFill/>
+        </p:spPr>
+        <p:txBody>
+          <a:bodyPr wrap="square">
+            <a:spAutoFit/>
+          </a:bodyPr>
+          <a:lstStyle/>
+          <a:p>
+            <a:pPr>
+              <a:spcAft>
+                <a:spcPts val="1400"/>
+              </a:spcAft>
+              <a:defRPr sz="1800" b="1">
+                <a:solidFill>
+                  <a:srgbClr val="F59E0B"/>
+                </a:solidFill>
+              </a:defRPr>
+            </a:pPr>
+            <a:r>
+              <a:t>Full-Body Skeleton Rendering</a:t>
+            </a:r>
+          </a:p>
+          <a:p>
+            <a:pPr>
+              <a:spcAft>
+                <a:spcPts val="800"/>
+              </a:spcAft>
+              <a:defRPr sz="1300">
+                <a:solidFill>
+                  <a:srgbClr val="94A3B8"/>
+                </a:solidFill>
+              </a:defRPr>
+            </a:pPr>
+            <a:r>
+              <a:t>• 17-landmark interconnected bone lines rendered in bright emerald green.</a:t>
+            </a:r>
+          </a:p>
+          <a:p>
+            <a:pPr>
+              <a:spcAft>
+                <a:spcPts val="800"/>
+              </a:spcAft>
+              <a:defRPr sz="1300">
+                <a:solidFill>
+                  <a:srgbClr val="94A3B8"/>
+                </a:solidFill>
+              </a:defRPr>
+            </a:pPr>
+            <a:r>
+              <a:t>• Lower confidence fallback preserves connected limb structure during occlusion.</a:t>
+            </a:r>
+          </a:p>
+          <a:p>
+            <a:pPr>
+              <a:spcAft>
+                <a:spcPts val="800"/>
+              </a:spcAft>
+              <a:defRPr sz="1300">
+                <a:solidFill>
+                  <a:srgbClr val="94A3B8"/>
+                </a:solidFill>
+              </a:defRPr>
+            </a:pPr>
+            <a:r>
+              <a:t>• Joint highlight circles show exact pivot points for hips, knees, and shoulders.</a:t>
             </a:r>
           </a:p>
         </p:txBody>
@@ -5755,8 +6345,8 @@
         </p:nvSpPr>
         <p:spPr>
           <a:xfrm>
-            <a:off x="731520" y="365760"/>
-            <a:ext cx="10698480" cy="320040"/>
+            <a:off x="731520" y="457200"/>
+            <a:ext cx="10698480" cy="365760"/>
           </a:xfrm>
           <a:prstGeom prst="rect">
             <a:avLst/>
@@ -5777,7 +6367,7 @@
               </a:defRPr>
             </a:pPr>
             <a:r>
-              <a:t>YOGA AI • DISTRICT EXHIBITION 2026</a:t>
+              <a:t>YOGA AI • EXHIBITION 2026</a:t>
             </a:r>
           </a:p>
         </p:txBody>
@@ -5790,8 +6380,8 @@
         </p:nvSpPr>
         <p:spPr>
           <a:xfrm>
-            <a:off x="731520" y="640080"/>
-            <a:ext cx="10698480" cy="685800"/>
+            <a:off x="731520" y="777240"/>
+            <a:ext cx="10698480" cy="731520"/>
           </a:xfrm>
           <a:prstGeom prst="rect">
             <a:avLst/>
@@ -5812,7 +6402,7 @@
               </a:defRPr>
             </a:pPr>
             <a:r>
-              <a:t>Dual-Mode Camera (Landscape &amp; Portrait) &amp; 10s Scorecard</a:t>
+              <a:t>Tutorials Masterclass: Comprehensive Pose Academy</a:t>
             </a:r>
           </a:p>
         </p:txBody>
@@ -5825,8 +6415,8 @@
         </p:nvSpPr>
         <p:spPr>
           <a:xfrm>
-            <a:off x="731520" y="1463040"/>
-            <a:ext cx="5120640" cy="4846320"/>
+            <a:off x="731520" y="1645920"/>
+            <a:ext cx="5120640" cy="4572000"/>
           </a:xfrm>
           <a:prstGeom prst="roundRect">
             <a:avLst/>
@@ -5834,7 +6424,7 @@
           <a:solidFill>
             <a:srgbClr val="1E293B"/>
           </a:solidFill>
-          <a:ln w="25400">
+          <a:ln w="19050">
             <a:solidFill>
               <a:srgbClr val="10B981"/>
             </a:solidFill>
@@ -5870,8 +6460,8 @@
         </p:nvSpPr>
         <p:spPr>
           <a:xfrm>
-            <a:off x="1005840" y="1719072"/>
-            <a:ext cx="4572000" cy="4334256"/>
+            <a:off x="1005840" y="1920240"/>
+            <a:ext cx="4572000" cy="4023360"/>
           </a:xfrm>
           <a:prstGeom prst="rect">
             <a:avLst/>
@@ -5886,91 +6476,91 @@
           <a:p>
             <a:pPr>
               <a:spcAft>
-                <a:spcPts val="1200"/>
-              </a:spcAft>
-              <a:defRPr sz="2000" b="1">
+                <a:spcPts val="1400"/>
+              </a:spcAft>
+              <a:defRPr sz="1800" b="1">
                 <a:solidFill>
                   <a:srgbClr val="10B981"/>
                 </a:solidFill>
               </a:defRPr>
             </a:pPr>
             <a:r>
-              <a:t>🧘 Dual-Mode Camera &amp; Ergonomics</a:t>
-            </a:r>
-          </a:p>
-          <a:p>
-            <a:pPr>
-              <a:spcAft>
-                <a:spcPts val="1000"/>
-              </a:spcAft>
-              <a:defRPr sz="1450">
-                <a:solidFill>
-                  <a:srgbClr val="E2E8F0"/>
-                </a:solidFill>
-              </a:defRPr>
-            </a:pPr>
-            <a:r>
-              <a:t>• Landscape (640x480): Wide studio perspective ideal for mat floor poses like Downward Dog, Cobra, and Triangle.</a:t>
-            </a:r>
-          </a:p>
-          <a:p>
-            <a:pPr>
-              <a:spcAft>
-                <a:spcPts val="1000"/>
-              </a:spcAft>
-              <a:defRPr sz="1450">
-                <a:solidFill>
-                  <a:srgbClr val="E2E8F0"/>
-                </a:solidFill>
-              </a:defRPr>
-            </a:pPr>
-            <a:r>
-              <a:t>• Portrait (480x640): Tall full-body perspective ideal for vertical standing poses like Tree Pose and Chair Pose.</a:t>
-            </a:r>
-          </a:p>
-          <a:p>
-            <a:pPr>
-              <a:spcAft>
-                <a:spcPts val="1000"/>
-              </a:spcAft>
-              <a:defRPr sz="1450">
-                <a:solidFill>
-                  <a:srgbClr val="E2E8F0"/>
-                </a:solidFill>
-              </a:defRPr>
-            </a:pPr>
-            <a:r>
-              <a:t>• One-Click Live Switcher: Instant toggle button on the camera HUD switches resolution without reloading neural models.</a:t>
-            </a:r>
-          </a:p>
-          <a:p>
-            <a:pPr>
-              <a:spcAft>
-                <a:spcPts val="1000"/>
-              </a:spcAft>
-              <a:defRPr sz="1450">
-                <a:solidFill>
-                  <a:srgbClr val="E2E8F0"/>
-                </a:solidFill>
-              </a:defRPr>
-            </a:pPr>
-            <a:r>
-              <a:t>• Responsive Studio Stage: Displays live camera feed and target reference photo side-by-side on all screen sizes.</a:t>
-            </a:r>
-          </a:p>
-          <a:p>
-            <a:pPr>
-              <a:spcAft>
-                <a:spcPts val="1000"/>
-              </a:spcAft>
-              <a:defRPr sz="1450">
-                <a:solidFill>
-                  <a:srgbClr val="E2E8F0"/>
-                </a:solidFill>
-              </a:defRPr>
-            </a:pPr>
-            <a:r>
-              <a:t>• Sub-15ms Latency: MoveNet Lightning runs locally at 30-60 FPS with zero video transmission outside the device.</a:t>
+              <a:t>Step-by-Step Pose Guides</a:t>
+            </a:r>
+          </a:p>
+          <a:p>
+            <a:pPr>
+              <a:spcAft>
+                <a:spcPts val="800"/>
+              </a:spcAft>
+              <a:defRPr sz="1300">
+                <a:solidFill>
+                  <a:srgbClr val="94A3B8"/>
+                </a:solidFill>
+              </a:defRPr>
+            </a:pPr>
+            <a:r>
+              <a:t>• Complete dedicated Academy page covering all 7 classical asanas.</a:t>
+            </a:r>
+          </a:p>
+          <a:p>
+            <a:pPr>
+              <a:spcAft>
+                <a:spcPts val="800"/>
+              </a:spcAft>
+              <a:defRPr sz="1300">
+                <a:solidFill>
+                  <a:srgbClr val="94A3B8"/>
+                </a:solidFill>
+              </a:defRPr>
+            </a:pPr>
+            <a:r>
+              <a:t>• Target anatomical focus badges (Balance, Core, Spine, Legs, Inversion).</a:t>
+            </a:r>
+          </a:p>
+          <a:p>
+            <a:pPr>
+              <a:spcAft>
+                <a:spcPts val="800"/>
+              </a:spcAft>
+              <a:defRPr sz="1300">
+                <a:solidFill>
+                  <a:srgbClr val="94A3B8"/>
+                </a:solidFill>
+              </a:defRPr>
+            </a:pPr>
+            <a:r>
+              <a:t>• Numbered phase-by-phase execution instructions from setup to release.</a:t>
+            </a:r>
+          </a:p>
+          <a:p>
+            <a:pPr>
+              <a:spcAft>
+                <a:spcPts val="800"/>
+              </a:spcAft>
+              <a:defRPr sz="1300">
+                <a:solidFill>
+                  <a:srgbClr val="94A3B8"/>
+                </a:solidFill>
+              </a:defRPr>
+            </a:pPr>
+            <a:r>
+              <a:t>• Breathing coordination advice (inhale during expansion, exhale during folds).</a:t>
+            </a:r>
+          </a:p>
+          <a:p>
+            <a:pPr>
+              <a:spcAft>
+                <a:spcPts val="800"/>
+              </a:spcAft>
+              <a:defRPr sz="1300">
+                <a:solidFill>
+                  <a:srgbClr val="94A3B8"/>
+                </a:solidFill>
+              </a:defRPr>
+            </a:pPr>
+            <a:r>
+              <a:t>• Common mistakes highlighted to protect vulnerable joints.</a:t>
             </a:r>
           </a:p>
         </p:txBody>
@@ -5983,8 +6573,8 @@
         </p:nvSpPr>
         <p:spPr>
           <a:xfrm>
-            <a:off x="6309360" y="1463040"/>
-            <a:ext cx="5120640" cy="4846320"/>
+            <a:off x="6309360" y="1645920"/>
+            <a:ext cx="5120640" cy="4572000"/>
           </a:xfrm>
           <a:prstGeom prst="roundRect">
             <a:avLst/>
@@ -5992,9 +6582,9 @@
           <a:solidFill>
             <a:srgbClr val="1E293B"/>
           </a:solidFill>
-          <a:ln w="25400">
+          <a:ln w="19050">
             <a:solidFill>
-              <a:srgbClr val="F59E0B"/>
+              <a:srgbClr val="0EA5E9"/>
             </a:solidFill>
           </a:ln>
         </p:spPr>
@@ -6028,8 +6618,8 @@
         </p:nvSpPr>
         <p:spPr>
           <a:xfrm>
-            <a:off x="6583680" y="1719072"/>
-            <a:ext cx="4572000" cy="4334256"/>
+            <a:off x="6583680" y="1920240"/>
+            <a:ext cx="4572000" cy="4023360"/>
           </a:xfrm>
           <a:prstGeom prst="rect">
             <a:avLst/>
@@ -6044,76 +6634,76 @@
           <a:p>
             <a:pPr>
               <a:spcAft>
-                <a:spcPts val="1200"/>
-              </a:spcAft>
-              <a:defRPr sz="2000" b="1">
-                <a:solidFill>
-                  <a:srgbClr val="F59E0B"/>
-                </a:solidFill>
-              </a:defRPr>
-            </a:pPr>
-            <a:r>
-              <a:t>⏱️ 10-Second Auto-Closing Modal</a:t>
-            </a:r>
-          </a:p>
-          <a:p>
-            <a:pPr>
-              <a:spcAft>
-                <a:spcPts val="1000"/>
-              </a:spcAft>
-              <a:defRPr sz="1450">
-                <a:solidFill>
-                  <a:srgbClr val="E2E8F0"/>
-                </a:solidFill>
-              </a:defRPr>
-            </a:pPr>
-            <a:r>
-              <a:t>• Hands-Free Auto-Dismiss: Closes automatically in 10s if untouched, returning practitioner to the selection menu without keyboard reach.</a:t>
-            </a:r>
-          </a:p>
-          <a:p>
-            <a:pPr>
-              <a:spcAft>
-                <a:spcPts val="1000"/>
-              </a:spcAft>
-              <a:defRPr sz="1450">
-                <a:solidFill>
-                  <a:srgbClr val="E2E8F0"/>
-                </a:solidFill>
-              </a:defRPr>
-            </a:pPr>
-            <a:r>
-              <a:t>• Hover &amp; Touch Hold: Touching the screen or hovering the mouse immediately pauses countdown to allow comfortable reading.</a:t>
-            </a:r>
-          </a:p>
-          <a:p>
-            <a:pPr>
-              <a:spcAft>
-                <a:spcPts val="1000"/>
-              </a:spcAft>
-              <a:defRPr sz="1450">
-                <a:solidFill>
-                  <a:srgbClr val="E2E8F0"/>
-                </a:solidFill>
-              </a:defRPr>
-            </a:pPr>
-            <a:r>
-              <a:t>• Always-Scrollable: Modal body is scrollable with custom soft-tinted scrollbars, eliminating clipping on laptops and tablets.</a:t>
-            </a:r>
-          </a:p>
-          <a:p>
-            <a:pPr>
-              <a:spcAft>
-                <a:spcPts val="1000"/>
-              </a:spcAft>
-              <a:defRPr sz="1450">
-                <a:solidFill>
-                  <a:srgbClr val="E2E8F0"/>
-                </a:solidFill>
-              </a:defRPr>
-            </a:pPr>
-            <a:r>
-              <a:t>• Auto-Save Guarantee: Comprehensive session metrics (stability, accuracy, hold time) auto-persist to IndexedDB even on auto-close.</a:t>
+                <a:spcPts val="1400"/>
+              </a:spcAft>
+              <a:defRPr sz="1800" b="1">
+                <a:solidFill>
+                  <a:srgbClr val="0EA5E9"/>
+                </a:solidFill>
+              </a:defRPr>
+            </a:pPr>
+            <a:r>
+              <a:t>Camera Calibration &amp; Best Practices</a:t>
+            </a:r>
+          </a:p>
+          <a:p>
+            <a:pPr>
+              <a:spcAft>
+                <a:spcPts val="800"/>
+              </a:spcAft>
+              <a:defRPr sz="1300">
+                <a:solidFill>
+                  <a:srgbClr val="94A3B8"/>
+                </a:solidFill>
+              </a:defRPr>
+            </a:pPr>
+            <a:r>
+              <a:t>• Full-Body Framing: How to position webcam 6–8 feet away for full head-to-toe capture.</a:t>
+            </a:r>
+          </a:p>
+          <a:p>
+            <a:pPr>
+              <a:spcAft>
+                <a:spcPts val="800"/>
+              </a:spcAft>
+              <a:defRPr sz="1300">
+                <a:solidFill>
+                  <a:srgbClr val="94A3B8"/>
+                </a:solidFill>
+              </a:defRPr>
+            </a:pPr>
+            <a:r>
+              <a:t>• Optimal Studio Lighting: Ensuring front-facing ambient light without backlighting glare.</a:t>
+            </a:r>
+          </a:p>
+          <a:p>
+            <a:pPr>
+              <a:spcAft>
+                <a:spcPts val="800"/>
+              </a:spcAft>
+              <a:defRPr sz="1300">
+                <a:solidFill>
+                  <a:srgbClr val="94A3B8"/>
+                </a:solidFill>
+              </a:defRPr>
+            </a:pPr>
+            <a:r>
+              <a:t>• Clothing Guidance: Recommending form-fitting workout attire for crisp keypoint detection.</a:t>
+            </a:r>
+          </a:p>
+          <a:p>
+            <a:pPr>
+              <a:spcAft>
+                <a:spcPts val="800"/>
+              </a:spcAft>
+              <a:defRPr sz="1300">
+                <a:solidFill>
+                  <a:srgbClr val="94A3B8"/>
+                </a:solidFill>
+              </a:defRPr>
+            </a:pPr>
+            <a:r>
+              <a:t>• One-Click Direct Launch: 'Practice Now' buttons jump instantly into the live AI studio.</a:t>
             </a:r>
           </a:p>
         </p:txBody>
@@ -6187,8 +6777,8 @@
         </p:nvSpPr>
         <p:spPr>
           <a:xfrm>
-            <a:off x="731520" y="365760"/>
-            <a:ext cx="10698480" cy="320040"/>
+            <a:off x="731520" y="457200"/>
+            <a:ext cx="10698480" cy="365760"/>
           </a:xfrm>
           <a:prstGeom prst="rect">
             <a:avLst/>
@@ -6209,7 +6799,7 @@
               </a:defRPr>
             </a:pPr>
             <a:r>
-              <a:t>YOGA AI • DISTRICT EXHIBITION 2026</a:t>
+              <a:t>YOGA AI • EXHIBITION 2026</a:t>
             </a:r>
           </a:p>
         </p:txBody>
@@ -6222,8 +6812,8 @@
         </p:nvSpPr>
         <p:spPr>
           <a:xfrm>
-            <a:off x="731520" y="640080"/>
-            <a:ext cx="10698480" cy="685800"/>
+            <a:off x="731520" y="777240"/>
+            <a:ext cx="10698480" cy="731520"/>
           </a:xfrm>
           <a:prstGeom prst="rect">
             <a:avLst/>
@@ -6244,7 +6834,7 @@
               </a:defRPr>
             </a:pPr>
             <a:r>
-              <a:t>IndexedDB Analytics &amp; Dual Performance Charts (/progress)</a:t>
+              <a:t>Analytics, Progress Tracking &amp; Session Diagnostics</a:t>
             </a:r>
           </a:p>
         </p:txBody>
@@ -6257,8 +6847,8 @@
         </p:nvSpPr>
         <p:spPr>
           <a:xfrm>
-            <a:off x="731520" y="1463040"/>
-            <a:ext cx="5120640" cy="4846320"/>
+            <a:off x="731520" y="1645920"/>
+            <a:ext cx="5120640" cy="2148840"/>
           </a:xfrm>
           <a:prstGeom prst="roundRect">
             <a:avLst/>
@@ -6266,7 +6856,7 @@
           <a:solidFill>
             <a:srgbClr val="1E293B"/>
           </a:solidFill>
-          <a:ln w="25400">
+          <a:ln w="19050">
             <a:solidFill>
               <a:srgbClr val="10B981"/>
             </a:solidFill>
@@ -6302,8 +6892,8 @@
         </p:nvSpPr>
         <p:spPr>
           <a:xfrm>
-            <a:off x="1005840" y="1719072"/>
-            <a:ext cx="4572000" cy="4334256"/>
+            <a:off x="1005840" y="1920240"/>
+            <a:ext cx="4572000" cy="1600200"/>
           </a:xfrm>
           <a:prstGeom prst="rect">
             <a:avLst/>
@@ -6318,76 +6908,61 @@
           <a:p>
             <a:pPr>
               <a:spcAft>
-                <a:spcPts val="1200"/>
-              </a:spcAft>
-              <a:defRPr sz="2000" b="1">
+                <a:spcPts val="1400"/>
+              </a:spcAft>
+              <a:defRPr sz="1800" b="1">
                 <a:solidFill>
                   <a:srgbClr val="10B981"/>
                 </a:solidFill>
               </a:defRPr>
             </a:pPr>
             <a:r>
-              <a:t>🗄️ 100% Offline Client Database</a:t>
-            </a:r>
-          </a:p>
-          <a:p>
-            <a:pPr>
-              <a:spcAft>
-                <a:spcPts val="1000"/>
-              </a:spcAft>
-              <a:defRPr sz="1450">
-                <a:solidFill>
-                  <a:srgbClr val="E2E8F0"/>
-                </a:solidFill>
-              </a:defRPr>
-            </a:pPr>
-            <a:r>
-              <a:t>• Browser IndexedDB Storage: Employs local database 'YogaAIDB' with object store 'sessions' directly inside the client browser.</a:t>
-            </a:r>
-          </a:p>
-          <a:p>
-            <a:pPr>
-              <a:spcAft>
-                <a:spcPts val="1000"/>
-              </a:spcAft>
-              <a:defRPr sz="1450">
-                <a:solidFill>
-                  <a:srgbClr val="E2E8F0"/>
-                </a:solidFill>
-              </a:defRPr>
-            </a:pPr>
-            <a:r>
-              <a:t>• Zero Cloud Server Dependency: Eliminates monthly cloud hosting bills, database subscription costs, and user authentication walls.</a:t>
-            </a:r>
-          </a:p>
-          <a:p>
-            <a:pPr>
-              <a:spcAft>
-                <a:spcPts val="1000"/>
-              </a:spcAft>
-              <a:defRPr sz="1450">
-                <a:solidFill>
-                  <a:srgbClr val="E2E8F0"/>
-                </a:solidFill>
-              </a:defRPr>
-            </a:pPr>
-            <a:r>
-              <a:t>• 100% Biometric Privacy: Video streams, joint coordinates, and workout performance data never transmit over the network.</a:t>
-            </a:r>
-          </a:p>
-          <a:p>
-            <a:pPr>
-              <a:spcAft>
-                <a:spcPts val="1000"/>
-              </a:spcAft>
-              <a:defRPr sz="1450">
-                <a:solidFill>
-                  <a:srgbClr val="E2E8F0"/>
-                </a:solidFill>
-              </a:defRPr>
-            </a:pPr>
-            <a:r>
-              <a:t>• Permanent Session Retention: Automatically logs timestamp, pose name, hold duration, average accuracy, and stability score.</a:t>
+              <a:t>Pose Accuracy Bar Graph</a:t>
+            </a:r>
+          </a:p>
+          <a:p>
+            <a:pPr>
+              <a:spcAft>
+                <a:spcPts val="800"/>
+              </a:spcAft>
+              <a:defRPr sz="1300">
+                <a:solidFill>
+                  <a:srgbClr val="94A3B8"/>
+                </a:solidFill>
+              </a:defRPr>
+            </a:pPr>
+            <a:r>
+              <a:t>• Interactive horizontal comparison bars tracking accuracy % per asana.</a:t>
+            </a:r>
+          </a:p>
+          <a:p>
+            <a:pPr>
+              <a:spcAft>
+                <a:spcPts val="800"/>
+              </a:spcAft>
+              <a:defRPr sz="1300">
+                <a:solidFill>
+                  <a:srgbClr val="94A3B8"/>
+                </a:solidFill>
+              </a:defRPr>
+            </a:pPr>
+            <a:r>
+              <a:t>• Visual breakdown shows user's strongest postures and areas needing practice.</a:t>
+            </a:r>
+          </a:p>
+          <a:p>
+            <a:pPr>
+              <a:spcAft>
+                <a:spcPts val="800"/>
+              </a:spcAft>
+              <a:defRPr sz="1300">
+                <a:solidFill>
+                  <a:srgbClr val="94A3B8"/>
+                </a:solidFill>
+              </a:defRPr>
+            </a:pPr>
+            <a:r>
+              <a:t>• Color-coded thresholds (Emerald = Excellent, Amber = Good, Sky = Practice).</a:t>
             </a:r>
           </a:p>
         </p:txBody>
@@ -6400,8 +6975,8 @@
         </p:nvSpPr>
         <p:spPr>
           <a:xfrm>
-            <a:off x="6309360" y="1463040"/>
-            <a:ext cx="5120640" cy="4846320"/>
+            <a:off x="6309360" y="1645920"/>
+            <a:ext cx="5120640" cy="2148840"/>
           </a:xfrm>
           <a:prstGeom prst="roundRect">
             <a:avLst/>
@@ -6409,7 +6984,7 @@
           <a:solidFill>
             <a:srgbClr val="1E293B"/>
           </a:solidFill>
-          <a:ln w="25400">
+          <a:ln w="19050">
             <a:solidFill>
               <a:srgbClr val="0EA5E9"/>
             </a:solidFill>
@@ -6445,8 +7020,8 @@
         </p:nvSpPr>
         <p:spPr>
           <a:xfrm>
-            <a:off x="6583680" y="1719072"/>
-            <a:ext cx="4572000" cy="4334256"/>
+            <a:off x="6583680" y="1920240"/>
+            <a:ext cx="4572000" cy="1600200"/>
           </a:xfrm>
           <a:prstGeom prst="rect">
             <a:avLst/>
@@ -6461,76 +7036,332 @@
           <a:p>
             <a:pPr>
               <a:spcAft>
-                <a:spcPts val="1200"/>
-              </a:spcAft>
-              <a:defRPr sz="2000" b="1">
+                <a:spcPts val="1400"/>
+              </a:spcAft>
+              <a:defRPr sz="1800" b="1">
                 <a:solidFill>
                   <a:srgbClr val="0EA5E9"/>
                 </a:solidFill>
               </a:defRPr>
             </a:pPr>
             <a:r>
-              <a:t>📊 Always-Visible Dual Charts &amp; Export</a:t>
-            </a:r>
-          </a:p>
-          <a:p>
-            <a:pPr>
-              <a:spcAft>
-                <a:spcPts val="1000"/>
-              </a:spcAft>
-              <a:defRPr sz="1450">
-                <a:solidFill>
-                  <a:srgbClr val="E2E8F0"/>
-                </a:solidFill>
-              </a:defRPr>
-            </a:pPr>
-            <a:r>
-              <a:t>• Dual Performance Chart: Seamlessly renders dual Bar &amp; Line SVG visualization comparing stability trajectory and posture score.</a:t>
-            </a:r>
-          </a:p>
-          <a:p>
-            <a:pPr>
-              <a:spcAft>
-                <a:spcPts val="1000"/>
-              </a:spcAft>
-              <a:defRPr sz="1450">
-                <a:solidFill>
-                  <a:srgbClr val="E2E8F0"/>
-                </a:solidFill>
-              </a:defRPr>
-            </a:pPr>
-            <a:r>
-              <a:t>• Always Displays Baseline: Even on a fresh installation, shows clear reference trends so judges and users immediately see charts.</a:t>
-            </a:r>
-          </a:p>
-          <a:p>
-            <a:pPr>
-              <a:spcAft>
-                <a:spcPts val="1000"/>
-              </a:spcAft>
-              <a:defRPr sz="1450">
-                <a:solidFill>
-                  <a:srgbClr val="E2E8F0"/>
-                </a:solidFill>
-              </a:defRPr>
-            </a:pPr>
-            <a:r>
-              <a:t>• Soft-Tinted Smooth Scrolling: Natural vertical scrolling with subtle custom scrollbars, preventing any viewport clipping.</a:t>
-            </a:r>
-          </a:p>
-          <a:p>
-            <a:pPr>
-              <a:spcAft>
-                <a:spcPts val="1000"/>
-              </a:spcAft>
-              <a:defRPr sz="1450">
-                <a:solidFill>
-                  <a:srgbClr val="E2E8F0"/>
-                </a:solidFill>
-              </a:defRPr>
-            </a:pPr>
-            <a:r>
-              <a:t>• One-Click JSON Audit Export: Clinicians, physical therapists, and judges can download the full chronological workout dataset with one click.</a:t>
+              <a:t>Performance Trend SVG Line Chart</a:t>
+            </a:r>
+          </a:p>
+          <a:p>
+            <a:pPr>
+              <a:spcAft>
+                <a:spcPts val="800"/>
+              </a:spcAft>
+              <a:defRPr sz="1300">
+                <a:solidFill>
+                  <a:srgbClr val="94A3B8"/>
+                </a:solidFill>
+              </a:defRPr>
+            </a:pPr>
+            <a:r>
+              <a:t>• Historical accuracy timeline plotted over practice sessions.</a:t>
+            </a:r>
+          </a:p>
+          <a:p>
+            <a:pPr>
+              <a:spcAft>
+                <a:spcPts val="800"/>
+              </a:spcAft>
+              <a:defRPr sz="1300">
+                <a:solidFill>
+                  <a:srgbClr val="94A3B8"/>
+                </a:solidFill>
+              </a:defRPr>
+            </a:pPr>
+            <a:r>
+              <a:t>• Shows verifiable progress and stability improvement curves across days.</a:t>
+            </a:r>
+          </a:p>
+          <a:p>
+            <a:pPr>
+              <a:spcAft>
+                <a:spcPts val="800"/>
+              </a:spcAft>
+              <a:defRPr sz="1300">
+                <a:solidFill>
+                  <a:srgbClr val="94A3B8"/>
+                </a:solidFill>
+              </a:defRPr>
+            </a:pPr>
+            <a:r>
+              <a:t>• Smooth vector rendering directly in browser with interactive data points.</a:t>
+            </a:r>
+          </a:p>
+        </p:txBody>
+      </p:sp>
+      <p:sp>
+        <p:nvSpPr>
+          <p:cNvPr id="9" name="Rounded Rectangle 8"/>
+          <p:cNvSpPr/>
+          <p:nvPr/>
+        </p:nvSpPr>
+        <p:spPr>
+          <a:xfrm>
+            <a:off x="731520" y="4069080"/>
+            <a:ext cx="5120640" cy="2148840"/>
+          </a:xfrm>
+          <a:prstGeom prst="roundRect">
+            <a:avLst/>
+          </a:prstGeom>
+          <a:solidFill>
+            <a:srgbClr val="1E293B"/>
+          </a:solidFill>
+          <a:ln w="19050">
+            <a:solidFill>
+              <a:srgbClr val="A855F7"/>
+            </a:solidFill>
+          </a:ln>
+        </p:spPr>
+        <p:style>
+          <a:lnRef idx="1">
+            <a:schemeClr val="accent1"/>
+          </a:lnRef>
+          <a:fillRef idx="3">
+            <a:schemeClr val="accent1"/>
+          </a:fillRef>
+          <a:effectRef idx="2">
+            <a:schemeClr val="accent1"/>
+          </a:effectRef>
+          <a:fontRef idx="minor">
+            <a:schemeClr val="lt1"/>
+          </a:fontRef>
+        </p:style>
+        <p:txBody>
+          <a:bodyPr rtlCol="0" anchor="ctr"/>
+          <a:lstStyle/>
+          <a:p>
+            <a:pPr algn="ctr"/>
+          </a:p>
+        </p:txBody>
+      </p:sp>
+      <p:sp>
+        <p:nvSpPr>
+          <p:cNvPr id="10" name="TextBox 9"/>
+          <p:cNvSpPr txBox="1"/>
+          <p:nvPr/>
+        </p:nvSpPr>
+        <p:spPr>
+          <a:xfrm>
+            <a:off x="1005840" y="4343400"/>
+            <a:ext cx="4572000" cy="1600200"/>
+          </a:xfrm>
+          <a:prstGeom prst="rect">
+            <a:avLst/>
+          </a:prstGeom>
+          <a:noFill/>
+        </p:spPr>
+        <p:txBody>
+          <a:bodyPr wrap="square">
+            <a:spAutoFit/>
+          </a:bodyPr>
+          <a:lstStyle/>
+          <a:p>
+            <a:pPr>
+              <a:spcAft>
+                <a:spcPts val="1400"/>
+              </a:spcAft>
+              <a:defRPr sz="1800" b="1">
+                <a:solidFill>
+                  <a:srgbClr val="A855F7"/>
+                </a:solidFill>
+              </a:defRPr>
+            </a:pPr>
+            <a:r>
+              <a:t>Automated Diagnostic Scorecard</a:t>
+            </a:r>
+          </a:p>
+          <a:p>
+            <a:pPr>
+              <a:spcAft>
+                <a:spcPts val="800"/>
+              </a:spcAft>
+              <a:defRPr sz="1300">
+                <a:solidFill>
+                  <a:srgbClr val="94A3B8"/>
+                </a:solidFill>
+              </a:defRPr>
+            </a:pPr>
+            <a:r>
+              <a:t>• Displays immediately upon session completion or clicking Stop Pose.</a:t>
+            </a:r>
+          </a:p>
+          <a:p>
+            <a:pPr>
+              <a:spcAft>
+                <a:spcPts val="800"/>
+              </a:spcAft>
+              <a:defRPr sz="1300">
+                <a:solidFill>
+                  <a:srgbClr val="94A3B8"/>
+                </a:solidFill>
+              </a:defRPr>
+            </a:pPr>
+            <a:r>
+              <a:t>• 10-second auto-close timer with smart hover/click pause detection.</a:t>
+            </a:r>
+          </a:p>
+          <a:p>
+            <a:pPr>
+              <a:spcAft>
+                <a:spcPts val="800"/>
+              </a:spcAft>
+              <a:defRPr sz="1300">
+                <a:solidFill>
+                  <a:srgbClr val="94A3B8"/>
+                </a:solidFill>
+              </a:defRPr>
+            </a:pPr>
+            <a:r>
+              <a:t>• Detailed breakdown: Total Hold Duration, Biomechanical Score, and Tips.</a:t>
+            </a:r>
+          </a:p>
+          <a:p>
+            <a:pPr>
+              <a:spcAft>
+                <a:spcPts val="800"/>
+              </a:spcAft>
+              <a:defRPr sz="1300">
+                <a:solidFill>
+                  <a:srgbClr val="94A3B8"/>
+                </a:solidFill>
+              </a:defRPr>
+            </a:pPr>
+            <a:r>
+              <a:t>• Fully scrollable modal prevents overflow on smaller laptop screens.</a:t>
+            </a:r>
+          </a:p>
+        </p:txBody>
+      </p:sp>
+      <p:sp>
+        <p:nvSpPr>
+          <p:cNvPr id="11" name="Rounded Rectangle 10"/>
+          <p:cNvSpPr/>
+          <p:nvPr/>
+        </p:nvSpPr>
+        <p:spPr>
+          <a:xfrm>
+            <a:off x="6309360" y="4069080"/>
+            <a:ext cx="5120640" cy="2148840"/>
+          </a:xfrm>
+          <a:prstGeom prst="roundRect">
+            <a:avLst/>
+          </a:prstGeom>
+          <a:solidFill>
+            <a:srgbClr val="1E293B"/>
+          </a:solidFill>
+          <a:ln w="19050">
+            <a:solidFill>
+              <a:srgbClr val="F59E0B"/>
+            </a:solidFill>
+          </a:ln>
+        </p:spPr>
+        <p:style>
+          <a:lnRef idx="1">
+            <a:schemeClr val="accent1"/>
+          </a:lnRef>
+          <a:fillRef idx="3">
+            <a:schemeClr val="accent1"/>
+          </a:fillRef>
+          <a:effectRef idx="2">
+            <a:schemeClr val="accent1"/>
+          </a:effectRef>
+          <a:fontRef idx="minor">
+            <a:schemeClr val="lt1"/>
+          </a:fontRef>
+        </p:style>
+        <p:txBody>
+          <a:bodyPr rtlCol="0" anchor="ctr"/>
+          <a:lstStyle/>
+          <a:p>
+            <a:pPr algn="ctr"/>
+          </a:p>
+        </p:txBody>
+      </p:sp>
+      <p:sp>
+        <p:nvSpPr>
+          <p:cNvPr id="12" name="TextBox 11"/>
+          <p:cNvSpPr txBox="1"/>
+          <p:nvPr/>
+        </p:nvSpPr>
+        <p:spPr>
+          <a:xfrm>
+            <a:off x="6583680" y="4343400"/>
+            <a:ext cx="4572000" cy="1600200"/>
+          </a:xfrm>
+          <a:prstGeom prst="rect">
+            <a:avLst/>
+          </a:prstGeom>
+          <a:noFill/>
+        </p:spPr>
+        <p:txBody>
+          <a:bodyPr wrap="square">
+            <a:spAutoFit/>
+          </a:bodyPr>
+          <a:lstStyle/>
+          <a:p>
+            <a:pPr>
+              <a:spcAft>
+                <a:spcPts val="1400"/>
+              </a:spcAft>
+              <a:defRPr sz="1800" b="1">
+                <a:solidFill>
+                  <a:srgbClr val="F59E0B"/>
+                </a:solidFill>
+              </a:defRPr>
+            </a:pPr>
+            <a:r>
+              <a:t>Persistent Local Storage</a:t>
+            </a:r>
+          </a:p>
+          <a:p>
+            <a:pPr>
+              <a:spcAft>
+                <a:spcPts val="800"/>
+              </a:spcAft>
+              <a:defRPr sz="1300">
+                <a:solidFill>
+                  <a:srgbClr val="94A3B8"/>
+                </a:solidFill>
+              </a:defRPr>
+            </a:pPr>
+            <a:r>
+              <a:t>• Session history and personal best hold streaks stored securely in browser.</a:t>
+            </a:r>
+          </a:p>
+          <a:p>
+            <a:pPr>
+              <a:spcAft>
+                <a:spcPts val="800"/>
+              </a:spcAft>
+              <a:defRPr sz="1300">
+                <a:solidFill>
+                  <a:srgbClr val="94A3B8"/>
+                </a:solidFill>
+              </a:defRPr>
+            </a:pPr>
+            <a:r>
+              <a:t>• Zero server dependency: records persist across browser reloads without cloud DB.</a:t>
+            </a:r>
+          </a:p>
+          <a:p>
+            <a:pPr>
+              <a:spcAft>
+                <a:spcPts val="800"/>
+              </a:spcAft>
+              <a:defRPr sz="1300">
+                <a:solidFill>
+                  <a:srgbClr val="94A3B8"/>
+                </a:solidFill>
+              </a:defRPr>
+            </a:pPr>
+            <a:r>
+              <a:t>• Exportable summary stats for student practice logs and science exhibitions.</a:t>
             </a:r>
           </a:p>
         </p:txBody>
@@ -6604,8 +7435,8 @@
         </p:nvSpPr>
         <p:spPr>
           <a:xfrm>
-            <a:off x="731520" y="365760"/>
-            <a:ext cx="10698480" cy="320040"/>
+            <a:off x="731520" y="457200"/>
+            <a:ext cx="10698480" cy="365760"/>
           </a:xfrm>
           <a:prstGeom prst="rect">
             <a:avLst/>
@@ -6626,7 +7457,7 @@
               </a:defRPr>
             </a:pPr>
             <a:r>
-              <a:t>YOGA AI • DISTRICT EXHIBITION 2026</a:t>
+              <a:t>YOGA AI • EXHIBITION 2026</a:t>
             </a:r>
           </a:p>
         </p:txBody>
@@ -6639,8 +7470,8 @@
         </p:nvSpPr>
         <p:spPr>
           <a:xfrm>
-            <a:off x="731520" y="640080"/>
-            <a:ext cx="10698480" cy="685800"/>
+            <a:off x="731520" y="777240"/>
+            <a:ext cx="10698480" cy="731520"/>
           </a:xfrm>
           <a:prstGeom prst="rect">
             <a:avLst/>
@@ -6661,7 +7492,7 @@
               </a:defRPr>
             </a:pPr>
             <a:r>
-              <a:t>Full-Stack Edge Architecture &amp; 60 FPS Processing Pipeline</a:t>
+              <a:t>Technical Stack &amp; Engineering Highlights</a:t>
             </a:r>
           </a:p>
         </p:txBody>
@@ -6674,8 +7505,8 @@
         </p:nvSpPr>
         <p:spPr>
           <a:xfrm>
-            <a:off x="731520" y="1463040"/>
-            <a:ext cx="5120640" cy="4846320"/>
+            <a:off x="731520" y="1645920"/>
+            <a:ext cx="3291840" cy="4572000"/>
           </a:xfrm>
           <a:prstGeom prst="roundRect">
             <a:avLst/>
@@ -6683,7 +7514,7 @@
           <a:solidFill>
             <a:srgbClr val="1E293B"/>
           </a:solidFill>
-          <a:ln w="25400">
+          <a:ln w="19050">
             <a:solidFill>
               <a:srgbClr val="10B981"/>
             </a:solidFill>
@@ -6719,8 +7550,8 @@
         </p:nvSpPr>
         <p:spPr>
           <a:xfrm>
-            <a:off x="1005840" y="1719072"/>
-            <a:ext cx="4572000" cy="4334256"/>
+            <a:off x="1005840" y="1920240"/>
+            <a:ext cx="2743200" cy="4023360"/>
           </a:xfrm>
           <a:prstGeom prst="rect">
             <a:avLst/>
@@ -6735,76 +7566,76 @@
           <a:p>
             <a:pPr>
               <a:spcAft>
-                <a:spcPts val="1200"/>
-              </a:spcAft>
-              <a:defRPr sz="2000" b="1">
+                <a:spcPts val="1400"/>
+              </a:spcAft>
+              <a:defRPr sz="1800" b="1">
                 <a:solidFill>
                   <a:srgbClr val="10B981"/>
                 </a:solidFill>
               </a:defRPr>
             </a:pPr>
             <a:r>
-              <a:t>⚡ 60 FPS On-Device Vision Pipeline</a:t>
-            </a:r>
-          </a:p>
-          <a:p>
-            <a:pPr>
-              <a:spcAft>
-                <a:spcPts val="1000"/>
-              </a:spcAft>
-              <a:defRPr sz="1450">
-                <a:solidFill>
-                  <a:srgbClr val="E2E8F0"/>
-                </a:solidFill>
-              </a:defRPr>
-            </a:pPr>
-            <a:r>
-              <a:t>• Direct Webcam Stream: Captures raw video frames at 60 FPS directly into an HTML5 Canvas using WebGL acceleration.</a:t>
-            </a:r>
-          </a:p>
-          <a:p>
-            <a:pPr>
-              <a:spcAft>
-                <a:spcPts val="1000"/>
-              </a:spcAft>
-              <a:defRPr sz="1450">
-                <a:solidFill>
-                  <a:srgbClr val="E2E8F0"/>
-                </a:solidFill>
-              </a:defRPr>
-            </a:pPr>
-            <a:r>
-              <a:t>• MoveNet Lightning Engine: Evaluates 17 anatomical keypoints locally in 8-12 milliseconds on standard commodity CPU/GPUs.</a:t>
-            </a:r>
-          </a:p>
-          <a:p>
-            <a:pPr>
-              <a:spcAft>
-                <a:spcPts val="1000"/>
-              </a:spcAft>
-              <a:defRPr sz="1450">
-                <a:solidFill>
-                  <a:srgbClr val="E2E8F0"/>
-                </a:solidFill>
-              </a:defRPr>
-            </a:pPr>
-            <a:r>
-              <a:t>• Anatomical Graph Assembly: Maps explicit skeletal segments (shoulders to hips, hips to knees, knees to ankles) with zero breakages.</a:t>
-            </a:r>
-          </a:p>
-          <a:p>
-            <a:pPr>
-              <a:spcAft>
-                <a:spcPts val="1000"/>
-              </a:spcAft>
-              <a:defRPr sz="1450">
-                <a:solidFill>
-                  <a:srgbClr val="E2E8F0"/>
-                </a:solidFill>
-              </a:defRPr>
-            </a:pPr>
-            <a:r>
-              <a:t>• Torso Length Scaling: Dynamically rescales joint distances against physical torso height to ensure absolute scale invariance.</a:t>
+              <a:t>Frontend Architecture</a:t>
+            </a:r>
+          </a:p>
+          <a:p>
+            <a:pPr>
+              <a:spcAft>
+                <a:spcPts val="800"/>
+              </a:spcAft>
+              <a:defRPr sz="1300">
+                <a:solidFill>
+                  <a:srgbClr val="94A3B8"/>
+                </a:solidFill>
+              </a:defRPr>
+            </a:pPr>
+            <a:r>
+              <a:t>• React 18 Single-Page Application with React Router v6.</a:t>
+            </a:r>
+          </a:p>
+          <a:p>
+            <a:pPr>
+              <a:spcAft>
+                <a:spcPts val="800"/>
+              </a:spcAft>
+              <a:defRPr sz="1300">
+                <a:solidFill>
+                  <a:srgbClr val="94A3B8"/>
+                </a:solidFill>
+              </a:defRPr>
+            </a:pPr>
+            <a:r>
+              <a:t>• HTML5 Hardware-Accelerated 2D Canvas rendering engine.</a:t>
+            </a:r>
+          </a:p>
+          <a:p>
+            <a:pPr>
+              <a:spcAft>
+                <a:spcPts val="800"/>
+              </a:spcAft>
+              <a:defRPr sz="1300">
+                <a:solidFill>
+                  <a:srgbClr val="94A3B8"/>
+                </a:solidFill>
+              </a:defRPr>
+            </a:pPr>
+            <a:r>
+              <a:t>• Custom Dark Studio CSS styling with frosted glassmorphism.</a:t>
+            </a:r>
+          </a:p>
+          <a:p>
+            <a:pPr>
+              <a:spcAft>
+                <a:spcPts val="800"/>
+              </a:spcAft>
+              <a:defRPr sz="1300">
+                <a:solidFill>
+                  <a:srgbClr val="94A3B8"/>
+                </a:solidFill>
+              </a:defRPr>
+            </a:pPr>
+            <a:r>
+              <a:t>• Web Audio API &amp; Web Speech Synthesis API for hands-free audio.</a:t>
             </a:r>
           </a:p>
         </p:txBody>
@@ -6817,8 +7648,8 @@
         </p:nvSpPr>
         <p:spPr>
           <a:xfrm>
-            <a:off x="6309360" y="1463040"/>
-            <a:ext cx="5120640" cy="4846320"/>
+            <a:off x="4434840" y="1645920"/>
+            <a:ext cx="3291840" cy="4572000"/>
           </a:xfrm>
           <a:prstGeom prst="roundRect">
             <a:avLst/>
@@ -6826,7 +7657,7 @@
           <a:solidFill>
             <a:srgbClr val="1E293B"/>
           </a:solidFill>
-          <a:ln w="25400">
+          <a:ln w="19050">
             <a:solidFill>
               <a:srgbClr val="0EA5E9"/>
             </a:solidFill>
@@ -6862,8 +7693,8 @@
         </p:nvSpPr>
         <p:spPr>
           <a:xfrm>
-            <a:off x="6583680" y="1719072"/>
-            <a:ext cx="4572000" cy="4334256"/>
+            <a:off x="4709160" y="1920240"/>
+            <a:ext cx="2743200" cy="4023360"/>
           </a:xfrm>
           <a:prstGeom prst="rect">
             <a:avLst/>
@@ -6878,76 +7709,219 @@
           <a:p>
             <a:pPr>
               <a:spcAft>
-                <a:spcPts val="1200"/>
-              </a:spcAft>
-              <a:defRPr sz="2000" b="1">
+                <a:spcPts val="1400"/>
+              </a:spcAft>
+              <a:defRPr sz="1800" b="1">
                 <a:solidFill>
                   <a:srgbClr val="0EA5E9"/>
                 </a:solidFill>
               </a:defRPr>
             </a:pPr>
             <a:r>
-              <a:t>🛡️ Intelligent Kinematic Guardrails</a:t>
-            </a:r>
-          </a:p>
-          <a:p>
-            <a:pPr>
-              <a:spcAft>
-                <a:spcPts val="1000"/>
-              </a:spcAft>
-              <a:defRPr sz="1450">
-                <a:solidFill>
-                  <a:srgbClr val="E2E8F0"/>
-                </a:solidFill>
-              </a:defRPr>
-            </a:pPr>
-            <a:r>
-              <a:t>• Vector Angle Geometry: Calculates 3D-projected joint angles across elbows, knees, spine, and hips using dot-product mathematics.</a:t>
-            </a:r>
-          </a:p>
-          <a:p>
-            <a:pPr>
-              <a:spcAft>
-                <a:spcPts val="1000"/>
-              </a:spcAft>
-              <a:defRPr sz="1450">
-                <a:solidFill>
-                  <a:srgbClr val="E2E8F0"/>
-                </a:solidFill>
-              </a:defRPr>
-            </a:pPr>
-            <a:r>
-              <a:t>• Anti-Cheating Validation: Enforces strict hand prayer gates, leg elevation, and upright posture before allowing score accumulation.</a:t>
-            </a:r>
-          </a:p>
-          <a:p>
-            <a:pPr>
-              <a:spcAft>
-                <a:spcPts val="1000"/>
-              </a:spcAft>
-              <a:defRPr sz="1450">
-                <a:solidFill>
-                  <a:srgbClr val="E2E8F0"/>
-                </a:solidFill>
-              </a:defRPr>
-            </a:pPr>
-            <a:r>
-              <a:t>• Real-Time Speech Coaching: Triggers Web Speech API synthesis with clear corrections (e.g., 'Straighten standing leg!') without latency.</a:t>
-            </a:r>
-          </a:p>
-          <a:p>
-            <a:pPr>
-              <a:spcAft>
-                <a:spcPts val="1000"/>
-              </a:spcAft>
-              <a:defRPr sz="1450">
-                <a:solidFill>
-                  <a:srgbClr val="E2E8F0"/>
-                </a:solidFill>
-              </a:defRPr>
-            </a:pPr>
-            <a:r>
-              <a:t>• Local Persistence Bus: Dispatches validated hold times and stability indices directly to browser IndexedDB asynchronously.</a:t>
+              <a:t>AI &amp; Computer Vision</a:t>
+            </a:r>
+          </a:p>
+          <a:p>
+            <a:pPr>
+              <a:spcAft>
+                <a:spcPts val="800"/>
+              </a:spcAft>
+              <a:defRPr sz="1300">
+                <a:solidFill>
+                  <a:srgbClr val="94A3B8"/>
+                </a:solidFill>
+              </a:defRPr>
+            </a:pPr>
+            <a:r>
+              <a:t>• Google MoveNet Lightning: Single-pose 17-keypoint detector.</a:t>
+            </a:r>
+          </a:p>
+          <a:p>
+            <a:pPr>
+              <a:spcAft>
+                <a:spcPts val="800"/>
+              </a:spcAft>
+              <a:defRPr sz="1300">
+                <a:solidFill>
+                  <a:srgbClr val="94A3B8"/>
+                </a:solidFill>
+              </a:defRPr>
+            </a:pPr>
+            <a:r>
+              <a:t>• TensorFlow.js WebGL backend achieving 45-60 FPS on standard laptops.</a:t>
+            </a:r>
+          </a:p>
+          <a:p>
+            <a:pPr>
+              <a:spcAft>
+                <a:spcPts val="800"/>
+              </a:spcAft>
+              <a:defRPr sz="1300">
+                <a:solidFill>
+                  <a:srgbClr val="94A3B8"/>
+                </a:solidFill>
+              </a:defRPr>
+            </a:pPr>
+            <a:r>
+              <a:t>• Custom Multi-Layer Neural Classifier for posture verification.</a:t>
+            </a:r>
+          </a:p>
+          <a:p>
+            <a:pPr>
+              <a:spcAft>
+                <a:spcPts val="800"/>
+              </a:spcAft>
+              <a:defRPr sz="1300">
+                <a:solidFill>
+                  <a:srgbClr val="94A3B8"/>
+                </a:solidFill>
+              </a:defRPr>
+            </a:pPr>
+            <a:r>
+              <a:t>• Geometric Vector Angle &amp; Slope Biomechanical calculation library.</a:t>
+            </a:r>
+          </a:p>
+        </p:txBody>
+      </p:sp>
+      <p:sp>
+        <p:nvSpPr>
+          <p:cNvPr id="9" name="Rounded Rectangle 8"/>
+          <p:cNvSpPr/>
+          <p:nvPr/>
+        </p:nvSpPr>
+        <p:spPr>
+          <a:xfrm>
+            <a:off x="8138160" y="1645920"/>
+            <a:ext cx="3291840" cy="4572000"/>
+          </a:xfrm>
+          <a:prstGeom prst="roundRect">
+            <a:avLst/>
+          </a:prstGeom>
+          <a:solidFill>
+            <a:srgbClr val="1E293B"/>
+          </a:solidFill>
+          <a:ln w="19050">
+            <a:solidFill>
+              <a:srgbClr val="A855F7"/>
+            </a:solidFill>
+          </a:ln>
+        </p:spPr>
+        <p:style>
+          <a:lnRef idx="1">
+            <a:schemeClr val="accent1"/>
+          </a:lnRef>
+          <a:fillRef idx="3">
+            <a:schemeClr val="accent1"/>
+          </a:fillRef>
+          <a:effectRef idx="2">
+            <a:schemeClr val="accent1"/>
+          </a:effectRef>
+          <a:fontRef idx="minor">
+            <a:schemeClr val="lt1"/>
+          </a:fontRef>
+        </p:style>
+        <p:txBody>
+          <a:bodyPr rtlCol="0" anchor="ctr"/>
+          <a:lstStyle/>
+          <a:p>
+            <a:pPr algn="ctr"/>
+          </a:p>
+        </p:txBody>
+      </p:sp>
+      <p:sp>
+        <p:nvSpPr>
+          <p:cNvPr id="10" name="TextBox 9"/>
+          <p:cNvSpPr txBox="1"/>
+          <p:nvPr/>
+        </p:nvSpPr>
+        <p:spPr>
+          <a:xfrm>
+            <a:off x="8412480" y="1920240"/>
+            <a:ext cx="2743200" cy="4023360"/>
+          </a:xfrm>
+          <a:prstGeom prst="rect">
+            <a:avLst/>
+          </a:prstGeom>
+          <a:noFill/>
+        </p:spPr>
+        <p:txBody>
+          <a:bodyPr wrap="square">
+            <a:spAutoFit/>
+          </a:bodyPr>
+          <a:lstStyle/>
+          <a:p>
+            <a:pPr>
+              <a:spcAft>
+                <a:spcPts val="1400"/>
+              </a:spcAft>
+              <a:defRPr sz="1800" b="1">
+                <a:solidFill>
+                  <a:srgbClr val="A855F7"/>
+                </a:solidFill>
+              </a:defRPr>
+            </a:pPr>
+            <a:r>
+              <a:t>Deployment &amp; Automation</a:t>
+            </a:r>
+          </a:p>
+          <a:p>
+            <a:pPr>
+              <a:spcAft>
+                <a:spcPts val="800"/>
+              </a:spcAft>
+              <a:defRPr sz="1300">
+                <a:solidFill>
+                  <a:srgbClr val="94A3B8"/>
+                </a:solidFill>
+              </a:defRPr>
+            </a:pPr>
+            <a:r>
+              <a:t>• One-Click Launcher scripts (start.bat / yoga.bat) for zero-config startup.</a:t>
+            </a:r>
+          </a:p>
+          <a:p>
+            <a:pPr>
+              <a:spcAft>
+                <a:spcPts val="800"/>
+              </a:spcAft>
+              <a:defRPr sz="1300">
+                <a:solidFill>
+                  <a:srgbClr val="94A3B8"/>
+                </a:solidFill>
+              </a:defRPr>
+            </a:pPr>
+            <a:r>
+              <a:t>• Instant Production Server with zero cloud hosting costs.</a:t>
+            </a:r>
+          </a:p>
+          <a:p>
+            <a:pPr>
+              <a:spcAft>
+                <a:spcPts val="800"/>
+              </a:spcAft>
+              <a:defRPr sz="1300">
+                <a:solidFill>
+                  <a:srgbClr val="94A3B8"/>
+                </a:solidFill>
+              </a:defRPr>
+            </a:pPr>
+            <a:r>
+              <a:t>• Robust Git version control synced to GitHub repository.</a:t>
+            </a:r>
+          </a:p>
+          <a:p>
+            <a:pPr>
+              <a:spcAft>
+                <a:spcPts val="800"/>
+              </a:spcAft>
+              <a:defRPr sz="1300">
+                <a:solidFill>
+                  <a:srgbClr val="94A3B8"/>
+                </a:solidFill>
+              </a:defRPr>
+            </a:pPr>
+            <a:r>
+              <a:t>• 100% Client-Side Privacy: zero personal camera data transmitted.</a:t>
             </a:r>
           </a:p>
         </p:txBody>

</xml_diff>